<commit_message>
tweeks in part 1, Q2
</commit_message>
<xml_diff>
--- a/cits1003-lecture_slides/CITS1003-B ExamExample-exercises.pptx
+++ b/cits1003-lecture_slides/CITS1003-B ExamExample-exercises.pptx
@@ -12501,7 +12501,7 @@
           </a:effectLst>
           <a:extLst>
             <a:ext uri="{91240B29-F687-4f45-9708-019B960494DF}">
-              <a14:hiddenLine xmlns:a16="http://schemas.microsoft.com/office/drawing/2014/main" xmlns:p14="http://schemas.microsoft.com/office/powerpoint/2010/main" xmlns:a14="http://schemas.microsoft.com/office/drawing/2010/main" xmlns="" w="9525">
+              <a14:hiddenLine xmlns="" xmlns:a14="http://schemas.microsoft.com/office/drawing/2010/main" xmlns:p14="http://schemas.microsoft.com/office/powerpoint/2010/main" xmlns:a16="http://schemas.microsoft.com/office/drawing/2014/main" w="9525">
                 <a:solidFill>
                   <a:srgbClr val="000000"/>
                 </a:solidFill>
@@ -15159,7 +15159,23 @@
                   <a:srgbClr val="FF0000"/>
                 </a:solidFill>
               </a:rPr>
-              <a:t>recursively deleting all files and directories in the current directory</a:t>
+              <a:t>recursively deleting all files and directories in the </a:t>
+            </a:r>
+            <a:r>
+              <a:rPr lang="en-US" sz="2800">
+                <a:solidFill>
+                  <a:srgbClr val="FF0000"/>
+                </a:solidFill>
+              </a:rPr>
+              <a:t>currently logged-in user </a:t>
+            </a:r>
+            <a:r>
+              <a:rPr lang="en-US" sz="2800" dirty="0">
+                <a:solidFill>
+                  <a:srgbClr val="FF0000"/>
+                </a:solidFill>
+              </a:rPr>
+              <a:t>directory</a:t>
             </a:r>
             <a:r>
               <a:rPr lang="en-AU" sz="2800" dirty="0">

</xml_diff>

<commit_message>
tweeks in part 2 Q2
</commit_message>
<xml_diff>
--- a/cits1003-lecture_slides/CITS1003-B ExamExample-exercises.pptx
+++ b/cits1003-lecture_slides/CITS1003-B ExamExample-exercises.pptx
@@ -1,6 +1,6 @@
 
 <file path=ppt/presentation.xml><?xml version="1.0" encoding="utf-8"?>
-<p:presentation xmlns:a="http://schemas.openxmlformats.org/drawingml/2006/main" xmlns:r="http://schemas.openxmlformats.org/officeDocument/2006/relationships" xmlns:p="http://schemas.openxmlformats.org/presentationml/2006/main" removePersonalInfoOnSave="1" saveSubsetFonts="1" autoCompressPictures="0">
+<p:presentation xmlns:a="http://schemas.openxmlformats.org/drawingml/2006/main" xmlns:r="http://schemas.openxmlformats.org/officeDocument/2006/relationships" xmlns:p="http://schemas.openxmlformats.org/presentationml/2006/main" saveSubsetFonts="1" autoCompressPictures="0">
   <p:sldMasterIdLst>
     <p:sldMasterId id="2147483763" r:id="rId1"/>
   </p:sldMasterIdLst>
@@ -188,8 +188,4566 @@
 
 <file path=ppt/commentAuthors.xml><?xml version="1.0" encoding="utf-8"?>
 <p:cmAuthorLst xmlns:a="http://schemas.openxmlformats.org/drawingml/2006/main" xmlns:r="http://schemas.openxmlformats.org/officeDocument/2006/relationships" xmlns:p="http://schemas.openxmlformats.org/presentationml/2006/main">
-  <p:cmAuthor id="2" name="Author" initials="A" lastIdx="0" clrIdx="1"/>
+  <p:cmAuthor id="1" name="David Glance" initials="DG" lastIdx="1" clrIdx="0">
+    <p:extLst>
+      <p:ext uri="{19B8F6BF-5375-455C-9EA6-DF929625EA0E}">
+        <p15:presenceInfo xmlns:p15="http://schemas.microsoft.com/office/powerpoint/2012/main" userId="S::00048920@uwa.edu.au::78f19221-0802-4a87-b561-ec50043bdac8" providerId="AD"/>
+      </p:ext>
+    </p:extLst>
+  </p:cmAuthor>
 </p:cmAuthorLst>
+</file>
+
+<file path=ppt/changesInfos/changesInfo1.xml><?xml version="1.0" encoding="utf-8"?>
+<pc:chgInfo xmlns:a="http://schemas.openxmlformats.org/drawingml/2006/main" xmlns:r="http://schemas.openxmlformats.org/officeDocument/2006/relationships" xmlns:ac="http://schemas.microsoft.com/office/drawing/2013/main/command" xmlns:pc="http://schemas.microsoft.com/office/powerpoint/2013/main/command">
+  <pc:docChgLst>
+    <pc:chgData name="张 智" userId="36bdf691fd3510be" providerId="LiveId" clId="{F20A470C-BF10-42F8-AC2A-1C3CAE1C0A18}"/>
+    <pc:docChg chg="undo redo custSel addSld delSld modSld sldOrd">
+      <pc:chgData name="张 智" userId="36bdf691fd3510be" providerId="LiveId" clId="{F20A470C-BF10-42F8-AC2A-1C3CAE1C0A18}" dt="2023-05-15T05:08:23.873" v="18309" actId="20577"/>
+      <pc:docMkLst>
+        <pc:docMk/>
+      </pc:docMkLst>
+      <pc:sldChg chg="modSp mod modNotesTx">
+        <pc:chgData name="张 智" userId="36bdf691fd3510be" providerId="LiveId" clId="{F20A470C-BF10-42F8-AC2A-1C3CAE1C0A18}" dt="2023-05-15T03:34:51.672" v="18048" actId="20577"/>
+        <pc:sldMkLst>
+          <pc:docMk/>
+          <pc:sldMk cId="1077586671" sldId="256"/>
+        </pc:sldMkLst>
+        <pc:spChg chg="mod">
+          <ac:chgData name="张 智" userId="36bdf691fd3510be" providerId="LiveId" clId="{F20A470C-BF10-42F8-AC2A-1C3CAE1C0A18}" dt="2023-05-11T05:49:09.068" v="8" actId="20577"/>
+          <ac:spMkLst>
+            <pc:docMk/>
+            <pc:sldMk cId="1077586671" sldId="256"/>
+            <ac:spMk id="3" creationId="{1804B053-88E2-6F47-B5CB-F0B21DD687A8}"/>
+          </ac:spMkLst>
+        </pc:spChg>
+      </pc:sldChg>
+      <pc:sldChg chg="addSp delSp modSp mod modAnim modNotesTx">
+        <pc:chgData name="张 智" userId="36bdf691fd3510be" providerId="LiveId" clId="{F20A470C-BF10-42F8-AC2A-1C3CAE1C0A18}" dt="2023-05-15T03:10:48.892" v="16943" actId="20577"/>
+        <pc:sldMkLst>
+          <pc:docMk/>
+          <pc:sldMk cId="1112541085" sldId="260"/>
+        </pc:sldMkLst>
+        <pc:spChg chg="mod">
+          <ac:chgData name="张 智" userId="36bdf691fd3510be" providerId="LiveId" clId="{F20A470C-BF10-42F8-AC2A-1C3CAE1C0A18}" dt="2023-05-11T14:41:16.675" v="5547" actId="14100"/>
+          <ac:spMkLst>
+            <pc:docMk/>
+            <pc:sldMk cId="1112541085" sldId="260"/>
+            <ac:spMk id="2" creationId="{5C4F01C5-5333-2248-B03B-703C97F7CC69}"/>
+          </ac:spMkLst>
+        </pc:spChg>
+        <pc:spChg chg="mod">
+          <ac:chgData name="张 智" userId="36bdf691fd3510be" providerId="LiveId" clId="{F20A470C-BF10-42F8-AC2A-1C3CAE1C0A18}" dt="2023-05-15T03:10:18.062" v="16883" actId="14100"/>
+          <ac:spMkLst>
+            <pc:docMk/>
+            <pc:sldMk cId="1112541085" sldId="260"/>
+            <ac:spMk id="3" creationId="{F7DD7DCB-C7E2-1B4F-BD83-3B7AF005DD76}"/>
+          </ac:spMkLst>
+        </pc:spChg>
+        <pc:spChg chg="del">
+          <ac:chgData name="张 智" userId="36bdf691fd3510be" providerId="LiveId" clId="{F20A470C-BF10-42F8-AC2A-1C3CAE1C0A18}" dt="2023-05-11T14:37:33.310" v="5391" actId="478"/>
+          <ac:spMkLst>
+            <pc:docMk/>
+            <pc:sldMk cId="1112541085" sldId="260"/>
+            <ac:spMk id="5" creationId="{0FF4F030-5994-4653-AB70-A06627880F5F}"/>
+          </ac:spMkLst>
+        </pc:spChg>
+        <pc:graphicFrameChg chg="add del mod">
+          <ac:chgData name="张 智" userId="36bdf691fd3510be" providerId="LiveId" clId="{F20A470C-BF10-42F8-AC2A-1C3CAE1C0A18}" dt="2023-05-11T14:42:30.153" v="5554"/>
+          <ac:graphicFrameMkLst>
+            <pc:docMk/>
+            <pc:sldMk cId="1112541085" sldId="260"/>
+            <ac:graphicFrameMk id="4" creationId="{A820C76E-0AA4-4C4D-92B6-63254708DF3F}"/>
+          </ac:graphicFrameMkLst>
+        </pc:graphicFrameChg>
+      </pc:sldChg>
+      <pc:sldChg chg="addSp delSp modSp mod modNotesTx">
+        <pc:chgData name="张 智" userId="36bdf691fd3510be" providerId="LiveId" clId="{F20A470C-BF10-42F8-AC2A-1C3CAE1C0A18}" dt="2023-05-15T03:29:50.615" v="17987" actId="108"/>
+        <pc:sldMkLst>
+          <pc:docMk/>
+          <pc:sldMk cId="182683393" sldId="272"/>
+        </pc:sldMkLst>
+        <pc:spChg chg="mod">
+          <ac:chgData name="张 智" userId="36bdf691fd3510be" providerId="LiveId" clId="{F20A470C-BF10-42F8-AC2A-1C3CAE1C0A18}" dt="2023-05-13T03:03:55.784" v="7471" actId="27636"/>
+          <ac:spMkLst>
+            <pc:docMk/>
+            <pc:sldMk cId="182683393" sldId="272"/>
+            <ac:spMk id="2" creationId="{92B3B218-E6B7-E949-9413-DBDFA9A361B9}"/>
+          </ac:spMkLst>
+        </pc:spChg>
+        <pc:spChg chg="del">
+          <ac:chgData name="张 智" userId="36bdf691fd3510be" providerId="LiveId" clId="{F20A470C-BF10-42F8-AC2A-1C3CAE1C0A18}" dt="2023-05-13T02:22:42.252" v="6749" actId="478"/>
+          <ac:spMkLst>
+            <pc:docMk/>
+            <pc:sldMk cId="182683393" sldId="272"/>
+            <ac:spMk id="3" creationId="{13DB3674-2D4B-8645-8753-8E30E629B377}"/>
+          </ac:spMkLst>
+        </pc:spChg>
+        <pc:spChg chg="add del mod">
+          <ac:chgData name="张 智" userId="36bdf691fd3510be" providerId="LiveId" clId="{F20A470C-BF10-42F8-AC2A-1C3CAE1C0A18}" dt="2023-05-13T02:22:44.194" v="6750" actId="478"/>
+          <ac:spMkLst>
+            <pc:docMk/>
+            <pc:sldMk cId="182683393" sldId="272"/>
+            <ac:spMk id="5" creationId="{50C567F1-0098-40E0-B54E-50D355E6F5B2}"/>
+          </ac:spMkLst>
+        </pc:spChg>
+        <pc:spChg chg="add mod">
+          <ac:chgData name="张 智" userId="36bdf691fd3510be" providerId="LiveId" clId="{F20A470C-BF10-42F8-AC2A-1C3CAE1C0A18}" dt="2023-05-15T03:29:50.615" v="17987" actId="108"/>
+          <ac:spMkLst>
+            <pc:docMk/>
+            <pc:sldMk cId="182683393" sldId="272"/>
+            <ac:spMk id="7" creationId="{75E0A5E3-B5A7-40C6-9FE8-508ABF9E1458}"/>
+          </ac:spMkLst>
+        </pc:spChg>
+      </pc:sldChg>
+      <pc:sldChg chg="addSp delSp modSp mod modShow modNotesTx">
+        <pc:chgData name="张 智" userId="36bdf691fd3510be" providerId="LiveId" clId="{F20A470C-BF10-42F8-AC2A-1C3CAE1C0A18}" dt="2023-05-15T03:36:08.751" v="18049" actId="729"/>
+        <pc:sldMkLst>
+          <pc:docMk/>
+          <pc:sldMk cId="3255237353" sldId="374"/>
+        </pc:sldMkLst>
+        <pc:spChg chg="del">
+          <ac:chgData name="张 智" userId="36bdf691fd3510be" providerId="LiveId" clId="{F20A470C-BF10-42F8-AC2A-1C3CAE1C0A18}" dt="2023-05-11T06:05:22.558" v="49" actId="478"/>
+          <ac:spMkLst>
+            <pc:docMk/>
+            <pc:sldMk cId="3255237353" sldId="374"/>
+            <ac:spMk id="2" creationId="{00000000-0000-0000-0000-000000000000}"/>
+          </ac:spMkLst>
+        </pc:spChg>
+        <pc:spChg chg="mod">
+          <ac:chgData name="张 智" userId="36bdf691fd3510be" providerId="LiveId" clId="{F20A470C-BF10-42F8-AC2A-1C3CAE1C0A18}" dt="2023-05-11T15:19:18.334" v="6165" actId="20577"/>
+          <ac:spMkLst>
+            <pc:docMk/>
+            <pc:sldMk cId="3255237353" sldId="374"/>
+            <ac:spMk id="3" creationId="{00000000-0000-0000-0000-000000000000}"/>
+          </ac:spMkLst>
+        </pc:spChg>
+        <pc:spChg chg="add del mod">
+          <ac:chgData name="张 智" userId="36bdf691fd3510be" providerId="LiveId" clId="{F20A470C-BF10-42F8-AC2A-1C3CAE1C0A18}" dt="2023-05-11T15:16:07.042" v="6009"/>
+          <ac:spMkLst>
+            <pc:docMk/>
+            <pc:sldMk cId="3255237353" sldId="374"/>
+            <ac:spMk id="4" creationId="{8D8D382B-996B-49CC-9C8A-BF472DFCE056}"/>
+          </ac:spMkLst>
+        </pc:spChg>
+        <pc:spChg chg="add del mod">
+          <ac:chgData name="张 智" userId="36bdf691fd3510be" providerId="LiveId" clId="{F20A470C-BF10-42F8-AC2A-1C3CAE1C0A18}" dt="2023-05-11T06:05:23.938" v="50" actId="478"/>
+          <ac:spMkLst>
+            <pc:docMk/>
+            <pc:sldMk cId="3255237353" sldId="374"/>
+            <ac:spMk id="5" creationId="{2831FE25-B6E3-4AA3-A31C-4289B6C6D449}"/>
+          </ac:spMkLst>
+        </pc:spChg>
+      </pc:sldChg>
+      <pc:sldChg chg="del">
+        <pc:chgData name="张 智" userId="36bdf691fd3510be" providerId="LiveId" clId="{F20A470C-BF10-42F8-AC2A-1C3CAE1C0A18}" dt="2023-05-11T14:17:12.327" v="4687" actId="2696"/>
+        <pc:sldMkLst>
+          <pc:docMk/>
+          <pc:sldMk cId="1447061360" sldId="375"/>
+        </pc:sldMkLst>
+      </pc:sldChg>
+      <pc:sldChg chg="del">
+        <pc:chgData name="张 智" userId="36bdf691fd3510be" providerId="LiveId" clId="{F20A470C-BF10-42F8-AC2A-1C3CAE1C0A18}" dt="2023-05-11T14:17:04.727" v="4685" actId="2696"/>
+        <pc:sldMkLst>
+          <pc:docMk/>
+          <pc:sldMk cId="9128289" sldId="376"/>
+        </pc:sldMkLst>
+      </pc:sldChg>
+      <pc:sldChg chg="modSp add mod modNotesTx">
+        <pc:chgData name="张 智" userId="36bdf691fd3510be" providerId="LiveId" clId="{F20A470C-BF10-42F8-AC2A-1C3CAE1C0A18}" dt="2023-05-15T05:07:14.076" v="18257" actId="20577"/>
+        <pc:sldMkLst>
+          <pc:docMk/>
+          <pc:sldMk cId="417064799" sldId="381"/>
+        </pc:sldMkLst>
+        <pc:spChg chg="mod">
+          <ac:chgData name="张 智" userId="36bdf691fd3510be" providerId="LiveId" clId="{F20A470C-BF10-42F8-AC2A-1C3CAE1C0A18}" dt="2023-05-11T14:29:59.923" v="5268" actId="1076"/>
+          <ac:spMkLst>
+            <pc:docMk/>
+            <pc:sldMk cId="417064799" sldId="381"/>
+            <ac:spMk id="2" creationId="{00000000-0000-0000-0000-000000000000}"/>
+          </ac:spMkLst>
+        </pc:spChg>
+        <pc:spChg chg="mod">
+          <ac:chgData name="张 智" userId="36bdf691fd3510be" providerId="LiveId" clId="{F20A470C-BF10-42F8-AC2A-1C3CAE1C0A18}" dt="2023-05-11T15:24:53.818" v="6304" actId="20577"/>
+          <ac:spMkLst>
+            <pc:docMk/>
+            <pc:sldMk cId="417064799" sldId="381"/>
+            <ac:spMk id="4" creationId="{00000000-0000-0000-0000-000000000000}"/>
+          </ac:spMkLst>
+        </pc:spChg>
+      </pc:sldChg>
+      <pc:sldChg chg="del">
+        <pc:chgData name="张 智" userId="36bdf691fd3510be" providerId="LiveId" clId="{F20A470C-BF10-42F8-AC2A-1C3CAE1C0A18}" dt="2023-05-11T06:07:57.903" v="51" actId="2696"/>
+        <pc:sldMkLst>
+          <pc:docMk/>
+          <pc:sldMk cId="432660327" sldId="381"/>
+        </pc:sldMkLst>
+      </pc:sldChg>
+      <pc:sldChg chg="del">
+        <pc:chgData name="张 智" userId="36bdf691fd3510be" providerId="LiveId" clId="{F20A470C-BF10-42F8-AC2A-1C3CAE1C0A18}" dt="2023-05-11T14:17:09.517" v="4686" actId="2696"/>
+        <pc:sldMkLst>
+          <pc:docMk/>
+          <pc:sldMk cId="4148359282" sldId="384"/>
+        </pc:sldMkLst>
+      </pc:sldChg>
+      <pc:sldChg chg="del">
+        <pc:chgData name="张 智" userId="36bdf691fd3510be" providerId="LiveId" clId="{F20A470C-BF10-42F8-AC2A-1C3CAE1C0A18}" dt="2023-05-11T14:17:15.798" v="4688" actId="2696"/>
+        <pc:sldMkLst>
+          <pc:docMk/>
+          <pc:sldMk cId="3340726252" sldId="385"/>
+        </pc:sldMkLst>
+      </pc:sldChg>
+      <pc:sldChg chg="delSp modSp mod modNotesTx">
+        <pc:chgData name="张 智" userId="36bdf691fd3510be" providerId="LiveId" clId="{F20A470C-BF10-42F8-AC2A-1C3CAE1C0A18}" dt="2023-05-15T05:06:14.716" v="18254" actId="20577"/>
+        <pc:sldMkLst>
+          <pc:docMk/>
+          <pc:sldMk cId="1836985979" sldId="386"/>
+        </pc:sldMkLst>
+        <pc:spChg chg="del">
+          <ac:chgData name="张 智" userId="36bdf691fd3510be" providerId="LiveId" clId="{F20A470C-BF10-42F8-AC2A-1C3CAE1C0A18}" dt="2023-05-11T06:03:54.739" v="11" actId="478"/>
+          <ac:spMkLst>
+            <pc:docMk/>
+            <pc:sldMk cId="1836985979" sldId="386"/>
+            <ac:spMk id="2" creationId="{700AC81D-9401-4B7C-81FF-553D55D07D26}"/>
+          </ac:spMkLst>
+        </pc:spChg>
+        <pc:spChg chg="mod">
+          <ac:chgData name="张 智" userId="36bdf691fd3510be" providerId="LiveId" clId="{F20A470C-BF10-42F8-AC2A-1C3CAE1C0A18}" dt="2023-05-11T13:43:12.646" v="3575" actId="1076"/>
+          <ac:spMkLst>
+            <pc:docMk/>
+            <pc:sldMk cId="1836985979" sldId="386"/>
+            <ac:spMk id="3" creationId="{BF67693E-A48F-4F32-8586-A906B0CE6024}"/>
+          </ac:spMkLst>
+        </pc:spChg>
+      </pc:sldChg>
+      <pc:sldChg chg="modSp add mod">
+        <pc:chgData name="张 智" userId="36bdf691fd3510be" providerId="LiveId" clId="{F20A470C-BF10-42F8-AC2A-1C3CAE1C0A18}" dt="2023-05-14T15:15:37.308" v="11511" actId="20577"/>
+        <pc:sldMkLst>
+          <pc:docMk/>
+          <pc:sldMk cId="2518083175" sldId="387"/>
+        </pc:sldMkLst>
+        <pc:spChg chg="mod">
+          <ac:chgData name="张 智" userId="36bdf691fd3510be" providerId="LiveId" clId="{F20A470C-BF10-42F8-AC2A-1C3CAE1C0A18}" dt="2023-05-14T14:53:24.919" v="10984" actId="14100"/>
+          <ac:spMkLst>
+            <pc:docMk/>
+            <pc:sldMk cId="2518083175" sldId="387"/>
+            <ac:spMk id="2" creationId="{92B3B218-E6B7-E949-9413-DBDFA9A361B9}"/>
+          </ac:spMkLst>
+        </pc:spChg>
+        <pc:spChg chg="mod">
+          <ac:chgData name="张 智" userId="36bdf691fd3510be" providerId="LiveId" clId="{F20A470C-BF10-42F8-AC2A-1C3CAE1C0A18}" dt="2023-05-14T15:15:37.308" v="11511" actId="20577"/>
+          <ac:spMkLst>
+            <pc:docMk/>
+            <pc:sldMk cId="2518083175" sldId="387"/>
+            <ac:spMk id="3" creationId="{13DB3674-2D4B-8645-8753-8E30E629B377}"/>
+          </ac:spMkLst>
+        </pc:spChg>
+      </pc:sldChg>
+      <pc:sldChg chg="modSp del mod">
+        <pc:chgData name="张 智" userId="36bdf691fd3510be" providerId="LiveId" clId="{F20A470C-BF10-42F8-AC2A-1C3CAE1C0A18}" dt="2023-05-14T14:18:45.546" v="10328" actId="2696"/>
+        <pc:sldMkLst>
+          <pc:docMk/>
+          <pc:sldMk cId="3758508635" sldId="387"/>
+        </pc:sldMkLst>
+        <pc:spChg chg="mod">
+          <ac:chgData name="张 智" userId="36bdf691fd3510be" providerId="LiveId" clId="{F20A470C-BF10-42F8-AC2A-1C3CAE1C0A18}" dt="2023-05-11T15:36:23.498" v="6575" actId="1076"/>
+          <ac:spMkLst>
+            <pc:docMk/>
+            <pc:sldMk cId="3758508635" sldId="387"/>
+            <ac:spMk id="2" creationId="{92B3B218-E6B7-E949-9413-DBDFA9A361B9}"/>
+          </ac:spMkLst>
+        </pc:spChg>
+      </pc:sldChg>
+      <pc:sldChg chg="modSp mod">
+        <pc:chgData name="张 智" userId="36bdf691fd3510be" providerId="LiveId" clId="{F20A470C-BF10-42F8-AC2A-1C3CAE1C0A18}" dt="2023-05-14T14:44:31.615" v="10697" actId="20577"/>
+        <pc:sldMkLst>
+          <pc:docMk/>
+          <pc:sldMk cId="1629619534" sldId="388"/>
+        </pc:sldMkLst>
+        <pc:spChg chg="mod">
+          <ac:chgData name="张 智" userId="36bdf691fd3510be" providerId="LiveId" clId="{F20A470C-BF10-42F8-AC2A-1C3CAE1C0A18}" dt="2023-05-14T13:57:24.824" v="9937" actId="14100"/>
+          <ac:spMkLst>
+            <pc:docMk/>
+            <pc:sldMk cId="1629619534" sldId="388"/>
+            <ac:spMk id="2" creationId="{92B3B218-E6B7-E949-9413-DBDFA9A361B9}"/>
+          </ac:spMkLst>
+        </pc:spChg>
+        <pc:spChg chg="mod">
+          <ac:chgData name="张 智" userId="36bdf691fd3510be" providerId="LiveId" clId="{F20A470C-BF10-42F8-AC2A-1C3CAE1C0A18}" dt="2023-05-14T14:44:31.615" v="10697" actId="20577"/>
+          <ac:spMkLst>
+            <pc:docMk/>
+            <pc:sldMk cId="1629619534" sldId="388"/>
+            <ac:spMk id="3" creationId="{13DB3674-2D4B-8645-8753-8E30E629B377}"/>
+          </ac:spMkLst>
+        </pc:spChg>
+      </pc:sldChg>
+      <pc:sldChg chg="delSp del mod">
+        <pc:chgData name="张 智" userId="36bdf691fd3510be" providerId="LiveId" clId="{F20A470C-BF10-42F8-AC2A-1C3CAE1C0A18}" dt="2023-05-11T05:51:27.230" v="10" actId="2696"/>
+        <pc:sldMkLst>
+          <pc:docMk/>
+          <pc:sldMk cId="852751009" sldId="389"/>
+        </pc:sldMkLst>
+        <pc:spChg chg="del">
+          <ac:chgData name="张 智" userId="36bdf691fd3510be" providerId="LiveId" clId="{F20A470C-BF10-42F8-AC2A-1C3CAE1C0A18}" dt="2023-05-11T05:51:20.631" v="9" actId="478"/>
+          <ac:spMkLst>
+            <pc:docMk/>
+            <pc:sldMk cId="852751009" sldId="389"/>
+            <ac:spMk id="3" creationId="{BA0E001D-9DCA-4D38-A4CA-360405FBD226}"/>
+          </ac:spMkLst>
+        </pc:spChg>
+      </pc:sldChg>
+      <pc:sldChg chg="addSp delSp modSp add mod modNotesTx">
+        <pc:chgData name="张 智" userId="36bdf691fd3510be" providerId="LiveId" clId="{F20A470C-BF10-42F8-AC2A-1C3CAE1C0A18}" dt="2023-05-15T02:49:00.742" v="16038" actId="20577"/>
+        <pc:sldMkLst>
+          <pc:docMk/>
+          <pc:sldMk cId="2447282596" sldId="389"/>
+        </pc:sldMkLst>
+        <pc:spChg chg="mod">
+          <ac:chgData name="张 智" userId="36bdf691fd3510be" providerId="LiveId" clId="{F20A470C-BF10-42F8-AC2A-1C3CAE1C0A18}" dt="2023-05-11T08:09:07.661" v="3211" actId="20577"/>
+          <ac:spMkLst>
+            <pc:docMk/>
+            <pc:sldMk cId="2447282596" sldId="389"/>
+            <ac:spMk id="2" creationId="{00000000-0000-0000-0000-000000000000}"/>
+          </ac:spMkLst>
+        </pc:spChg>
+        <pc:spChg chg="del">
+          <ac:chgData name="张 智" userId="36bdf691fd3510be" providerId="LiveId" clId="{F20A470C-BF10-42F8-AC2A-1C3CAE1C0A18}" dt="2023-05-11T07:03:41.011" v="1058" actId="478"/>
+          <ac:spMkLst>
+            <pc:docMk/>
+            <pc:sldMk cId="2447282596" sldId="389"/>
+            <ac:spMk id="4" creationId="{00000000-0000-0000-0000-000000000000}"/>
+          </ac:spMkLst>
+        </pc:spChg>
+        <pc:spChg chg="add del mod">
+          <ac:chgData name="张 智" userId="36bdf691fd3510be" providerId="LiveId" clId="{F20A470C-BF10-42F8-AC2A-1C3CAE1C0A18}" dt="2023-05-11T07:03:42.210" v="1059" actId="478"/>
+          <ac:spMkLst>
+            <pc:docMk/>
+            <pc:sldMk cId="2447282596" sldId="389"/>
+            <ac:spMk id="6" creationId="{98B072FF-BCC5-49BE-879E-1C086AD0D467}"/>
+          </ac:spMkLst>
+        </pc:spChg>
+        <pc:graphicFrameChg chg="add mod modGraphic">
+          <ac:chgData name="张 智" userId="36bdf691fd3510be" providerId="LiveId" clId="{F20A470C-BF10-42F8-AC2A-1C3CAE1C0A18}" dt="2023-05-11T14:35:55.101" v="5376" actId="14100"/>
+          <ac:graphicFrameMkLst>
+            <pc:docMk/>
+            <pc:sldMk cId="2447282596" sldId="389"/>
+            <ac:graphicFrameMk id="7" creationId="{64BF649E-4F89-4FF9-8E80-77DC125E0469}"/>
+          </ac:graphicFrameMkLst>
+        </pc:graphicFrameChg>
+      </pc:sldChg>
+      <pc:sldChg chg="addSp modSp add mod modNotesTx">
+        <pc:chgData name="张 智" userId="36bdf691fd3510be" providerId="LiveId" clId="{F20A470C-BF10-42F8-AC2A-1C3CAE1C0A18}" dt="2023-05-15T05:08:23.873" v="18309" actId="20577"/>
+        <pc:sldMkLst>
+          <pc:docMk/>
+          <pc:sldMk cId="3694241775" sldId="390"/>
+        </pc:sldMkLst>
+        <pc:spChg chg="mod">
+          <ac:chgData name="张 智" userId="36bdf691fd3510be" providerId="LiveId" clId="{F20A470C-BF10-42F8-AC2A-1C3CAE1C0A18}" dt="2023-05-11T06:32:52.657" v="214" actId="1076"/>
+          <ac:spMkLst>
+            <pc:docMk/>
+            <pc:sldMk cId="3694241775" sldId="390"/>
+            <ac:spMk id="2" creationId="{00000000-0000-0000-0000-000000000000}"/>
+          </ac:spMkLst>
+        </pc:spChg>
+        <pc:spChg chg="mod">
+          <ac:chgData name="张 智" userId="36bdf691fd3510be" providerId="LiveId" clId="{F20A470C-BF10-42F8-AC2A-1C3CAE1C0A18}" dt="2023-05-15T02:11:41.808" v="13101" actId="20577"/>
+          <ac:spMkLst>
+            <pc:docMk/>
+            <pc:sldMk cId="3694241775" sldId="390"/>
+            <ac:spMk id="4" creationId="{00000000-0000-0000-0000-000000000000}"/>
+          </ac:spMkLst>
+        </pc:spChg>
+        <pc:spChg chg="add mod">
+          <ac:chgData name="张 智" userId="36bdf691fd3510be" providerId="LiveId" clId="{F20A470C-BF10-42F8-AC2A-1C3CAE1C0A18}" dt="2023-05-11T14:30:10.187" v="5269" actId="1076"/>
+          <ac:spMkLst>
+            <pc:docMk/>
+            <pc:sldMk cId="3694241775" sldId="390"/>
+            <ac:spMk id="5" creationId="{B43D19D8-4875-4F12-84BA-ABE8C8303F73}"/>
+          </ac:spMkLst>
+        </pc:spChg>
+      </pc:sldChg>
+      <pc:sldChg chg="addSp delSp modSp add mod modNotesTx">
+        <pc:chgData name="张 智" userId="36bdf691fd3510be" providerId="LiveId" clId="{F20A470C-BF10-42F8-AC2A-1C3CAE1C0A18}" dt="2023-05-15T02:42:53.510" v="15576" actId="20577"/>
+        <pc:sldMkLst>
+          <pc:docMk/>
+          <pc:sldMk cId="1777350827" sldId="391"/>
+        </pc:sldMkLst>
+        <pc:spChg chg="mod">
+          <ac:chgData name="张 智" userId="36bdf691fd3510be" providerId="LiveId" clId="{F20A470C-BF10-42F8-AC2A-1C3CAE1C0A18}" dt="2023-05-15T02:38:42.427" v="15242" actId="27636"/>
+          <ac:spMkLst>
+            <pc:docMk/>
+            <pc:sldMk cId="1777350827" sldId="391"/>
+            <ac:spMk id="2" creationId="{00000000-0000-0000-0000-000000000000}"/>
+          </ac:spMkLst>
+        </pc:spChg>
+        <pc:graphicFrameChg chg="add del mod">
+          <ac:chgData name="张 智" userId="36bdf691fd3510be" providerId="LiveId" clId="{F20A470C-BF10-42F8-AC2A-1C3CAE1C0A18}" dt="2023-05-15T02:39:06.938" v="15246"/>
+          <ac:graphicFrameMkLst>
+            <pc:docMk/>
+            <pc:sldMk cId="1777350827" sldId="391"/>
+            <ac:graphicFrameMk id="4" creationId="{6B7B7062-9440-491B-872E-FC06C7960CFB}"/>
+          </ac:graphicFrameMkLst>
+        </pc:graphicFrameChg>
+        <pc:graphicFrameChg chg="mod modGraphic">
+          <ac:chgData name="张 智" userId="36bdf691fd3510be" providerId="LiveId" clId="{F20A470C-BF10-42F8-AC2A-1C3CAE1C0A18}" dt="2023-05-15T02:40:32.754" v="15263" actId="108"/>
+          <ac:graphicFrameMkLst>
+            <pc:docMk/>
+            <pc:sldMk cId="1777350827" sldId="391"/>
+            <ac:graphicFrameMk id="7" creationId="{64BF649E-4F89-4FF9-8E80-77DC125E0469}"/>
+          </ac:graphicFrameMkLst>
+        </pc:graphicFrameChg>
+      </pc:sldChg>
+      <pc:sldChg chg="addSp delSp modSp add del mod">
+        <pc:chgData name="张 智" userId="36bdf691fd3510be" providerId="LiveId" clId="{F20A470C-BF10-42F8-AC2A-1C3CAE1C0A18}" dt="2023-05-11T08:46:54.995" v="3226" actId="2696"/>
+        <pc:sldMkLst>
+          <pc:docMk/>
+          <pc:sldMk cId="1804857881" sldId="392"/>
+        </pc:sldMkLst>
+        <pc:spChg chg="del mod">
+          <ac:chgData name="张 智" userId="36bdf691fd3510be" providerId="LiveId" clId="{F20A470C-BF10-42F8-AC2A-1C3CAE1C0A18}" dt="2023-05-11T08:46:36.364" v="3220" actId="478"/>
+          <ac:spMkLst>
+            <pc:docMk/>
+            <pc:sldMk cId="1804857881" sldId="392"/>
+            <ac:spMk id="2" creationId="{00000000-0000-0000-0000-000000000000}"/>
+          </ac:spMkLst>
+        </pc:spChg>
+        <pc:spChg chg="add del mod">
+          <ac:chgData name="张 智" userId="36bdf691fd3510be" providerId="LiveId" clId="{F20A470C-BF10-42F8-AC2A-1C3CAE1C0A18}" dt="2023-05-11T08:46:38.174" v="3221" actId="478"/>
+          <ac:spMkLst>
+            <pc:docMk/>
+            <pc:sldMk cId="1804857881" sldId="392"/>
+            <ac:spMk id="6" creationId="{3EDCF898-30A3-4811-97B5-EA8B423D35F7}"/>
+          </ac:spMkLst>
+        </pc:spChg>
+        <pc:spChg chg="add del mod">
+          <ac:chgData name="张 智" userId="36bdf691fd3510be" providerId="LiveId" clId="{F20A470C-BF10-42F8-AC2A-1C3CAE1C0A18}" dt="2023-05-11T08:46:43.673" v="3223" actId="478"/>
+          <ac:spMkLst>
+            <pc:docMk/>
+            <pc:sldMk cId="1804857881" sldId="392"/>
+            <ac:spMk id="9" creationId="{32939446-295E-4E72-A4F8-4CE9C6A1B71C}"/>
+          </ac:spMkLst>
+        </pc:spChg>
+        <pc:graphicFrameChg chg="add del mod">
+          <ac:chgData name="张 智" userId="36bdf691fd3510be" providerId="LiveId" clId="{F20A470C-BF10-42F8-AC2A-1C3CAE1C0A18}" dt="2023-05-11T07:55:23.579" v="2597"/>
+          <ac:graphicFrameMkLst>
+            <pc:docMk/>
+            <pc:sldMk cId="1804857881" sldId="392"/>
+            <ac:graphicFrameMk id="5" creationId="{45E495FC-4403-41FF-808E-D60D75C969C5}"/>
+          </ac:graphicFrameMkLst>
+        </pc:graphicFrameChg>
+        <pc:graphicFrameChg chg="del mod modGraphic">
+          <ac:chgData name="张 智" userId="36bdf691fd3510be" providerId="LiveId" clId="{F20A470C-BF10-42F8-AC2A-1C3CAE1C0A18}" dt="2023-05-11T08:46:41.469" v="3222" actId="478"/>
+          <ac:graphicFrameMkLst>
+            <pc:docMk/>
+            <pc:sldMk cId="1804857881" sldId="392"/>
+            <ac:graphicFrameMk id="7" creationId="{64BF649E-4F89-4FF9-8E80-77DC125E0469}"/>
+          </ac:graphicFrameMkLst>
+        </pc:graphicFrameChg>
+      </pc:sldChg>
+      <pc:sldChg chg="addSp delSp modSp add mod modNotesTx">
+        <pc:chgData name="张 智" userId="36bdf691fd3510be" providerId="LiveId" clId="{F20A470C-BF10-42F8-AC2A-1C3CAE1C0A18}" dt="2023-05-15T02:51:25.928" v="16199" actId="20577"/>
+        <pc:sldMkLst>
+          <pc:docMk/>
+          <pc:sldMk cId="265166926" sldId="393"/>
+        </pc:sldMkLst>
+        <pc:spChg chg="mod">
+          <ac:chgData name="张 智" userId="36bdf691fd3510be" providerId="LiveId" clId="{F20A470C-BF10-42F8-AC2A-1C3CAE1C0A18}" dt="2023-05-11T07:49:57.725" v="2385" actId="20577"/>
+          <ac:spMkLst>
+            <pc:docMk/>
+            <pc:sldMk cId="265166926" sldId="393"/>
+            <ac:spMk id="2" creationId="{00000000-0000-0000-0000-000000000000}"/>
+          </ac:spMkLst>
+        </pc:spChg>
+        <pc:graphicFrameChg chg="add del mod">
+          <ac:chgData name="张 智" userId="36bdf691fd3510be" providerId="LiveId" clId="{F20A470C-BF10-42F8-AC2A-1C3CAE1C0A18}" dt="2023-05-11T07:53:53.531" v="2530"/>
+          <ac:graphicFrameMkLst>
+            <pc:docMk/>
+            <pc:sldMk cId="265166926" sldId="393"/>
+            <ac:graphicFrameMk id="4" creationId="{B44A7D2E-CE90-4095-9E89-E0E8ADC00C29}"/>
+          </ac:graphicFrameMkLst>
+        </pc:graphicFrameChg>
+        <pc:graphicFrameChg chg="mod modGraphic">
+          <ac:chgData name="张 智" userId="36bdf691fd3510be" providerId="LiveId" clId="{F20A470C-BF10-42F8-AC2A-1C3CAE1C0A18}" dt="2023-05-11T14:35:07.979" v="5362" actId="1076"/>
+          <ac:graphicFrameMkLst>
+            <pc:docMk/>
+            <pc:sldMk cId="265166926" sldId="393"/>
+            <ac:graphicFrameMk id="7" creationId="{64BF649E-4F89-4FF9-8E80-77DC125E0469}"/>
+          </ac:graphicFrameMkLst>
+        </pc:graphicFrameChg>
+      </pc:sldChg>
+      <pc:sldChg chg="add del">
+        <pc:chgData name="张 智" userId="36bdf691fd3510be" providerId="LiveId" clId="{F20A470C-BF10-42F8-AC2A-1C3CAE1C0A18}" dt="2023-05-11T07:31:23.288" v="2240"/>
+        <pc:sldMkLst>
+          <pc:docMk/>
+          <pc:sldMk cId="4227881981" sldId="393"/>
+        </pc:sldMkLst>
+      </pc:sldChg>
+      <pc:sldChg chg="addSp delSp modSp add mod modNotesTx">
+        <pc:chgData name="张 智" userId="36bdf691fd3510be" providerId="LiveId" clId="{F20A470C-BF10-42F8-AC2A-1C3CAE1C0A18}" dt="2023-05-15T02:53:56.878" v="16412" actId="20577"/>
+        <pc:sldMkLst>
+          <pc:docMk/>
+          <pc:sldMk cId="2093694809" sldId="394"/>
+        </pc:sldMkLst>
+        <pc:spChg chg="del">
+          <ac:chgData name="张 智" userId="36bdf691fd3510be" providerId="LiveId" clId="{F20A470C-BF10-42F8-AC2A-1C3CAE1C0A18}" dt="2023-05-11T07:57:30.110" v="2661" actId="478"/>
+          <ac:spMkLst>
+            <pc:docMk/>
+            <pc:sldMk cId="2093694809" sldId="394"/>
+            <ac:spMk id="2" creationId="{00000000-0000-0000-0000-000000000000}"/>
+          </ac:spMkLst>
+        </pc:spChg>
+        <pc:spChg chg="add del mod">
+          <ac:chgData name="张 智" userId="36bdf691fd3510be" providerId="LiveId" clId="{F20A470C-BF10-42F8-AC2A-1C3CAE1C0A18}" dt="2023-05-11T07:57:31.878" v="2662" actId="478"/>
+          <ac:spMkLst>
+            <pc:docMk/>
+            <pc:sldMk cId="2093694809" sldId="394"/>
+            <ac:spMk id="5" creationId="{CB1C2F74-D668-466F-AF9A-0E80B6F4840C}"/>
+          </ac:spMkLst>
+        </pc:spChg>
+        <pc:spChg chg="add mod">
+          <ac:chgData name="张 智" userId="36bdf691fd3510be" providerId="LiveId" clId="{F20A470C-BF10-42F8-AC2A-1C3CAE1C0A18}" dt="2023-05-11T07:57:32.224" v="2663"/>
+          <ac:spMkLst>
+            <pc:docMk/>
+            <pc:sldMk cId="2093694809" sldId="394"/>
+            <ac:spMk id="8" creationId="{2DD1613E-62EC-455D-B2C7-9E871C01A31F}"/>
+          </ac:spMkLst>
+        </pc:spChg>
+        <pc:graphicFrameChg chg="mod modGraphic">
+          <ac:chgData name="张 智" userId="36bdf691fd3510be" providerId="LiveId" clId="{F20A470C-BF10-42F8-AC2A-1C3CAE1C0A18}" dt="2023-05-11T14:36:09.491" v="5379" actId="14734"/>
+          <ac:graphicFrameMkLst>
+            <pc:docMk/>
+            <pc:sldMk cId="2093694809" sldId="394"/>
+            <ac:graphicFrameMk id="7" creationId="{64BF649E-4F89-4FF9-8E80-77DC125E0469}"/>
+          </ac:graphicFrameMkLst>
+        </pc:graphicFrameChg>
+      </pc:sldChg>
+      <pc:sldChg chg="delSp modSp add mod modNotesTx">
+        <pc:chgData name="张 智" userId="36bdf691fd3510be" providerId="LiveId" clId="{F20A470C-BF10-42F8-AC2A-1C3CAE1C0A18}" dt="2023-05-15T02:46:22.606" v="15935" actId="20577"/>
+        <pc:sldMkLst>
+          <pc:docMk/>
+          <pc:sldMk cId="563417353" sldId="395"/>
+        </pc:sldMkLst>
+        <pc:spChg chg="mod">
+          <ac:chgData name="张 智" userId="36bdf691fd3510be" providerId="LiveId" clId="{F20A470C-BF10-42F8-AC2A-1C3CAE1C0A18}" dt="2023-05-15T02:27:24.422" v="14491" actId="15"/>
+          <ac:spMkLst>
+            <pc:docMk/>
+            <pc:sldMk cId="563417353" sldId="395"/>
+            <ac:spMk id="4" creationId="{00000000-0000-0000-0000-000000000000}"/>
+          </ac:spMkLst>
+        </pc:spChg>
+        <pc:spChg chg="del">
+          <ac:chgData name="张 智" userId="36bdf691fd3510be" providerId="LiveId" clId="{F20A470C-BF10-42F8-AC2A-1C3CAE1C0A18}" dt="2023-05-11T08:07:27.274" v="3093" actId="478"/>
+          <ac:spMkLst>
+            <pc:docMk/>
+            <pc:sldMk cId="563417353" sldId="395"/>
+            <ac:spMk id="5" creationId="{B43D19D8-4875-4F12-84BA-ABE8C8303F73}"/>
+          </ac:spMkLst>
+        </pc:spChg>
+      </pc:sldChg>
+      <pc:sldChg chg="modSp add del mod">
+        <pc:chgData name="张 智" userId="36bdf691fd3510be" providerId="LiveId" clId="{F20A470C-BF10-42F8-AC2A-1C3CAE1C0A18}" dt="2023-05-11T13:41:32.736" v="3562" actId="2696"/>
+        <pc:sldMkLst>
+          <pc:docMk/>
+          <pc:sldMk cId="1804780514" sldId="440"/>
+        </pc:sldMkLst>
+        <pc:spChg chg="mod">
+          <ac:chgData name="张 智" userId="36bdf691fd3510be" providerId="LiveId" clId="{F20A470C-BF10-42F8-AC2A-1C3CAE1C0A18}" dt="2023-05-11T09:01:33.514" v="3426" actId="21"/>
+          <ac:spMkLst>
+            <pc:docMk/>
+            <pc:sldMk cId="1804780514" sldId="440"/>
+            <ac:spMk id="2" creationId="{00000000-0000-0000-0000-000000000000}"/>
+          </ac:spMkLst>
+        </pc:spChg>
+        <pc:spChg chg="mod">
+          <ac:chgData name="张 智" userId="36bdf691fd3510be" providerId="LiveId" clId="{F20A470C-BF10-42F8-AC2A-1C3CAE1C0A18}" dt="2023-05-11T08:46:51.404" v="3225" actId="108"/>
+          <ac:spMkLst>
+            <pc:docMk/>
+            <pc:sldMk cId="1804780514" sldId="440"/>
+            <ac:spMk id="4" creationId="{5B957625-E6B4-4A6E-AD88-440582743C65}"/>
+          </ac:spMkLst>
+        </pc:spChg>
+      </pc:sldChg>
+      <pc:sldChg chg="modSp add mod modShow">
+        <pc:chgData name="张 智" userId="36bdf691fd3510be" providerId="LiveId" clId="{F20A470C-BF10-42F8-AC2A-1C3CAE1C0A18}" dt="2023-05-15T02:55:28.457" v="16415" actId="729"/>
+        <pc:sldMkLst>
+          <pc:docMk/>
+          <pc:sldMk cId="2882433566" sldId="441"/>
+        </pc:sldMkLst>
+        <pc:spChg chg="mod">
+          <ac:chgData name="张 智" userId="36bdf691fd3510be" providerId="LiveId" clId="{F20A470C-BF10-42F8-AC2A-1C3CAE1C0A18}" dt="2023-05-11T08:57:01.346" v="3334" actId="14100"/>
+          <ac:spMkLst>
+            <pc:docMk/>
+            <pc:sldMk cId="2882433566" sldId="441"/>
+            <ac:spMk id="2" creationId="{00000000-0000-0000-0000-000000000000}"/>
+          </ac:spMkLst>
+        </pc:spChg>
+        <pc:graphicFrameChg chg="mod modGraphic">
+          <ac:chgData name="张 智" userId="36bdf691fd3510be" providerId="LiveId" clId="{F20A470C-BF10-42F8-AC2A-1C3CAE1C0A18}" dt="2023-05-11T14:36:19.429" v="5381" actId="403"/>
+          <ac:graphicFrameMkLst>
+            <pc:docMk/>
+            <pc:sldMk cId="2882433566" sldId="441"/>
+            <ac:graphicFrameMk id="7" creationId="{64BF649E-4F89-4FF9-8E80-77DC125E0469}"/>
+          </ac:graphicFrameMkLst>
+        </pc:graphicFrameChg>
+      </pc:sldChg>
+      <pc:sldChg chg="modSp add del mod modShow">
+        <pc:chgData name="张 智" userId="36bdf691fd3510be" providerId="LiveId" clId="{F20A470C-BF10-42F8-AC2A-1C3CAE1C0A18}" dt="2023-05-15T02:55:30.032" v="16416" actId="729"/>
+        <pc:sldMkLst>
+          <pc:docMk/>
+          <pc:sldMk cId="1948032825" sldId="442"/>
+        </pc:sldMkLst>
+        <pc:spChg chg="mod">
+          <ac:chgData name="张 智" userId="36bdf691fd3510be" providerId="LiveId" clId="{F20A470C-BF10-42F8-AC2A-1C3CAE1C0A18}" dt="2023-05-11T13:40:45.636" v="3561" actId="1076"/>
+          <ac:spMkLst>
+            <pc:docMk/>
+            <pc:sldMk cId="1948032825" sldId="442"/>
+            <ac:spMk id="2" creationId="{00000000-0000-0000-0000-000000000000}"/>
+          </ac:spMkLst>
+        </pc:spChg>
+        <pc:graphicFrameChg chg="mod modGraphic">
+          <ac:chgData name="张 智" userId="36bdf691fd3510be" providerId="LiveId" clId="{F20A470C-BF10-42F8-AC2A-1C3CAE1C0A18}" dt="2023-05-11T14:36:42.084" v="5384" actId="1076"/>
+          <ac:graphicFrameMkLst>
+            <pc:docMk/>
+            <pc:sldMk cId="1948032825" sldId="442"/>
+            <ac:graphicFrameMk id="7" creationId="{64BF649E-4F89-4FF9-8E80-77DC125E0469}"/>
+          </ac:graphicFrameMkLst>
+        </pc:graphicFrameChg>
+      </pc:sldChg>
+      <pc:sldChg chg="modSp add del mod">
+        <pc:chgData name="张 智" userId="36bdf691fd3510be" providerId="LiveId" clId="{F20A470C-BF10-42F8-AC2A-1C3CAE1C0A18}" dt="2023-05-11T08:59:42.350" v="3371" actId="2696"/>
+        <pc:sldMkLst>
+          <pc:docMk/>
+          <pc:sldMk cId="2550550105" sldId="442"/>
+        </pc:sldMkLst>
+        <pc:spChg chg="mod">
+          <ac:chgData name="张 智" userId="36bdf691fd3510be" providerId="LiveId" clId="{F20A470C-BF10-42F8-AC2A-1C3CAE1C0A18}" dt="2023-05-11T08:54:08.940" v="3279" actId="20577"/>
+          <ac:spMkLst>
+            <pc:docMk/>
+            <pc:sldMk cId="2550550105" sldId="442"/>
+            <ac:spMk id="2" creationId="{00000000-0000-0000-0000-000000000000}"/>
+          </ac:spMkLst>
+        </pc:spChg>
+        <pc:graphicFrameChg chg="mod modGraphic">
+          <ac:chgData name="张 智" userId="36bdf691fd3510be" providerId="LiveId" clId="{F20A470C-BF10-42F8-AC2A-1C3CAE1C0A18}" dt="2023-05-11T08:57:48.509" v="3346" actId="21"/>
+          <ac:graphicFrameMkLst>
+            <pc:docMk/>
+            <pc:sldMk cId="2550550105" sldId="442"/>
+            <ac:graphicFrameMk id="7" creationId="{64BF649E-4F89-4FF9-8E80-77DC125E0469}"/>
+          </ac:graphicFrameMkLst>
+        </pc:graphicFrameChg>
+      </pc:sldChg>
+      <pc:sldChg chg="modSp add del mod">
+        <pc:chgData name="张 智" userId="36bdf691fd3510be" providerId="LiveId" clId="{F20A470C-BF10-42F8-AC2A-1C3CAE1C0A18}" dt="2023-05-11T13:59:56.246" v="4166" actId="2696"/>
+        <pc:sldMkLst>
+          <pc:docMk/>
+          <pc:sldMk cId="2203017474" sldId="443"/>
+        </pc:sldMkLst>
+        <pc:spChg chg="mod">
+          <ac:chgData name="张 智" userId="36bdf691fd3510be" providerId="LiveId" clId="{F20A470C-BF10-42F8-AC2A-1C3CAE1C0A18}" dt="2023-05-11T13:59:35.873" v="4165" actId="20577"/>
+          <ac:spMkLst>
+            <pc:docMk/>
+            <pc:sldMk cId="2203017474" sldId="443"/>
+            <ac:spMk id="2" creationId="{00000000-0000-0000-0000-000000000000}"/>
+          </ac:spMkLst>
+        </pc:spChg>
+      </pc:sldChg>
+      <pc:sldChg chg="modSp add mod modNotesTx">
+        <pc:chgData name="张 智" userId="36bdf691fd3510be" providerId="LiveId" clId="{F20A470C-BF10-42F8-AC2A-1C3CAE1C0A18}" dt="2023-05-15T03:25:02.909" v="17790" actId="20577"/>
+        <pc:sldMkLst>
+          <pc:docMk/>
+          <pc:sldMk cId="4009072888" sldId="443"/>
+        </pc:sldMkLst>
+        <pc:spChg chg="mod">
+          <ac:chgData name="张 智" userId="36bdf691fd3510be" providerId="LiveId" clId="{F20A470C-BF10-42F8-AC2A-1C3CAE1C0A18}" dt="2023-05-11T15:34:10.219" v="6524" actId="14100"/>
+          <ac:spMkLst>
+            <pc:docMk/>
+            <pc:sldMk cId="4009072888" sldId="443"/>
+            <ac:spMk id="2" creationId="{5C4F01C5-5333-2248-B03B-703C97F7CC69}"/>
+          </ac:spMkLst>
+        </pc:spChg>
+        <pc:spChg chg="mod">
+          <ac:chgData name="张 智" userId="36bdf691fd3510be" providerId="LiveId" clId="{F20A470C-BF10-42F8-AC2A-1C3CAE1C0A18}" dt="2023-05-15T03:23:02.303" v="17736" actId="20577"/>
+          <ac:spMkLst>
+            <pc:docMk/>
+            <pc:sldMk cId="4009072888" sldId="443"/>
+            <ac:spMk id="3" creationId="{F7DD7DCB-C7E2-1B4F-BD83-3B7AF005DD76}"/>
+          </ac:spMkLst>
+        </pc:spChg>
+      </pc:sldChg>
+      <pc:sldChg chg="modSp add mod modNotesTx">
+        <pc:chgData name="张 智" userId="36bdf691fd3510be" providerId="LiveId" clId="{F20A470C-BF10-42F8-AC2A-1C3CAE1C0A18}" dt="2023-05-15T03:17:15.614" v="17298" actId="20577"/>
+        <pc:sldMkLst>
+          <pc:docMk/>
+          <pc:sldMk cId="811672812" sldId="444"/>
+        </pc:sldMkLst>
+        <pc:spChg chg="mod">
+          <ac:chgData name="张 智" userId="36bdf691fd3510be" providerId="LiveId" clId="{F20A470C-BF10-42F8-AC2A-1C3CAE1C0A18}" dt="2023-05-11T15:13:45.068" v="5994" actId="20577"/>
+          <ac:spMkLst>
+            <pc:docMk/>
+            <pc:sldMk cId="811672812" sldId="444"/>
+            <ac:spMk id="2" creationId="{5C4F01C5-5333-2248-B03B-703C97F7CC69}"/>
+          </ac:spMkLst>
+        </pc:spChg>
+        <pc:spChg chg="mod">
+          <ac:chgData name="张 智" userId="36bdf691fd3510be" providerId="LiveId" clId="{F20A470C-BF10-42F8-AC2A-1C3CAE1C0A18}" dt="2023-05-15T03:16:50.896" v="17296" actId="20577"/>
+          <ac:spMkLst>
+            <pc:docMk/>
+            <pc:sldMk cId="811672812" sldId="444"/>
+            <ac:spMk id="3" creationId="{F7DD7DCB-C7E2-1B4F-BD83-3B7AF005DD76}"/>
+          </ac:spMkLst>
+        </pc:spChg>
+      </pc:sldChg>
+      <pc:sldChg chg="modSp add mod ord modNotesTx">
+        <pc:chgData name="张 智" userId="36bdf691fd3510be" providerId="LiveId" clId="{F20A470C-BF10-42F8-AC2A-1C3CAE1C0A18}" dt="2023-05-15T03:14:37.964" v="17154" actId="20577"/>
+        <pc:sldMkLst>
+          <pc:docMk/>
+          <pc:sldMk cId="1306094259" sldId="445"/>
+        </pc:sldMkLst>
+        <pc:spChg chg="mod">
+          <ac:chgData name="张 智" userId="36bdf691fd3510be" providerId="LiveId" clId="{F20A470C-BF10-42F8-AC2A-1C3CAE1C0A18}" dt="2023-05-11T15:13:48.589" v="5995"/>
+          <ac:spMkLst>
+            <pc:docMk/>
+            <pc:sldMk cId="1306094259" sldId="445"/>
+            <ac:spMk id="2" creationId="{5C4F01C5-5333-2248-B03B-703C97F7CC69}"/>
+          </ac:spMkLst>
+        </pc:spChg>
+        <pc:spChg chg="mod">
+          <ac:chgData name="张 智" userId="36bdf691fd3510be" providerId="LiveId" clId="{F20A470C-BF10-42F8-AC2A-1C3CAE1C0A18}" dt="2023-05-15T03:12:55.966" v="17028" actId="20577"/>
+          <ac:spMkLst>
+            <pc:docMk/>
+            <pc:sldMk cId="1306094259" sldId="445"/>
+            <ac:spMk id="3" creationId="{F7DD7DCB-C7E2-1B4F-BD83-3B7AF005DD76}"/>
+          </ac:spMkLst>
+        </pc:spChg>
+      </pc:sldChg>
+      <pc:sldChg chg="addSp modSp add mod modShow modNotesTx">
+        <pc:chgData name="张 智" userId="36bdf691fd3510be" providerId="LiveId" clId="{F20A470C-BF10-42F8-AC2A-1C3CAE1C0A18}" dt="2023-05-15T03:03:53.424" v="16504" actId="729"/>
+        <pc:sldMkLst>
+          <pc:docMk/>
+          <pc:sldMk cId="3163015254" sldId="446"/>
+        </pc:sldMkLst>
+        <pc:spChg chg="mod">
+          <ac:chgData name="张 智" userId="36bdf691fd3510be" providerId="LiveId" clId="{F20A470C-BF10-42F8-AC2A-1C3CAE1C0A18}" dt="2023-05-11T15:16:31.316" v="6024" actId="14100"/>
+          <ac:spMkLst>
+            <pc:docMk/>
+            <pc:sldMk cId="3163015254" sldId="446"/>
+            <ac:spMk id="3" creationId="{00000000-0000-0000-0000-000000000000}"/>
+          </ac:spMkLst>
+        </pc:spChg>
+        <pc:spChg chg="add mod">
+          <ac:chgData name="张 智" userId="36bdf691fd3510be" providerId="LiveId" clId="{F20A470C-BF10-42F8-AC2A-1C3CAE1C0A18}" dt="2023-05-11T15:16:23.112" v="6023" actId="20577"/>
+          <ac:spMkLst>
+            <pc:docMk/>
+            <pc:sldMk cId="3163015254" sldId="446"/>
+            <ac:spMk id="4" creationId="{8405AEEC-53B8-4912-9BFD-D803B111A508}"/>
+          </ac:spMkLst>
+        </pc:spChg>
+      </pc:sldChg>
+      <pc:sldChg chg="addSp modSp add mod modShow modNotesTx">
+        <pc:chgData name="张 智" userId="36bdf691fd3510be" providerId="LiveId" clId="{F20A470C-BF10-42F8-AC2A-1C3CAE1C0A18}" dt="2023-05-15T03:03:42.280" v="16503" actId="729"/>
+        <pc:sldMkLst>
+          <pc:docMk/>
+          <pc:sldMk cId="654170490" sldId="447"/>
+        </pc:sldMkLst>
+        <pc:spChg chg="mod">
+          <ac:chgData name="张 智" userId="36bdf691fd3510be" providerId="LiveId" clId="{F20A470C-BF10-42F8-AC2A-1C3CAE1C0A18}" dt="2023-05-11T15:19:56.971" v="6172" actId="1076"/>
+          <ac:spMkLst>
+            <pc:docMk/>
+            <pc:sldMk cId="654170490" sldId="447"/>
+            <ac:spMk id="3" creationId="{00000000-0000-0000-0000-000000000000}"/>
+          </ac:spMkLst>
+        </pc:spChg>
+        <pc:spChg chg="add mod">
+          <ac:chgData name="张 智" userId="36bdf691fd3510be" providerId="LiveId" clId="{F20A470C-BF10-42F8-AC2A-1C3CAE1C0A18}" dt="2023-05-11T15:19:40.621" v="6168"/>
+          <ac:spMkLst>
+            <pc:docMk/>
+            <pc:sldMk cId="654170490" sldId="447"/>
+            <ac:spMk id="4" creationId="{316F3021-8713-4FA6-A2CF-D301B3C21D37}"/>
+          </ac:spMkLst>
+        </pc:spChg>
+      </pc:sldChg>
+      <pc:sldChg chg="modSp add mod modShow modNotesTx">
+        <pc:chgData name="张 智" userId="36bdf691fd3510be" providerId="LiveId" clId="{F20A470C-BF10-42F8-AC2A-1C3CAE1C0A18}" dt="2023-05-15T03:03:36.742" v="16502" actId="729"/>
+        <pc:sldMkLst>
+          <pc:docMk/>
+          <pc:sldMk cId="2109074688" sldId="448"/>
+        </pc:sldMkLst>
+        <pc:spChg chg="mod">
+          <ac:chgData name="张 智" userId="36bdf691fd3510be" providerId="LiveId" clId="{F20A470C-BF10-42F8-AC2A-1C3CAE1C0A18}" dt="2023-05-11T15:22:12.415" v="6272" actId="20577"/>
+          <ac:spMkLst>
+            <pc:docMk/>
+            <pc:sldMk cId="2109074688" sldId="448"/>
+            <ac:spMk id="3" creationId="{00000000-0000-0000-0000-000000000000}"/>
+          </ac:spMkLst>
+        </pc:spChg>
+      </pc:sldChg>
+      <pc:sldChg chg="add mod modShow modNotesTx">
+        <pc:chgData name="张 智" userId="36bdf691fd3510be" providerId="LiveId" clId="{F20A470C-BF10-42F8-AC2A-1C3CAE1C0A18}" dt="2023-05-15T03:03:33.472" v="16501" actId="729"/>
+        <pc:sldMkLst>
+          <pc:docMk/>
+          <pc:sldMk cId="1772147089" sldId="449"/>
+        </pc:sldMkLst>
+      </pc:sldChg>
+      <pc:sldChg chg="modSp add mod modNotesTx">
+        <pc:chgData name="张 智" userId="36bdf691fd3510be" providerId="LiveId" clId="{F20A470C-BF10-42F8-AC2A-1C3CAE1C0A18}" dt="2023-05-15T03:30:40.975" v="17990" actId="20577"/>
+        <pc:sldMkLst>
+          <pc:docMk/>
+          <pc:sldMk cId="3392029162" sldId="450"/>
+        </pc:sldMkLst>
+        <pc:spChg chg="mod">
+          <ac:chgData name="张 智" userId="36bdf691fd3510be" providerId="LiveId" clId="{F20A470C-BF10-42F8-AC2A-1C3CAE1C0A18}" dt="2023-05-15T03:30:34.485" v="17989" actId="20577"/>
+          <ac:spMkLst>
+            <pc:docMk/>
+            <pc:sldMk cId="3392029162" sldId="450"/>
+            <ac:spMk id="7" creationId="{75E0A5E3-B5A7-40C6-9FE8-508ABF9E1458}"/>
+          </ac:spMkLst>
+        </pc:spChg>
+      </pc:sldChg>
+      <pc:sldChg chg="modSp add mod modNotesTx">
+        <pc:chgData name="张 智" userId="36bdf691fd3510be" providerId="LiveId" clId="{F20A470C-BF10-42F8-AC2A-1C3CAE1C0A18}" dt="2023-05-15T03:39:19.870" v="18129" actId="20577"/>
+        <pc:sldMkLst>
+          <pc:docMk/>
+          <pc:sldMk cId="3890419788" sldId="451"/>
+        </pc:sldMkLst>
+        <pc:spChg chg="mod">
+          <ac:chgData name="张 智" userId="36bdf691fd3510be" providerId="LiveId" clId="{F20A470C-BF10-42F8-AC2A-1C3CAE1C0A18}" dt="2023-05-13T02:34:48.019" v="7048" actId="1076"/>
+          <ac:spMkLst>
+            <pc:docMk/>
+            <pc:sldMk cId="3890419788" sldId="451"/>
+            <ac:spMk id="2" creationId="{92B3B218-E6B7-E949-9413-DBDFA9A361B9}"/>
+          </ac:spMkLst>
+        </pc:spChg>
+        <pc:spChg chg="mod">
+          <ac:chgData name="张 智" userId="36bdf691fd3510be" providerId="LiveId" clId="{F20A470C-BF10-42F8-AC2A-1C3CAE1C0A18}" dt="2023-05-14T14:12:07.734" v="10246" actId="20577"/>
+          <ac:spMkLst>
+            <pc:docMk/>
+            <pc:sldMk cId="3890419788" sldId="451"/>
+            <ac:spMk id="7" creationId="{75E0A5E3-B5A7-40C6-9FE8-508ABF9E1458}"/>
+          </ac:spMkLst>
+        </pc:spChg>
+      </pc:sldChg>
+      <pc:sldChg chg="modSp add mod modNotesTx">
+        <pc:chgData name="张 智" userId="36bdf691fd3510be" providerId="LiveId" clId="{F20A470C-BF10-42F8-AC2A-1C3CAE1C0A18}" dt="2023-05-15T03:29:00.315" v="17972" actId="20577"/>
+        <pc:sldMkLst>
+          <pc:docMk/>
+          <pc:sldMk cId="3667523257" sldId="452"/>
+        </pc:sldMkLst>
+        <pc:spChg chg="mod">
+          <ac:chgData name="张 智" userId="36bdf691fd3510be" providerId="LiveId" clId="{F20A470C-BF10-42F8-AC2A-1C3CAE1C0A18}" dt="2023-05-14T14:12:46.231" v="10253" actId="1076"/>
+          <ac:spMkLst>
+            <pc:docMk/>
+            <pc:sldMk cId="3667523257" sldId="452"/>
+            <ac:spMk id="2" creationId="{92B3B218-E6B7-E949-9413-DBDFA9A361B9}"/>
+          </ac:spMkLst>
+        </pc:spChg>
+        <pc:spChg chg="mod">
+          <ac:chgData name="张 智" userId="36bdf691fd3510be" providerId="LiveId" clId="{F20A470C-BF10-42F8-AC2A-1C3CAE1C0A18}" dt="2023-05-15T03:29:00.315" v="17972" actId="20577"/>
+          <ac:spMkLst>
+            <pc:docMk/>
+            <pc:sldMk cId="3667523257" sldId="452"/>
+            <ac:spMk id="7" creationId="{75E0A5E3-B5A7-40C6-9FE8-508ABF9E1458}"/>
+          </ac:spMkLst>
+        </pc:spChg>
+      </pc:sldChg>
+      <pc:sldChg chg="modSp add mod modNotesTx">
+        <pc:chgData name="张 智" userId="36bdf691fd3510be" providerId="LiveId" clId="{F20A470C-BF10-42F8-AC2A-1C3CAE1C0A18}" dt="2023-05-14T14:13:06.186" v="10261" actId="20577"/>
+        <pc:sldMkLst>
+          <pc:docMk/>
+          <pc:sldMk cId="3592248448" sldId="453"/>
+        </pc:sldMkLst>
+        <pc:spChg chg="mod">
+          <ac:chgData name="张 智" userId="36bdf691fd3510be" providerId="LiveId" clId="{F20A470C-BF10-42F8-AC2A-1C3CAE1C0A18}" dt="2023-05-14T14:12:55.679" v="10255" actId="1076"/>
+          <ac:spMkLst>
+            <pc:docMk/>
+            <pc:sldMk cId="3592248448" sldId="453"/>
+            <ac:spMk id="2" creationId="{92B3B218-E6B7-E949-9413-DBDFA9A361B9}"/>
+          </ac:spMkLst>
+        </pc:spChg>
+        <pc:spChg chg="mod">
+          <ac:chgData name="张 智" userId="36bdf691fd3510be" providerId="LiveId" clId="{F20A470C-BF10-42F8-AC2A-1C3CAE1C0A18}" dt="2023-05-14T14:13:06.186" v="10261" actId="20577"/>
+          <ac:spMkLst>
+            <pc:docMk/>
+            <pc:sldMk cId="3592248448" sldId="453"/>
+            <ac:spMk id="7" creationId="{75E0A5E3-B5A7-40C6-9FE8-508ABF9E1458}"/>
+          </ac:spMkLst>
+        </pc:spChg>
+      </pc:sldChg>
+      <pc:sldChg chg="addSp delSp modSp add mod modNotesTx">
+        <pc:chgData name="张 智" userId="36bdf691fd3510be" providerId="LiveId" clId="{F20A470C-BF10-42F8-AC2A-1C3CAE1C0A18}" dt="2023-05-15T03:30:56.067" v="17994" actId="20577"/>
+        <pc:sldMkLst>
+          <pc:docMk/>
+          <pc:sldMk cId="110243109" sldId="454"/>
+        </pc:sldMkLst>
+        <pc:spChg chg="mod">
+          <ac:chgData name="张 智" userId="36bdf691fd3510be" providerId="LiveId" clId="{F20A470C-BF10-42F8-AC2A-1C3CAE1C0A18}" dt="2023-05-13T03:09:03.310" v="7579" actId="27636"/>
+          <ac:spMkLst>
+            <pc:docMk/>
+            <pc:sldMk cId="110243109" sldId="454"/>
+            <ac:spMk id="2" creationId="{92B3B218-E6B7-E949-9413-DBDFA9A361B9}"/>
+          </ac:spMkLst>
+        </pc:spChg>
+        <pc:spChg chg="add del mod">
+          <ac:chgData name="张 智" userId="36bdf691fd3510be" providerId="LiveId" clId="{F20A470C-BF10-42F8-AC2A-1C3CAE1C0A18}" dt="2023-05-15T03:30:56.067" v="17994" actId="20577"/>
+          <ac:spMkLst>
+            <pc:docMk/>
+            <pc:sldMk cId="110243109" sldId="454"/>
+            <ac:spMk id="7" creationId="{75E0A5E3-B5A7-40C6-9FE8-508ABF9E1458}"/>
+          </ac:spMkLst>
+        </pc:spChg>
+      </pc:sldChg>
+      <pc:sldChg chg="modSp add mod ord">
+        <pc:chgData name="张 智" userId="36bdf691fd3510be" providerId="LiveId" clId="{F20A470C-BF10-42F8-AC2A-1C3CAE1C0A18}" dt="2023-05-13T11:03:34.504" v="8017" actId="20577"/>
+        <pc:sldMkLst>
+          <pc:docMk/>
+          <pc:sldMk cId="2414964948" sldId="455"/>
+        </pc:sldMkLst>
+        <pc:spChg chg="mod">
+          <ac:chgData name="张 智" userId="36bdf691fd3510be" providerId="LiveId" clId="{F20A470C-BF10-42F8-AC2A-1C3CAE1C0A18}" dt="2023-05-13T11:03:34.504" v="8017" actId="20577"/>
+          <ac:spMkLst>
+            <pc:docMk/>
+            <pc:sldMk cId="2414964948" sldId="455"/>
+            <ac:spMk id="7" creationId="{75E0A5E3-B5A7-40C6-9FE8-508ABF9E1458}"/>
+          </ac:spMkLst>
+        </pc:spChg>
+      </pc:sldChg>
+      <pc:sldChg chg="modSp add mod">
+        <pc:chgData name="张 智" userId="36bdf691fd3510be" providerId="LiveId" clId="{F20A470C-BF10-42F8-AC2A-1C3CAE1C0A18}" dt="2023-05-14T14:17:07.893" v="10315" actId="20577"/>
+        <pc:sldMkLst>
+          <pc:docMk/>
+          <pc:sldMk cId="1468594782" sldId="456"/>
+        </pc:sldMkLst>
+        <pc:spChg chg="mod">
+          <ac:chgData name="张 智" userId="36bdf691fd3510be" providerId="LiveId" clId="{F20A470C-BF10-42F8-AC2A-1C3CAE1C0A18}" dt="2023-05-14T14:17:07.893" v="10315" actId="20577"/>
+          <ac:spMkLst>
+            <pc:docMk/>
+            <pc:sldMk cId="1468594782" sldId="456"/>
+            <ac:spMk id="7" creationId="{75E0A5E3-B5A7-40C6-9FE8-508ABF9E1458}"/>
+          </ac:spMkLst>
+        </pc:spChg>
+      </pc:sldChg>
+      <pc:sldChg chg="addSp delSp modSp add mod">
+        <pc:chgData name="张 智" userId="36bdf691fd3510be" providerId="LiveId" clId="{F20A470C-BF10-42F8-AC2A-1C3CAE1C0A18}" dt="2023-05-13T13:20:20.291" v="8785" actId="207"/>
+        <pc:sldMkLst>
+          <pc:docMk/>
+          <pc:sldMk cId="631149133" sldId="457"/>
+        </pc:sldMkLst>
+        <pc:spChg chg="add del">
+          <ac:chgData name="张 智" userId="36bdf691fd3510be" providerId="LiveId" clId="{F20A470C-BF10-42F8-AC2A-1C3CAE1C0A18}" dt="2023-05-13T12:31:35.145" v="8210" actId="22"/>
+          <ac:spMkLst>
+            <pc:docMk/>
+            <pc:sldMk cId="631149133" sldId="457"/>
+            <ac:spMk id="5" creationId="{C679AE2B-B4A3-4300-BC1D-B0F462386990}"/>
+          </ac:spMkLst>
+        </pc:spChg>
+        <pc:spChg chg="add del mod">
+          <ac:chgData name="张 智" userId="36bdf691fd3510be" providerId="LiveId" clId="{F20A470C-BF10-42F8-AC2A-1C3CAE1C0A18}" dt="2023-05-13T13:20:20.291" v="8785" actId="207"/>
+          <ac:spMkLst>
+            <pc:docMk/>
+            <pc:sldMk cId="631149133" sldId="457"/>
+            <ac:spMk id="7" creationId="{75E0A5E3-B5A7-40C6-9FE8-508ABF9E1458}"/>
+          </ac:spMkLst>
+        </pc:spChg>
+      </pc:sldChg>
+      <pc:sldChg chg="modSp add mod">
+        <pc:chgData name="张 智" userId="36bdf691fd3510be" providerId="LiveId" clId="{F20A470C-BF10-42F8-AC2A-1C3CAE1C0A18}" dt="2023-05-15T03:31:25.805" v="17996" actId="20577"/>
+        <pc:sldMkLst>
+          <pc:docMk/>
+          <pc:sldMk cId="1803946351" sldId="458"/>
+        </pc:sldMkLst>
+        <pc:spChg chg="mod">
+          <ac:chgData name="张 智" userId="36bdf691fd3510be" providerId="LiveId" clId="{F20A470C-BF10-42F8-AC2A-1C3CAE1C0A18}" dt="2023-05-15T03:31:25.805" v="17996" actId="20577"/>
+          <ac:spMkLst>
+            <pc:docMk/>
+            <pc:sldMk cId="1803946351" sldId="458"/>
+            <ac:spMk id="7" creationId="{75E0A5E3-B5A7-40C6-9FE8-508ABF9E1458}"/>
+          </ac:spMkLst>
+        </pc:spChg>
+      </pc:sldChg>
+      <pc:sldChg chg="modSp add mod">
+        <pc:chgData name="张 智" userId="36bdf691fd3510be" providerId="LiveId" clId="{F20A470C-BF10-42F8-AC2A-1C3CAE1C0A18}" dt="2023-05-15T03:31:41.639" v="18000" actId="20577"/>
+        <pc:sldMkLst>
+          <pc:docMk/>
+          <pc:sldMk cId="2410610366" sldId="459"/>
+        </pc:sldMkLst>
+        <pc:spChg chg="mod">
+          <ac:chgData name="张 智" userId="36bdf691fd3510be" providerId="LiveId" clId="{F20A470C-BF10-42F8-AC2A-1C3CAE1C0A18}" dt="2023-05-15T03:31:41.639" v="18000" actId="20577"/>
+          <ac:spMkLst>
+            <pc:docMk/>
+            <pc:sldMk cId="2410610366" sldId="459"/>
+            <ac:spMk id="3" creationId="{13DB3674-2D4B-8645-8753-8E30E629B377}"/>
+          </ac:spMkLst>
+        </pc:spChg>
+      </pc:sldChg>
+      <pc:sldChg chg="modSp add mod">
+        <pc:chgData name="张 智" userId="36bdf691fd3510be" providerId="LiveId" clId="{F20A470C-BF10-42F8-AC2A-1C3CAE1C0A18}" dt="2023-05-14T14:45:30.472" v="10706" actId="20577"/>
+        <pc:sldMkLst>
+          <pc:docMk/>
+          <pc:sldMk cId="1436142334" sldId="460"/>
+        </pc:sldMkLst>
+        <pc:spChg chg="mod">
+          <ac:chgData name="张 智" userId="36bdf691fd3510be" providerId="LiveId" clId="{F20A470C-BF10-42F8-AC2A-1C3CAE1C0A18}" dt="2023-05-14T14:45:30.472" v="10706" actId="20577"/>
+          <ac:spMkLst>
+            <pc:docMk/>
+            <pc:sldMk cId="1436142334" sldId="460"/>
+            <ac:spMk id="3" creationId="{13DB3674-2D4B-8645-8753-8E30E629B377}"/>
+          </ac:spMkLst>
+        </pc:spChg>
+      </pc:sldChg>
+      <pc:sldChg chg="modSp add mod">
+        <pc:chgData name="张 智" userId="36bdf691fd3510be" providerId="LiveId" clId="{F20A470C-BF10-42F8-AC2A-1C3CAE1C0A18}" dt="2023-05-14T14:12:43.303" v="10252" actId="1076"/>
+        <pc:sldMkLst>
+          <pc:docMk/>
+          <pc:sldMk cId="3626462958" sldId="461"/>
+        </pc:sldMkLst>
+        <pc:spChg chg="mod">
+          <ac:chgData name="张 智" userId="36bdf691fd3510be" providerId="LiveId" clId="{F20A470C-BF10-42F8-AC2A-1C3CAE1C0A18}" dt="2023-05-14T14:12:43.303" v="10252" actId="1076"/>
+          <ac:spMkLst>
+            <pc:docMk/>
+            <pc:sldMk cId="3626462958" sldId="461"/>
+            <ac:spMk id="2" creationId="{92B3B218-E6B7-E949-9413-DBDFA9A361B9}"/>
+          </ac:spMkLst>
+        </pc:spChg>
+      </pc:sldChg>
+      <pc:sldChg chg="modSp add mod">
+        <pc:chgData name="张 智" userId="36bdf691fd3510be" providerId="LiveId" clId="{F20A470C-BF10-42F8-AC2A-1C3CAE1C0A18}" dt="2023-05-14T14:12:51.311" v="10254" actId="1076"/>
+        <pc:sldMkLst>
+          <pc:docMk/>
+          <pc:sldMk cId="1628170773" sldId="462"/>
+        </pc:sldMkLst>
+        <pc:spChg chg="mod">
+          <ac:chgData name="张 智" userId="36bdf691fd3510be" providerId="LiveId" clId="{F20A470C-BF10-42F8-AC2A-1C3CAE1C0A18}" dt="2023-05-14T14:12:51.311" v="10254" actId="1076"/>
+          <ac:spMkLst>
+            <pc:docMk/>
+            <pc:sldMk cId="1628170773" sldId="462"/>
+            <ac:spMk id="2" creationId="{92B3B218-E6B7-E949-9413-DBDFA9A361B9}"/>
+          </ac:spMkLst>
+        </pc:spChg>
+        <pc:spChg chg="mod">
+          <ac:chgData name="张 智" userId="36bdf691fd3510be" providerId="LiveId" clId="{F20A470C-BF10-42F8-AC2A-1C3CAE1C0A18}" dt="2023-05-14T14:12:23.425" v="10251" actId="20577"/>
+          <ac:spMkLst>
+            <pc:docMk/>
+            <pc:sldMk cId="1628170773" sldId="462"/>
+            <ac:spMk id="7" creationId="{75E0A5E3-B5A7-40C6-9FE8-508ABF9E1458}"/>
+          </ac:spMkLst>
+        </pc:spChg>
+      </pc:sldChg>
+      <pc:sldChg chg="add">
+        <pc:chgData name="张 智" userId="36bdf691fd3510be" providerId="LiveId" clId="{F20A470C-BF10-42F8-AC2A-1C3CAE1C0A18}" dt="2023-05-14T14:12:59.247" v="10256"/>
+        <pc:sldMkLst>
+          <pc:docMk/>
+          <pc:sldMk cId="3533530707" sldId="463"/>
+        </pc:sldMkLst>
+      </pc:sldChg>
+      <pc:sldChg chg="modSp add mod">
+        <pc:chgData name="张 智" userId="36bdf691fd3510be" providerId="LiveId" clId="{F20A470C-BF10-42F8-AC2A-1C3CAE1C0A18}" dt="2023-05-14T14:16:49.229" v="10313" actId="20577"/>
+        <pc:sldMkLst>
+          <pc:docMk/>
+          <pc:sldMk cId="1690056961" sldId="464"/>
+        </pc:sldMkLst>
+        <pc:spChg chg="mod">
+          <ac:chgData name="张 智" userId="36bdf691fd3510be" providerId="LiveId" clId="{F20A470C-BF10-42F8-AC2A-1C3CAE1C0A18}" dt="2023-05-14T14:16:49.229" v="10313" actId="20577"/>
+          <ac:spMkLst>
+            <pc:docMk/>
+            <pc:sldMk cId="1690056961" sldId="464"/>
+            <ac:spMk id="7" creationId="{75E0A5E3-B5A7-40C6-9FE8-508ABF9E1458}"/>
+          </ac:spMkLst>
+        </pc:spChg>
+      </pc:sldChg>
+      <pc:sldChg chg="modSp add mod">
+        <pc:chgData name="张 智" userId="36bdf691fd3510be" providerId="LiveId" clId="{F20A470C-BF10-42F8-AC2A-1C3CAE1C0A18}" dt="2023-05-14T14:16:08.422" v="10299" actId="20577"/>
+        <pc:sldMkLst>
+          <pc:docMk/>
+          <pc:sldMk cId="822221007" sldId="465"/>
+        </pc:sldMkLst>
+        <pc:spChg chg="mod">
+          <ac:chgData name="张 智" userId="36bdf691fd3510be" providerId="LiveId" clId="{F20A470C-BF10-42F8-AC2A-1C3CAE1C0A18}" dt="2023-05-14T14:16:08.422" v="10299" actId="20577"/>
+          <ac:spMkLst>
+            <pc:docMk/>
+            <pc:sldMk cId="822221007" sldId="465"/>
+            <ac:spMk id="7" creationId="{75E0A5E3-B5A7-40C6-9FE8-508ABF9E1458}"/>
+          </ac:spMkLst>
+        </pc:spChg>
+      </pc:sldChg>
+      <pc:sldChg chg="modSp add del mod ord">
+        <pc:chgData name="张 智" userId="36bdf691fd3510be" providerId="LiveId" clId="{F20A470C-BF10-42F8-AC2A-1C3CAE1C0A18}" dt="2023-05-14T14:16:43.942" v="10309" actId="20577"/>
+        <pc:sldMkLst>
+          <pc:docMk/>
+          <pc:sldMk cId="1462745473" sldId="466"/>
+        </pc:sldMkLst>
+        <pc:spChg chg="mod">
+          <ac:chgData name="张 智" userId="36bdf691fd3510be" providerId="LiveId" clId="{F20A470C-BF10-42F8-AC2A-1C3CAE1C0A18}" dt="2023-05-14T14:16:43.942" v="10309" actId="20577"/>
+          <ac:spMkLst>
+            <pc:docMk/>
+            <pc:sldMk cId="1462745473" sldId="466"/>
+            <ac:spMk id="7" creationId="{75E0A5E3-B5A7-40C6-9FE8-508ABF9E1458}"/>
+          </ac:spMkLst>
+        </pc:spChg>
+      </pc:sldChg>
+      <pc:sldChg chg="modSp add mod ord">
+        <pc:chgData name="张 智" userId="36bdf691fd3510be" providerId="LiveId" clId="{F20A470C-BF10-42F8-AC2A-1C3CAE1C0A18}" dt="2023-05-14T14:16:39.397" v="10305" actId="20577"/>
+        <pc:sldMkLst>
+          <pc:docMk/>
+          <pc:sldMk cId="56589812" sldId="467"/>
+        </pc:sldMkLst>
+        <pc:spChg chg="mod">
+          <ac:chgData name="张 智" userId="36bdf691fd3510be" providerId="LiveId" clId="{F20A470C-BF10-42F8-AC2A-1C3CAE1C0A18}" dt="2023-05-14T14:16:39.397" v="10305" actId="20577"/>
+          <ac:spMkLst>
+            <pc:docMk/>
+            <pc:sldMk cId="56589812" sldId="467"/>
+            <ac:spMk id="7" creationId="{75E0A5E3-B5A7-40C6-9FE8-508ABF9E1458}"/>
+          </ac:spMkLst>
+        </pc:spChg>
+      </pc:sldChg>
+      <pc:sldChg chg="modSp add mod">
+        <pc:chgData name="张 智" userId="36bdf691fd3510be" providerId="LiveId" clId="{F20A470C-BF10-42F8-AC2A-1C3CAE1C0A18}" dt="2023-05-14T14:17:19.720" v="10317" actId="20577"/>
+        <pc:sldMkLst>
+          <pc:docMk/>
+          <pc:sldMk cId="2017251195" sldId="468"/>
+        </pc:sldMkLst>
+        <pc:spChg chg="mod">
+          <ac:chgData name="张 智" userId="36bdf691fd3510be" providerId="LiveId" clId="{F20A470C-BF10-42F8-AC2A-1C3CAE1C0A18}" dt="2023-05-14T14:17:19.720" v="10317" actId="20577"/>
+          <ac:spMkLst>
+            <pc:docMk/>
+            <pc:sldMk cId="2017251195" sldId="468"/>
+            <ac:spMk id="7" creationId="{75E0A5E3-B5A7-40C6-9FE8-508ABF9E1458}"/>
+          </ac:spMkLst>
+        </pc:spChg>
+      </pc:sldChg>
+      <pc:sldChg chg="add">
+        <pc:chgData name="张 智" userId="36bdf691fd3510be" providerId="LiveId" clId="{F20A470C-BF10-42F8-AC2A-1C3CAE1C0A18}" dt="2023-05-14T14:17:13.282" v="10316"/>
+        <pc:sldMkLst>
+          <pc:docMk/>
+          <pc:sldMk cId="3286154215" sldId="469"/>
+        </pc:sldMkLst>
+      </pc:sldChg>
+      <pc:sldChg chg="modSp add mod">
+        <pc:chgData name="张 智" userId="36bdf691fd3510be" providerId="LiveId" clId="{F20A470C-BF10-42F8-AC2A-1C3CAE1C0A18}" dt="2023-05-14T14:18:01.208" v="10327" actId="20577"/>
+        <pc:sldMkLst>
+          <pc:docMk/>
+          <pc:sldMk cId="1574098949" sldId="470"/>
+        </pc:sldMkLst>
+        <pc:spChg chg="mod">
+          <ac:chgData name="张 智" userId="36bdf691fd3510be" providerId="LiveId" clId="{F20A470C-BF10-42F8-AC2A-1C3CAE1C0A18}" dt="2023-05-14T14:18:01.208" v="10327" actId="20577"/>
+          <ac:spMkLst>
+            <pc:docMk/>
+            <pc:sldMk cId="1574098949" sldId="470"/>
+            <ac:spMk id="7" creationId="{75E0A5E3-B5A7-40C6-9FE8-508ABF9E1458}"/>
+          </ac:spMkLst>
+        </pc:spChg>
+      </pc:sldChg>
+      <pc:sldChg chg="add">
+        <pc:chgData name="张 智" userId="36bdf691fd3510be" providerId="LiveId" clId="{F20A470C-BF10-42F8-AC2A-1C3CAE1C0A18}" dt="2023-05-14T14:17:55.931" v="10324"/>
+        <pc:sldMkLst>
+          <pc:docMk/>
+          <pc:sldMk cId="2544237434" sldId="471"/>
+        </pc:sldMkLst>
+      </pc:sldChg>
+      <pc:sldChg chg="modSp add mod">
+        <pc:chgData name="张 智" userId="36bdf691fd3510be" providerId="LiveId" clId="{F20A470C-BF10-42F8-AC2A-1C3CAE1C0A18}" dt="2023-05-14T14:51:10.311" v="10983" actId="20577"/>
+        <pc:sldMkLst>
+          <pc:docMk/>
+          <pc:sldMk cId="500213869" sldId="472"/>
+        </pc:sldMkLst>
+        <pc:spChg chg="mod">
+          <ac:chgData name="张 智" userId="36bdf691fd3510be" providerId="LiveId" clId="{F20A470C-BF10-42F8-AC2A-1C3CAE1C0A18}" dt="2023-05-14T14:51:10.311" v="10983" actId="20577"/>
+          <ac:spMkLst>
+            <pc:docMk/>
+            <pc:sldMk cId="500213869" sldId="472"/>
+            <ac:spMk id="3" creationId="{13DB3674-2D4B-8645-8753-8E30E629B377}"/>
+          </ac:spMkLst>
+        </pc:spChg>
+      </pc:sldChg>
+      <pc:sldChg chg="modSp add mod">
+        <pc:chgData name="张 智" userId="36bdf691fd3510be" providerId="LiveId" clId="{F20A470C-BF10-42F8-AC2A-1C3CAE1C0A18}" dt="2023-05-14T15:00:52.023" v="11168" actId="12"/>
+        <pc:sldMkLst>
+          <pc:docMk/>
+          <pc:sldMk cId="4283821982" sldId="473"/>
+        </pc:sldMkLst>
+        <pc:spChg chg="mod">
+          <ac:chgData name="张 智" userId="36bdf691fd3510be" providerId="LiveId" clId="{F20A470C-BF10-42F8-AC2A-1C3CAE1C0A18}" dt="2023-05-14T15:00:52.023" v="11168" actId="12"/>
+          <ac:spMkLst>
+            <pc:docMk/>
+            <pc:sldMk cId="4283821982" sldId="473"/>
+            <ac:spMk id="3" creationId="{13DB3674-2D4B-8645-8753-8E30E629B377}"/>
+          </ac:spMkLst>
+        </pc:spChg>
+      </pc:sldChg>
+      <pc:sldChg chg="modSp add mod">
+        <pc:chgData name="张 智" userId="36bdf691fd3510be" providerId="LiveId" clId="{F20A470C-BF10-42F8-AC2A-1C3CAE1C0A18}" dt="2023-05-14T15:00:35.616" v="11167" actId="12"/>
+        <pc:sldMkLst>
+          <pc:docMk/>
+          <pc:sldMk cId="1636182554" sldId="474"/>
+        </pc:sldMkLst>
+        <pc:spChg chg="mod">
+          <ac:chgData name="张 智" userId="36bdf691fd3510be" providerId="LiveId" clId="{F20A470C-BF10-42F8-AC2A-1C3CAE1C0A18}" dt="2023-05-14T15:00:35.616" v="11167" actId="12"/>
+          <ac:spMkLst>
+            <pc:docMk/>
+            <pc:sldMk cId="1636182554" sldId="474"/>
+            <ac:spMk id="3" creationId="{13DB3674-2D4B-8645-8753-8E30E629B377}"/>
+          </ac:spMkLst>
+        </pc:spChg>
+      </pc:sldChg>
+      <pc:sldChg chg="modSp add mod">
+        <pc:chgData name="张 智" userId="36bdf691fd3510be" providerId="LiveId" clId="{F20A470C-BF10-42F8-AC2A-1C3CAE1C0A18}" dt="2023-05-15T03:32:09.331" v="18004" actId="20577"/>
+        <pc:sldMkLst>
+          <pc:docMk/>
+          <pc:sldMk cId="3151914030" sldId="475"/>
+        </pc:sldMkLst>
+        <pc:spChg chg="mod">
+          <ac:chgData name="张 智" userId="36bdf691fd3510be" providerId="LiveId" clId="{F20A470C-BF10-42F8-AC2A-1C3CAE1C0A18}" dt="2023-05-14T14:58:59.103" v="11148" actId="14100"/>
+          <ac:spMkLst>
+            <pc:docMk/>
+            <pc:sldMk cId="3151914030" sldId="475"/>
+            <ac:spMk id="2" creationId="{92B3B218-E6B7-E949-9413-DBDFA9A361B9}"/>
+          </ac:spMkLst>
+        </pc:spChg>
+        <pc:spChg chg="mod">
+          <ac:chgData name="张 智" userId="36bdf691fd3510be" providerId="LiveId" clId="{F20A470C-BF10-42F8-AC2A-1C3CAE1C0A18}" dt="2023-05-15T03:32:09.331" v="18004" actId="20577"/>
+          <ac:spMkLst>
+            <pc:docMk/>
+            <pc:sldMk cId="3151914030" sldId="475"/>
+            <ac:spMk id="3" creationId="{13DB3674-2D4B-8645-8753-8E30E629B377}"/>
+          </ac:spMkLst>
+        </pc:spChg>
+      </pc:sldChg>
+      <pc:sldChg chg="modSp add mod modNotesTx">
+        <pc:chgData name="张 智" userId="36bdf691fd3510be" providerId="LiveId" clId="{F20A470C-BF10-42F8-AC2A-1C3CAE1C0A18}" dt="2023-05-14T15:12:22.580" v="11482" actId="20577"/>
+        <pc:sldMkLst>
+          <pc:docMk/>
+          <pc:sldMk cId="97459469" sldId="476"/>
+        </pc:sldMkLst>
+        <pc:spChg chg="mod">
+          <ac:chgData name="张 智" userId="36bdf691fd3510be" providerId="LiveId" clId="{F20A470C-BF10-42F8-AC2A-1C3CAE1C0A18}" dt="2023-05-14T15:12:22.580" v="11482" actId="20577"/>
+          <ac:spMkLst>
+            <pc:docMk/>
+            <pc:sldMk cId="97459469" sldId="476"/>
+            <ac:spMk id="3" creationId="{13DB3674-2D4B-8645-8753-8E30E629B377}"/>
+          </ac:spMkLst>
+        </pc:spChg>
+      </pc:sldChg>
+      <pc:sldChg chg="add">
+        <pc:chgData name="张 智" userId="36bdf691fd3510be" providerId="LiveId" clId="{F20A470C-BF10-42F8-AC2A-1C3CAE1C0A18}" dt="2023-05-14T15:12:18.711" v="11479"/>
+        <pc:sldMkLst>
+          <pc:docMk/>
+          <pc:sldMk cId="4081096777" sldId="477"/>
+        </pc:sldMkLst>
+      </pc:sldChg>
+      <pc:sldChg chg="modSp add mod modNotesTx">
+        <pc:chgData name="张 智" userId="36bdf691fd3510be" providerId="LiveId" clId="{F20A470C-BF10-42F8-AC2A-1C3CAE1C0A18}" dt="2023-05-14T15:15:28.942" v="11510" actId="27636"/>
+        <pc:sldMkLst>
+          <pc:docMk/>
+          <pc:sldMk cId="4015799420" sldId="478"/>
+        </pc:sldMkLst>
+        <pc:spChg chg="mod">
+          <ac:chgData name="张 智" userId="36bdf691fd3510be" providerId="LiveId" clId="{F20A470C-BF10-42F8-AC2A-1C3CAE1C0A18}" dt="2023-05-14T15:15:28.942" v="11510" actId="27636"/>
+          <ac:spMkLst>
+            <pc:docMk/>
+            <pc:sldMk cId="4015799420" sldId="478"/>
+            <ac:spMk id="3" creationId="{13DB3674-2D4B-8645-8753-8E30E629B377}"/>
+          </ac:spMkLst>
+        </pc:spChg>
+      </pc:sldChg>
+      <pc:sldChg chg="modSp add mod">
+        <pc:chgData name="张 智" userId="36bdf691fd3510be" providerId="LiveId" clId="{F20A470C-BF10-42F8-AC2A-1C3CAE1C0A18}" dt="2023-05-14T15:18:04.850" v="11585" actId="20577"/>
+        <pc:sldMkLst>
+          <pc:docMk/>
+          <pc:sldMk cId="3022655673" sldId="479"/>
+        </pc:sldMkLst>
+        <pc:spChg chg="mod">
+          <ac:chgData name="张 智" userId="36bdf691fd3510be" providerId="LiveId" clId="{F20A470C-BF10-42F8-AC2A-1C3CAE1C0A18}" dt="2023-05-14T15:18:04.850" v="11585" actId="20577"/>
+          <ac:spMkLst>
+            <pc:docMk/>
+            <pc:sldMk cId="3022655673" sldId="479"/>
+            <ac:spMk id="3" creationId="{13DB3674-2D4B-8645-8753-8E30E629B377}"/>
+          </ac:spMkLst>
+        </pc:spChg>
+      </pc:sldChg>
+      <pc:sldChg chg="modSp add mod modNotesTx">
+        <pc:chgData name="张 智" userId="36bdf691fd3510be" providerId="LiveId" clId="{F20A470C-BF10-42F8-AC2A-1C3CAE1C0A18}" dt="2023-05-15T03:38:33.209" v="18089" actId="14100"/>
+        <pc:sldMkLst>
+          <pc:docMk/>
+          <pc:sldMk cId="214179768" sldId="480"/>
+        </pc:sldMkLst>
+        <pc:spChg chg="mod">
+          <ac:chgData name="张 智" userId="36bdf691fd3510be" providerId="LiveId" clId="{F20A470C-BF10-42F8-AC2A-1C3CAE1C0A18}" dt="2023-05-15T03:38:33.209" v="18089" actId="14100"/>
+          <ac:spMkLst>
+            <pc:docMk/>
+            <pc:sldMk cId="214179768" sldId="480"/>
+            <ac:spMk id="7" creationId="{75E0A5E3-B5A7-40C6-9FE8-508ABF9E1458}"/>
+          </ac:spMkLst>
+        </pc:spChg>
+      </pc:sldChg>
+      <pc:sldChg chg="add">
+        <pc:chgData name="张 智" userId="36bdf691fd3510be" providerId="LiveId" clId="{F20A470C-BF10-42F8-AC2A-1C3CAE1C0A18}" dt="2023-05-15T03:30:49.997" v="17991"/>
+        <pc:sldMkLst>
+          <pc:docMk/>
+          <pc:sldMk cId="2857348335" sldId="481"/>
+        </pc:sldMkLst>
+      </pc:sldChg>
+      <pc:sldChg chg="add">
+        <pc:chgData name="张 智" userId="36bdf691fd3510be" providerId="LiveId" clId="{F20A470C-BF10-42F8-AC2A-1C3CAE1C0A18}" dt="2023-05-15T03:31:21.810" v="17995"/>
+        <pc:sldMkLst>
+          <pc:docMk/>
+          <pc:sldMk cId="1557232649" sldId="482"/>
+        </pc:sldMkLst>
+      </pc:sldChg>
+      <pc:sldChg chg="add">
+        <pc:chgData name="张 智" userId="36bdf691fd3510be" providerId="LiveId" clId="{F20A470C-BF10-42F8-AC2A-1C3CAE1C0A18}" dt="2023-05-15T03:31:37.059" v="17997"/>
+        <pc:sldMkLst>
+          <pc:docMk/>
+          <pc:sldMk cId="3101025385" sldId="483"/>
+        </pc:sldMkLst>
+      </pc:sldChg>
+      <pc:sldChg chg="add">
+        <pc:chgData name="张 智" userId="36bdf691fd3510be" providerId="LiveId" clId="{F20A470C-BF10-42F8-AC2A-1C3CAE1C0A18}" dt="2023-05-15T03:32:02.727" v="18001"/>
+        <pc:sldMkLst>
+          <pc:docMk/>
+          <pc:sldMk cId="1375948752" sldId="484"/>
+        </pc:sldMkLst>
+      </pc:sldChg>
+    </pc:docChg>
+  </pc:docChgLst>
+  <pc:docChgLst>
+    <pc:chgData name="张 智" userId="36bdf691fd3510be" providerId="LiveId" clId="{AE5DED4F-DA00-4450-AB73-450C993BC4FD}"/>
+    <pc:docChg chg="undo custSel addSld delSld modSld">
+      <pc:chgData name="张 智" userId="36bdf691fd3510be" providerId="LiveId" clId="{AE5DED4F-DA00-4450-AB73-450C993BC4FD}" dt="2024-05-27T07:09:53.833" v="10408" actId="207"/>
+      <pc:docMkLst>
+        <pc:docMk/>
+      </pc:docMkLst>
+      <pc:sldChg chg="modNotesTx">
+        <pc:chgData name="张 智" userId="36bdf691fd3510be" providerId="LiveId" clId="{AE5DED4F-DA00-4450-AB73-450C993BC4FD}" dt="2024-05-13T02:30:57.510" v="8945" actId="20577"/>
+        <pc:sldMkLst>
+          <pc:docMk/>
+          <pc:sldMk cId="1077586671" sldId="256"/>
+        </pc:sldMkLst>
+      </pc:sldChg>
+      <pc:sldChg chg="modSp mod modNotesTx">
+        <pc:chgData name="张 智" userId="36bdf691fd3510be" providerId="LiveId" clId="{AE5DED4F-DA00-4450-AB73-450C993BC4FD}" dt="2024-05-13T05:41:47.666" v="10286" actId="20577"/>
+        <pc:sldMkLst>
+          <pc:docMk/>
+          <pc:sldMk cId="1112541085" sldId="260"/>
+        </pc:sldMkLst>
+        <pc:spChg chg="mod">
+          <ac:chgData name="张 智" userId="36bdf691fd3510be" providerId="LiveId" clId="{AE5DED4F-DA00-4450-AB73-450C993BC4FD}" dt="2024-05-13T05:41:47.666" v="10286" actId="20577"/>
+          <ac:spMkLst>
+            <pc:docMk/>
+            <pc:sldMk cId="1112541085" sldId="260"/>
+            <ac:spMk id="3" creationId="{F7DD7DCB-C7E2-1B4F-BD83-3B7AF005DD76}"/>
+          </ac:spMkLst>
+        </pc:spChg>
+      </pc:sldChg>
+      <pc:sldChg chg="modSp mod modNotesTx">
+        <pc:chgData name="张 智" userId="36bdf691fd3510be" providerId="LiveId" clId="{AE5DED4F-DA00-4450-AB73-450C993BC4FD}" dt="2024-05-12T14:13:53.288" v="5090" actId="20577"/>
+        <pc:sldMkLst>
+          <pc:docMk/>
+          <pc:sldMk cId="182683393" sldId="272"/>
+        </pc:sldMkLst>
+        <pc:spChg chg="mod">
+          <ac:chgData name="张 智" userId="36bdf691fd3510be" providerId="LiveId" clId="{AE5DED4F-DA00-4450-AB73-450C993BC4FD}" dt="2024-05-09T07:59:09.426" v="937" actId="20577"/>
+          <ac:spMkLst>
+            <pc:docMk/>
+            <pc:sldMk cId="182683393" sldId="272"/>
+            <ac:spMk id="7" creationId="{75E0A5E3-B5A7-40C6-9FE8-508ABF9E1458}"/>
+          </ac:spMkLst>
+        </pc:spChg>
+      </pc:sldChg>
+      <pc:sldChg chg="del">
+        <pc:chgData name="张 智" userId="36bdf691fd3510be" providerId="LiveId" clId="{AE5DED4F-DA00-4450-AB73-450C993BC4FD}" dt="2024-05-09T05:55:39.187" v="43" actId="47"/>
+        <pc:sldMkLst>
+          <pc:docMk/>
+          <pc:sldMk cId="417064799" sldId="381"/>
+        </pc:sldMkLst>
+      </pc:sldChg>
+      <pc:sldChg chg="modSp mod modNotesTx">
+        <pc:chgData name="张 智" userId="36bdf691fd3510be" providerId="LiveId" clId="{AE5DED4F-DA00-4450-AB73-450C993BC4FD}" dt="2024-05-12T14:03:21.660" v="4978" actId="20577"/>
+        <pc:sldMkLst>
+          <pc:docMk/>
+          <pc:sldMk cId="1836985979" sldId="386"/>
+        </pc:sldMkLst>
+        <pc:spChg chg="mod">
+          <ac:chgData name="张 智" userId="36bdf691fd3510be" providerId="LiveId" clId="{AE5DED4F-DA00-4450-AB73-450C993BC4FD}" dt="2024-05-12T09:00:57.157" v="4233" actId="27636"/>
+          <ac:spMkLst>
+            <pc:docMk/>
+            <pc:sldMk cId="1836985979" sldId="386"/>
+            <ac:spMk id="3" creationId="{BF67693E-A48F-4F32-8586-A906B0CE6024}"/>
+          </ac:spMkLst>
+        </pc:spChg>
+      </pc:sldChg>
+      <pc:sldChg chg="modSp mod">
+        <pc:chgData name="张 智" userId="36bdf691fd3510be" providerId="LiveId" clId="{AE5DED4F-DA00-4450-AB73-450C993BC4FD}" dt="2024-05-11T14:26:35.613" v="3200" actId="20577"/>
+        <pc:sldMkLst>
+          <pc:docMk/>
+          <pc:sldMk cId="2518083175" sldId="387"/>
+        </pc:sldMkLst>
+        <pc:spChg chg="mod">
+          <ac:chgData name="张 智" userId="36bdf691fd3510be" providerId="LiveId" clId="{AE5DED4F-DA00-4450-AB73-450C993BC4FD}" dt="2024-05-11T14:26:35.613" v="3200" actId="20577"/>
+          <ac:spMkLst>
+            <pc:docMk/>
+            <pc:sldMk cId="2518083175" sldId="387"/>
+            <ac:spMk id="3" creationId="{13DB3674-2D4B-8645-8753-8E30E629B377}"/>
+          </ac:spMkLst>
+        </pc:spChg>
+      </pc:sldChg>
+      <pc:sldChg chg="modSp mod modNotesTx">
+        <pc:chgData name="张 智" userId="36bdf691fd3510be" providerId="LiveId" clId="{AE5DED4F-DA00-4450-AB73-450C993BC4FD}" dt="2024-05-11T14:18:43.674" v="3097" actId="20577"/>
+        <pc:sldMkLst>
+          <pc:docMk/>
+          <pc:sldMk cId="1629619534" sldId="388"/>
+        </pc:sldMkLst>
+        <pc:spChg chg="mod">
+          <ac:chgData name="张 智" userId="36bdf691fd3510be" providerId="LiveId" clId="{AE5DED4F-DA00-4450-AB73-450C993BC4FD}" dt="2024-05-10T15:44:08.552" v="1473" actId="20577"/>
+          <ac:spMkLst>
+            <pc:docMk/>
+            <pc:sldMk cId="1629619534" sldId="388"/>
+            <ac:spMk id="2" creationId="{92B3B218-E6B7-E949-9413-DBDFA9A361B9}"/>
+          </ac:spMkLst>
+        </pc:spChg>
+        <pc:spChg chg="mod">
+          <ac:chgData name="张 智" userId="36bdf691fd3510be" providerId="LiveId" clId="{AE5DED4F-DA00-4450-AB73-450C993BC4FD}" dt="2024-05-11T14:14:18.319" v="2758" actId="20577"/>
+          <ac:spMkLst>
+            <pc:docMk/>
+            <pc:sldMk cId="1629619534" sldId="388"/>
+            <ac:spMk id="3" creationId="{13DB3674-2D4B-8645-8753-8E30E629B377}"/>
+          </ac:spMkLst>
+        </pc:spChg>
+      </pc:sldChg>
+      <pc:sldChg chg="del">
+        <pc:chgData name="张 智" userId="36bdf691fd3510be" providerId="LiveId" clId="{AE5DED4F-DA00-4450-AB73-450C993BC4FD}" dt="2024-05-09T05:55:42.280" v="46" actId="47"/>
+        <pc:sldMkLst>
+          <pc:docMk/>
+          <pc:sldMk cId="2447282596" sldId="389"/>
+        </pc:sldMkLst>
+      </pc:sldChg>
+      <pc:sldChg chg="del">
+        <pc:chgData name="张 智" userId="36bdf691fd3510be" providerId="LiveId" clId="{AE5DED4F-DA00-4450-AB73-450C993BC4FD}" dt="2024-05-09T05:55:40.260" v="44" actId="47"/>
+        <pc:sldMkLst>
+          <pc:docMk/>
+          <pc:sldMk cId="3694241775" sldId="390"/>
+        </pc:sldMkLst>
+      </pc:sldChg>
+      <pc:sldChg chg="del">
+        <pc:chgData name="张 智" userId="36bdf691fd3510be" providerId="LiveId" clId="{AE5DED4F-DA00-4450-AB73-450C993BC4FD}" dt="2024-05-09T05:55:43.595" v="47" actId="47"/>
+        <pc:sldMkLst>
+          <pc:docMk/>
+          <pc:sldMk cId="1777350827" sldId="391"/>
+        </pc:sldMkLst>
+      </pc:sldChg>
+      <pc:sldChg chg="del">
+        <pc:chgData name="张 智" userId="36bdf691fd3510be" providerId="LiveId" clId="{AE5DED4F-DA00-4450-AB73-450C993BC4FD}" dt="2024-05-09T05:55:44.332" v="48" actId="47"/>
+        <pc:sldMkLst>
+          <pc:docMk/>
+          <pc:sldMk cId="265166926" sldId="393"/>
+        </pc:sldMkLst>
+      </pc:sldChg>
+      <pc:sldChg chg="del">
+        <pc:chgData name="张 智" userId="36bdf691fd3510be" providerId="LiveId" clId="{AE5DED4F-DA00-4450-AB73-450C993BC4FD}" dt="2024-05-09T05:55:45.203" v="49" actId="47"/>
+        <pc:sldMkLst>
+          <pc:docMk/>
+          <pc:sldMk cId="2093694809" sldId="394"/>
+        </pc:sldMkLst>
+      </pc:sldChg>
+      <pc:sldChg chg="del">
+        <pc:chgData name="张 智" userId="36bdf691fd3510be" providerId="LiveId" clId="{AE5DED4F-DA00-4450-AB73-450C993BC4FD}" dt="2024-05-09T05:55:41.521" v="45" actId="47"/>
+        <pc:sldMkLst>
+          <pc:docMk/>
+          <pc:sldMk cId="563417353" sldId="395"/>
+        </pc:sldMkLst>
+      </pc:sldChg>
+      <pc:sldChg chg="modSp mod modNotesTx">
+        <pc:chgData name="张 智" userId="36bdf691fd3510be" providerId="LiveId" clId="{AE5DED4F-DA00-4450-AB73-450C993BC4FD}" dt="2024-05-13T05:44:30.204" v="10287" actId="20577"/>
+        <pc:sldMkLst>
+          <pc:docMk/>
+          <pc:sldMk cId="4009072888" sldId="443"/>
+        </pc:sldMkLst>
+        <pc:spChg chg="mod">
+          <ac:chgData name="张 智" userId="36bdf691fd3510be" providerId="LiveId" clId="{AE5DED4F-DA00-4450-AB73-450C993BC4FD}" dt="2024-05-10T14:59:20.017" v="1043" actId="1076"/>
+          <ac:spMkLst>
+            <pc:docMk/>
+            <pc:sldMk cId="4009072888" sldId="443"/>
+            <ac:spMk id="2" creationId="{5C4F01C5-5333-2248-B03B-703C97F7CC69}"/>
+          </ac:spMkLst>
+        </pc:spChg>
+        <pc:spChg chg="mod">
+          <ac:chgData name="张 智" userId="36bdf691fd3510be" providerId="LiveId" clId="{AE5DED4F-DA00-4450-AB73-450C993BC4FD}" dt="2024-05-12T14:09:14.111" v="5009" actId="20577"/>
+          <ac:spMkLst>
+            <pc:docMk/>
+            <pc:sldMk cId="4009072888" sldId="443"/>
+            <ac:spMk id="3" creationId="{F7DD7DCB-C7E2-1B4F-BD83-3B7AF005DD76}"/>
+          </ac:spMkLst>
+        </pc:spChg>
+      </pc:sldChg>
+      <pc:sldChg chg="del">
+        <pc:chgData name="张 智" userId="36bdf691fd3510be" providerId="LiveId" clId="{AE5DED4F-DA00-4450-AB73-450C993BC4FD}" dt="2024-05-09T06:01:18.188" v="81" actId="2696"/>
+        <pc:sldMkLst>
+          <pc:docMk/>
+          <pc:sldMk cId="811672812" sldId="444"/>
+        </pc:sldMkLst>
+      </pc:sldChg>
+      <pc:sldChg chg="modNotesTx">
+        <pc:chgData name="张 智" userId="36bdf691fd3510be" providerId="LiveId" clId="{AE5DED4F-DA00-4450-AB73-450C993BC4FD}" dt="2024-05-12T14:08:42.258" v="5003" actId="20577"/>
+        <pc:sldMkLst>
+          <pc:docMk/>
+          <pc:sldMk cId="1306094259" sldId="445"/>
+        </pc:sldMkLst>
+      </pc:sldChg>
+      <pc:sldChg chg="modSp mod modNotesTx">
+        <pc:chgData name="张 智" userId="36bdf691fd3510be" providerId="LiveId" clId="{AE5DED4F-DA00-4450-AB73-450C993BC4FD}" dt="2024-05-12T14:31:10.731" v="5772" actId="20577"/>
+        <pc:sldMkLst>
+          <pc:docMk/>
+          <pc:sldMk cId="3392029162" sldId="450"/>
+        </pc:sldMkLst>
+        <pc:spChg chg="mod">
+          <ac:chgData name="张 智" userId="36bdf691fd3510be" providerId="LiveId" clId="{AE5DED4F-DA00-4450-AB73-450C993BC4FD}" dt="2024-05-10T15:01:02.098" v="1071" actId="20577"/>
+          <ac:spMkLst>
+            <pc:docMk/>
+            <pc:sldMk cId="3392029162" sldId="450"/>
+            <ac:spMk id="2" creationId="{92B3B218-E6B7-E949-9413-DBDFA9A361B9}"/>
+          </ac:spMkLst>
+        </pc:spChg>
+        <pc:spChg chg="mod">
+          <ac:chgData name="张 智" userId="36bdf691fd3510be" providerId="LiveId" clId="{AE5DED4F-DA00-4450-AB73-450C993BC4FD}" dt="2024-05-10T15:00:08.062" v="1066" actId="207"/>
+          <ac:spMkLst>
+            <pc:docMk/>
+            <pc:sldMk cId="3392029162" sldId="450"/>
+            <ac:spMk id="7" creationId="{75E0A5E3-B5A7-40C6-9FE8-508ABF9E1458}"/>
+          </ac:spMkLst>
+        </pc:spChg>
+      </pc:sldChg>
+      <pc:sldChg chg="modSp mod modNotesTx">
+        <pc:chgData name="张 智" userId="36bdf691fd3510be" providerId="LiveId" clId="{AE5DED4F-DA00-4450-AB73-450C993BC4FD}" dt="2024-05-13T06:04:00.086" v="10316" actId="20577"/>
+        <pc:sldMkLst>
+          <pc:docMk/>
+          <pc:sldMk cId="3890419788" sldId="451"/>
+        </pc:sldMkLst>
+        <pc:spChg chg="mod">
+          <ac:chgData name="张 智" userId="36bdf691fd3510be" providerId="LiveId" clId="{AE5DED4F-DA00-4450-AB73-450C993BC4FD}" dt="2024-05-10T15:02:53.102" v="1089" actId="20577"/>
+          <ac:spMkLst>
+            <pc:docMk/>
+            <pc:sldMk cId="3890419788" sldId="451"/>
+            <ac:spMk id="2" creationId="{92B3B218-E6B7-E949-9413-DBDFA9A361B9}"/>
+          </ac:spMkLst>
+        </pc:spChg>
+        <pc:spChg chg="mod">
+          <ac:chgData name="张 智" userId="36bdf691fd3510be" providerId="LiveId" clId="{AE5DED4F-DA00-4450-AB73-450C993BC4FD}" dt="2024-05-12T14:59:31.187" v="6007" actId="1076"/>
+          <ac:spMkLst>
+            <pc:docMk/>
+            <pc:sldMk cId="3890419788" sldId="451"/>
+            <ac:spMk id="7" creationId="{75E0A5E3-B5A7-40C6-9FE8-508ABF9E1458}"/>
+          </ac:spMkLst>
+        </pc:spChg>
+      </pc:sldChg>
+      <pc:sldChg chg="modSp mod">
+        <pc:chgData name="张 智" userId="36bdf691fd3510be" providerId="LiveId" clId="{AE5DED4F-DA00-4450-AB73-450C993BC4FD}" dt="2024-05-12T15:02:05.245" v="6013" actId="20577"/>
+        <pc:sldMkLst>
+          <pc:docMk/>
+          <pc:sldMk cId="3667523257" sldId="452"/>
+        </pc:sldMkLst>
+        <pc:spChg chg="mod">
+          <ac:chgData name="张 智" userId="36bdf691fd3510be" providerId="LiveId" clId="{AE5DED4F-DA00-4450-AB73-450C993BC4FD}" dt="2024-05-10T15:03:27.670" v="1099" actId="20577"/>
+          <ac:spMkLst>
+            <pc:docMk/>
+            <pc:sldMk cId="3667523257" sldId="452"/>
+            <ac:spMk id="2" creationId="{92B3B218-E6B7-E949-9413-DBDFA9A361B9}"/>
+          </ac:spMkLst>
+        </pc:spChg>
+        <pc:spChg chg="mod">
+          <ac:chgData name="张 智" userId="36bdf691fd3510be" providerId="LiveId" clId="{AE5DED4F-DA00-4450-AB73-450C993BC4FD}" dt="2024-05-12T15:02:05.245" v="6013" actId="20577"/>
+          <ac:spMkLst>
+            <pc:docMk/>
+            <pc:sldMk cId="3667523257" sldId="452"/>
+            <ac:spMk id="7" creationId="{75E0A5E3-B5A7-40C6-9FE8-508ABF9E1458}"/>
+          </ac:spMkLst>
+        </pc:spChg>
+      </pc:sldChg>
+      <pc:sldChg chg="modSp mod">
+        <pc:chgData name="张 智" userId="36bdf691fd3510be" providerId="LiveId" clId="{AE5DED4F-DA00-4450-AB73-450C993BC4FD}" dt="2024-05-10T15:05:36.610" v="1119" actId="207"/>
+        <pc:sldMkLst>
+          <pc:docMk/>
+          <pc:sldMk cId="3592248448" sldId="453"/>
+        </pc:sldMkLst>
+        <pc:spChg chg="mod">
+          <ac:chgData name="张 智" userId="36bdf691fd3510be" providerId="LiveId" clId="{AE5DED4F-DA00-4450-AB73-450C993BC4FD}" dt="2024-05-10T15:05:31.007" v="1118" actId="20577"/>
+          <ac:spMkLst>
+            <pc:docMk/>
+            <pc:sldMk cId="3592248448" sldId="453"/>
+            <ac:spMk id="2" creationId="{92B3B218-E6B7-E949-9413-DBDFA9A361B9}"/>
+          </ac:spMkLst>
+        </pc:spChg>
+        <pc:spChg chg="mod">
+          <ac:chgData name="张 智" userId="36bdf691fd3510be" providerId="LiveId" clId="{AE5DED4F-DA00-4450-AB73-450C993BC4FD}" dt="2024-05-10T15:05:36.610" v="1119" actId="207"/>
+          <ac:spMkLst>
+            <pc:docMk/>
+            <pc:sldMk cId="3592248448" sldId="453"/>
+            <ac:spMk id="7" creationId="{75E0A5E3-B5A7-40C6-9FE8-508ABF9E1458}"/>
+          </ac:spMkLst>
+        </pc:spChg>
+      </pc:sldChg>
+      <pc:sldChg chg="modSp mod">
+        <pc:chgData name="张 智" userId="36bdf691fd3510be" providerId="LiveId" clId="{AE5DED4F-DA00-4450-AB73-450C993BC4FD}" dt="2024-05-10T15:07:54.161" v="1158" actId="1076"/>
+        <pc:sldMkLst>
+          <pc:docMk/>
+          <pc:sldMk cId="110243109" sldId="454"/>
+        </pc:sldMkLst>
+        <pc:spChg chg="mod">
+          <ac:chgData name="张 智" userId="36bdf691fd3510be" providerId="LiveId" clId="{AE5DED4F-DA00-4450-AB73-450C993BC4FD}" dt="2024-05-10T15:07:52.540" v="1157" actId="20577"/>
+          <ac:spMkLst>
+            <pc:docMk/>
+            <pc:sldMk cId="110243109" sldId="454"/>
+            <ac:spMk id="2" creationId="{92B3B218-E6B7-E949-9413-DBDFA9A361B9}"/>
+          </ac:spMkLst>
+        </pc:spChg>
+        <pc:spChg chg="mod">
+          <ac:chgData name="张 智" userId="36bdf691fd3510be" providerId="LiveId" clId="{AE5DED4F-DA00-4450-AB73-450C993BC4FD}" dt="2024-05-10T15:07:54.161" v="1158" actId="1076"/>
+          <ac:spMkLst>
+            <pc:docMk/>
+            <pc:sldMk cId="110243109" sldId="454"/>
+            <ac:spMk id="7" creationId="{75E0A5E3-B5A7-40C6-9FE8-508ABF9E1458}"/>
+          </ac:spMkLst>
+        </pc:spChg>
+      </pc:sldChg>
+      <pc:sldChg chg="modSp mod">
+        <pc:chgData name="张 智" userId="36bdf691fd3510be" providerId="LiveId" clId="{AE5DED4F-DA00-4450-AB73-450C993BC4FD}" dt="2024-05-12T15:05:07.686" v="6021" actId="207"/>
+        <pc:sldMkLst>
+          <pc:docMk/>
+          <pc:sldMk cId="2414964948" sldId="455"/>
+        </pc:sldMkLst>
+        <pc:spChg chg="mod">
+          <ac:chgData name="张 智" userId="36bdf691fd3510be" providerId="LiveId" clId="{AE5DED4F-DA00-4450-AB73-450C993BC4FD}" dt="2024-05-12T15:04:12.986" v="6020" actId="1076"/>
+          <ac:spMkLst>
+            <pc:docMk/>
+            <pc:sldMk cId="2414964948" sldId="455"/>
+            <ac:spMk id="2" creationId="{92B3B218-E6B7-E949-9413-DBDFA9A361B9}"/>
+          </ac:spMkLst>
+        </pc:spChg>
+        <pc:spChg chg="mod">
+          <ac:chgData name="张 智" userId="36bdf691fd3510be" providerId="LiveId" clId="{AE5DED4F-DA00-4450-AB73-450C993BC4FD}" dt="2024-05-12T15:05:07.686" v="6021" actId="207"/>
+          <ac:spMkLst>
+            <pc:docMk/>
+            <pc:sldMk cId="2414964948" sldId="455"/>
+            <ac:spMk id="7" creationId="{75E0A5E3-B5A7-40C6-9FE8-508ABF9E1458}"/>
+          </ac:spMkLst>
+        </pc:spChg>
+      </pc:sldChg>
+      <pc:sldChg chg="modSp mod">
+        <pc:chgData name="张 智" userId="36bdf691fd3510be" providerId="LiveId" clId="{AE5DED4F-DA00-4450-AB73-450C993BC4FD}" dt="2024-05-10T15:14:19.440" v="1245" actId="1076"/>
+        <pc:sldMkLst>
+          <pc:docMk/>
+          <pc:sldMk cId="1468594782" sldId="456"/>
+        </pc:sldMkLst>
+        <pc:spChg chg="mod">
+          <ac:chgData name="张 智" userId="36bdf691fd3510be" providerId="LiveId" clId="{AE5DED4F-DA00-4450-AB73-450C993BC4FD}" dt="2024-05-10T15:14:19.440" v="1245" actId="1076"/>
+          <ac:spMkLst>
+            <pc:docMk/>
+            <pc:sldMk cId="1468594782" sldId="456"/>
+            <ac:spMk id="2" creationId="{92B3B218-E6B7-E949-9413-DBDFA9A361B9}"/>
+          </ac:spMkLst>
+        </pc:spChg>
+        <pc:spChg chg="mod">
+          <ac:chgData name="张 智" userId="36bdf691fd3510be" providerId="LiveId" clId="{AE5DED4F-DA00-4450-AB73-450C993BC4FD}" dt="2024-05-10T15:14:17.848" v="1244" actId="1076"/>
+          <ac:spMkLst>
+            <pc:docMk/>
+            <pc:sldMk cId="1468594782" sldId="456"/>
+            <ac:spMk id="7" creationId="{75E0A5E3-B5A7-40C6-9FE8-508ABF9E1458}"/>
+          </ac:spMkLst>
+        </pc:spChg>
+      </pc:sldChg>
+      <pc:sldChg chg="addSp modSp del mod">
+        <pc:chgData name="张 智" userId="36bdf691fd3510be" providerId="LiveId" clId="{AE5DED4F-DA00-4450-AB73-450C993BC4FD}" dt="2024-05-10T15:44:19.941" v="1474" actId="2696"/>
+        <pc:sldMkLst>
+          <pc:docMk/>
+          <pc:sldMk cId="631149133" sldId="457"/>
+        </pc:sldMkLst>
+        <pc:spChg chg="mod">
+          <ac:chgData name="张 智" userId="36bdf691fd3510be" providerId="LiveId" clId="{AE5DED4F-DA00-4450-AB73-450C993BC4FD}" dt="2024-05-10T15:16:33.041" v="1266" actId="20577"/>
+          <ac:spMkLst>
+            <pc:docMk/>
+            <pc:sldMk cId="631149133" sldId="457"/>
+            <ac:spMk id="2" creationId="{92B3B218-E6B7-E949-9413-DBDFA9A361B9}"/>
+          </ac:spMkLst>
+        </pc:spChg>
+        <pc:spChg chg="add mod">
+          <ac:chgData name="张 智" userId="36bdf691fd3510be" providerId="LiveId" clId="{AE5DED4F-DA00-4450-AB73-450C993BC4FD}" dt="2024-05-10T15:28:15.296" v="1312" actId="1076"/>
+          <ac:spMkLst>
+            <pc:docMk/>
+            <pc:sldMk cId="631149133" sldId="457"/>
+            <ac:spMk id="5" creationId="{212FFFC4-E00C-455E-BA6A-697EE9560C2D}"/>
+          </ac:spMkLst>
+        </pc:spChg>
+        <pc:spChg chg="mod">
+          <ac:chgData name="张 智" userId="36bdf691fd3510be" providerId="LiveId" clId="{AE5DED4F-DA00-4450-AB73-450C993BC4FD}" dt="2024-05-10T15:28:49.651" v="1323" actId="20577"/>
+          <ac:spMkLst>
+            <pc:docMk/>
+            <pc:sldMk cId="631149133" sldId="457"/>
+            <ac:spMk id="7" creationId="{75E0A5E3-B5A7-40C6-9FE8-508ABF9E1458}"/>
+          </ac:spMkLst>
+        </pc:spChg>
+        <pc:picChg chg="add mod">
+          <ac:chgData name="张 智" userId="36bdf691fd3510be" providerId="LiveId" clId="{AE5DED4F-DA00-4450-AB73-450C993BC4FD}" dt="2024-05-10T15:27:33.064" v="1303" actId="1076"/>
+          <ac:picMkLst>
+            <pc:docMk/>
+            <pc:sldMk cId="631149133" sldId="457"/>
+            <ac:picMk id="1026" creationId="{91BB2D63-9A43-4A70-94A6-83ACD9DA0AEE}"/>
+          </ac:picMkLst>
+        </pc:picChg>
+      </pc:sldChg>
+      <pc:sldChg chg="modSp add mod modNotesTx">
+        <pc:chgData name="张 智" userId="36bdf691fd3510be" providerId="LiveId" clId="{AE5DED4F-DA00-4450-AB73-450C993BC4FD}" dt="2024-05-13T02:00:03.119" v="7428" actId="20577"/>
+        <pc:sldMkLst>
+          <pc:docMk/>
+          <pc:sldMk cId="3535288268" sldId="457"/>
+        </pc:sldMkLst>
+        <pc:spChg chg="mod">
+          <ac:chgData name="张 智" userId="36bdf691fd3510be" providerId="LiveId" clId="{AE5DED4F-DA00-4450-AB73-450C993BC4FD}" dt="2024-05-11T15:29:06.097" v="4219" actId="20577"/>
+          <ac:spMkLst>
+            <pc:docMk/>
+            <pc:sldMk cId="3535288268" sldId="457"/>
+            <ac:spMk id="2" creationId="{92B3B218-E6B7-E949-9413-DBDFA9A361B9}"/>
+          </ac:spMkLst>
+        </pc:spChg>
+        <pc:spChg chg="mod">
+          <ac:chgData name="张 智" userId="36bdf691fd3510be" providerId="LiveId" clId="{AE5DED4F-DA00-4450-AB73-450C993BC4FD}" dt="2024-05-13T02:00:03.119" v="7428" actId="20577"/>
+          <ac:spMkLst>
+            <pc:docMk/>
+            <pc:sldMk cId="3535288268" sldId="457"/>
+            <ac:spMk id="5" creationId="{212FFFC4-E00C-455E-BA6A-697EE9560C2D}"/>
+          </ac:spMkLst>
+        </pc:spChg>
+        <pc:spChg chg="mod">
+          <ac:chgData name="张 智" userId="36bdf691fd3510be" providerId="LiveId" clId="{AE5DED4F-DA00-4450-AB73-450C993BC4FD}" dt="2024-05-13T01:48:22.136" v="6855" actId="20577"/>
+          <ac:spMkLst>
+            <pc:docMk/>
+            <pc:sldMk cId="3535288268" sldId="457"/>
+            <ac:spMk id="7" creationId="{75E0A5E3-B5A7-40C6-9FE8-508ABF9E1458}"/>
+          </ac:spMkLst>
+        </pc:spChg>
+      </pc:sldChg>
+      <pc:sldChg chg="del">
+        <pc:chgData name="张 智" userId="36bdf691fd3510be" providerId="LiveId" clId="{AE5DED4F-DA00-4450-AB73-450C993BC4FD}" dt="2024-05-10T15:22:04.788" v="1270" actId="47"/>
+        <pc:sldMkLst>
+          <pc:docMk/>
+          <pc:sldMk cId="1803946351" sldId="458"/>
+        </pc:sldMkLst>
+      </pc:sldChg>
+      <pc:sldChg chg="modSp mod modNotesTx">
+        <pc:chgData name="张 智" userId="36bdf691fd3510be" providerId="LiveId" clId="{AE5DED4F-DA00-4450-AB73-450C993BC4FD}" dt="2024-05-13T02:59:46.076" v="9239" actId="20577"/>
+        <pc:sldMkLst>
+          <pc:docMk/>
+          <pc:sldMk cId="2410610366" sldId="459"/>
+        </pc:sldMkLst>
+        <pc:spChg chg="mod">
+          <ac:chgData name="张 智" userId="36bdf691fd3510be" providerId="LiveId" clId="{AE5DED4F-DA00-4450-AB73-450C993BC4FD}" dt="2024-05-11T14:14:35.343" v="2769" actId="20577"/>
+          <ac:spMkLst>
+            <pc:docMk/>
+            <pc:sldMk cId="2410610366" sldId="459"/>
+            <ac:spMk id="3" creationId="{13DB3674-2D4B-8645-8753-8E30E629B377}"/>
+          </ac:spMkLst>
+        </pc:spChg>
+      </pc:sldChg>
+      <pc:sldChg chg="modSp mod modNotesTx">
+        <pc:chgData name="张 智" userId="36bdf691fd3510be" providerId="LiveId" clId="{AE5DED4F-DA00-4450-AB73-450C993BC4FD}" dt="2024-05-13T03:00:54.082" v="9365" actId="20577"/>
+        <pc:sldMkLst>
+          <pc:docMk/>
+          <pc:sldMk cId="1436142334" sldId="460"/>
+        </pc:sldMkLst>
+        <pc:spChg chg="mod">
+          <ac:chgData name="张 智" userId="36bdf691fd3510be" providerId="LiveId" clId="{AE5DED4F-DA00-4450-AB73-450C993BC4FD}" dt="2024-05-11T14:16:13.114" v="2801" actId="20577"/>
+          <ac:spMkLst>
+            <pc:docMk/>
+            <pc:sldMk cId="1436142334" sldId="460"/>
+            <ac:spMk id="3" creationId="{13DB3674-2D4B-8645-8753-8E30E629B377}"/>
+          </ac:spMkLst>
+        </pc:spChg>
+      </pc:sldChg>
+      <pc:sldChg chg="modSp mod modNotesTx">
+        <pc:chgData name="张 智" userId="36bdf691fd3510be" providerId="LiveId" clId="{AE5DED4F-DA00-4450-AB73-450C993BC4FD}" dt="2024-05-13T06:04:57.451" v="10327" actId="20577"/>
+        <pc:sldMkLst>
+          <pc:docMk/>
+          <pc:sldMk cId="3626462958" sldId="461"/>
+        </pc:sldMkLst>
+        <pc:spChg chg="mod">
+          <ac:chgData name="张 智" userId="36bdf691fd3510be" providerId="LiveId" clId="{AE5DED4F-DA00-4450-AB73-450C993BC4FD}" dt="2024-05-10T15:03:31.911" v="1100" actId="20577"/>
+          <ac:spMkLst>
+            <pc:docMk/>
+            <pc:sldMk cId="3626462958" sldId="461"/>
+            <ac:spMk id="2" creationId="{92B3B218-E6B7-E949-9413-DBDFA9A361B9}"/>
+          </ac:spMkLst>
+        </pc:spChg>
+        <pc:spChg chg="mod">
+          <ac:chgData name="张 智" userId="36bdf691fd3510be" providerId="LiveId" clId="{AE5DED4F-DA00-4450-AB73-450C993BC4FD}" dt="2024-05-12T14:59:52.035" v="6012" actId="20577"/>
+          <ac:spMkLst>
+            <pc:docMk/>
+            <pc:sldMk cId="3626462958" sldId="461"/>
+            <ac:spMk id="7" creationId="{75E0A5E3-B5A7-40C6-9FE8-508ABF9E1458}"/>
+          </ac:spMkLst>
+        </pc:spChg>
+      </pc:sldChg>
+      <pc:sldChg chg="modSp mod">
+        <pc:chgData name="张 智" userId="36bdf691fd3510be" providerId="LiveId" clId="{AE5DED4F-DA00-4450-AB73-450C993BC4FD}" dt="2024-05-12T15:02:08.646" v="6014" actId="20577"/>
+        <pc:sldMkLst>
+          <pc:docMk/>
+          <pc:sldMk cId="1628170773" sldId="462"/>
+        </pc:sldMkLst>
+        <pc:spChg chg="mod">
+          <ac:chgData name="张 智" userId="36bdf691fd3510be" providerId="LiveId" clId="{AE5DED4F-DA00-4450-AB73-450C993BC4FD}" dt="2024-05-10T15:05:04.718" v="1101" actId="20577"/>
+          <ac:spMkLst>
+            <pc:docMk/>
+            <pc:sldMk cId="1628170773" sldId="462"/>
+            <ac:spMk id="2" creationId="{92B3B218-E6B7-E949-9413-DBDFA9A361B9}"/>
+          </ac:spMkLst>
+        </pc:spChg>
+        <pc:spChg chg="mod">
+          <ac:chgData name="张 智" userId="36bdf691fd3510be" providerId="LiveId" clId="{AE5DED4F-DA00-4450-AB73-450C993BC4FD}" dt="2024-05-12T15:02:08.646" v="6014" actId="20577"/>
+          <ac:spMkLst>
+            <pc:docMk/>
+            <pc:sldMk cId="1628170773" sldId="462"/>
+            <ac:spMk id="7" creationId="{75E0A5E3-B5A7-40C6-9FE8-508ABF9E1458}"/>
+          </ac:spMkLst>
+        </pc:spChg>
+      </pc:sldChg>
+      <pc:sldChg chg="modSp mod">
+        <pc:chgData name="张 智" userId="36bdf691fd3510be" providerId="LiveId" clId="{AE5DED4F-DA00-4450-AB73-450C993BC4FD}" dt="2024-05-12T15:03:58.919" v="6019" actId="20577"/>
+        <pc:sldMkLst>
+          <pc:docMk/>
+          <pc:sldMk cId="3533530707" sldId="463"/>
+        </pc:sldMkLst>
+        <pc:spChg chg="mod">
+          <ac:chgData name="张 智" userId="36bdf691fd3510be" providerId="LiveId" clId="{AE5DED4F-DA00-4450-AB73-450C993BC4FD}" dt="2024-05-10T15:14:57.897" v="1262" actId="20577"/>
+          <ac:spMkLst>
+            <pc:docMk/>
+            <pc:sldMk cId="3533530707" sldId="463"/>
+            <ac:spMk id="2" creationId="{92B3B218-E6B7-E949-9413-DBDFA9A361B9}"/>
+          </ac:spMkLst>
+        </pc:spChg>
+        <pc:spChg chg="mod">
+          <ac:chgData name="张 智" userId="36bdf691fd3510be" providerId="LiveId" clId="{AE5DED4F-DA00-4450-AB73-450C993BC4FD}" dt="2024-05-12T15:03:58.919" v="6019" actId="20577"/>
+          <ac:spMkLst>
+            <pc:docMk/>
+            <pc:sldMk cId="3533530707" sldId="463"/>
+            <ac:spMk id="7" creationId="{75E0A5E3-B5A7-40C6-9FE8-508ABF9E1458}"/>
+          </ac:spMkLst>
+        </pc:spChg>
+      </pc:sldChg>
+      <pc:sldChg chg="modSp mod">
+        <pc:chgData name="张 智" userId="36bdf691fd3510be" providerId="LiveId" clId="{AE5DED4F-DA00-4450-AB73-450C993BC4FD}" dt="2024-05-10T15:08:33.610" v="1168" actId="108"/>
+        <pc:sldMkLst>
+          <pc:docMk/>
+          <pc:sldMk cId="1690056961" sldId="464"/>
+        </pc:sldMkLst>
+        <pc:spChg chg="mod">
+          <ac:chgData name="张 智" userId="36bdf691fd3510be" providerId="LiveId" clId="{AE5DED4F-DA00-4450-AB73-450C993BC4FD}" dt="2024-05-10T15:08:21.247" v="1162" actId="20577"/>
+          <ac:spMkLst>
+            <pc:docMk/>
+            <pc:sldMk cId="1690056961" sldId="464"/>
+            <ac:spMk id="2" creationId="{92B3B218-E6B7-E949-9413-DBDFA9A361B9}"/>
+          </ac:spMkLst>
+        </pc:spChg>
+        <pc:spChg chg="mod">
+          <ac:chgData name="张 智" userId="36bdf691fd3510be" providerId="LiveId" clId="{AE5DED4F-DA00-4450-AB73-450C993BC4FD}" dt="2024-05-10T15:08:33.610" v="1168" actId="108"/>
+          <ac:spMkLst>
+            <pc:docMk/>
+            <pc:sldMk cId="1690056961" sldId="464"/>
+            <ac:spMk id="7" creationId="{75E0A5E3-B5A7-40C6-9FE8-508ABF9E1458}"/>
+          </ac:spMkLst>
+        </pc:spChg>
+      </pc:sldChg>
+      <pc:sldChg chg="modSp mod">
+        <pc:chgData name="张 智" userId="36bdf691fd3510be" providerId="LiveId" clId="{AE5DED4F-DA00-4450-AB73-450C993BC4FD}" dt="2024-05-13T06:11:59.662" v="10345" actId="20577"/>
+        <pc:sldMkLst>
+          <pc:docMk/>
+          <pc:sldMk cId="822221007" sldId="465"/>
+        </pc:sldMkLst>
+        <pc:spChg chg="mod">
+          <ac:chgData name="张 智" userId="36bdf691fd3510be" providerId="LiveId" clId="{AE5DED4F-DA00-4450-AB73-450C993BC4FD}" dt="2024-05-10T15:12:03.833" v="1215" actId="20577"/>
+          <ac:spMkLst>
+            <pc:docMk/>
+            <pc:sldMk cId="822221007" sldId="465"/>
+            <ac:spMk id="2" creationId="{92B3B218-E6B7-E949-9413-DBDFA9A361B9}"/>
+          </ac:spMkLst>
+        </pc:spChg>
+        <pc:spChg chg="mod">
+          <ac:chgData name="张 智" userId="36bdf691fd3510be" providerId="LiveId" clId="{AE5DED4F-DA00-4450-AB73-450C993BC4FD}" dt="2024-05-13T06:11:59.662" v="10345" actId="20577"/>
+          <ac:spMkLst>
+            <pc:docMk/>
+            <pc:sldMk cId="822221007" sldId="465"/>
+            <ac:spMk id="7" creationId="{75E0A5E3-B5A7-40C6-9FE8-508ABF9E1458}"/>
+          </ac:spMkLst>
+        </pc:spChg>
+      </pc:sldChg>
+      <pc:sldChg chg="modSp mod">
+        <pc:chgData name="张 智" userId="36bdf691fd3510be" providerId="LiveId" clId="{AE5DED4F-DA00-4450-AB73-450C993BC4FD}" dt="2024-05-12T15:10:14.307" v="6058" actId="20577"/>
+        <pc:sldMkLst>
+          <pc:docMk/>
+          <pc:sldMk cId="1462745473" sldId="466"/>
+        </pc:sldMkLst>
+        <pc:spChg chg="mod">
+          <ac:chgData name="张 智" userId="36bdf691fd3510be" providerId="LiveId" clId="{AE5DED4F-DA00-4450-AB73-450C993BC4FD}" dt="2024-05-10T15:12:30.378" v="1223" actId="20577"/>
+          <ac:spMkLst>
+            <pc:docMk/>
+            <pc:sldMk cId="1462745473" sldId="466"/>
+            <ac:spMk id="2" creationId="{92B3B218-E6B7-E949-9413-DBDFA9A361B9}"/>
+          </ac:spMkLst>
+        </pc:spChg>
+        <pc:spChg chg="mod">
+          <ac:chgData name="张 智" userId="36bdf691fd3510be" providerId="LiveId" clId="{AE5DED4F-DA00-4450-AB73-450C993BC4FD}" dt="2024-05-12T15:10:14.307" v="6058" actId="20577"/>
+          <ac:spMkLst>
+            <pc:docMk/>
+            <pc:sldMk cId="1462745473" sldId="466"/>
+            <ac:spMk id="7" creationId="{75E0A5E3-B5A7-40C6-9FE8-508ABF9E1458}"/>
+          </ac:spMkLst>
+        </pc:spChg>
+      </pc:sldChg>
+      <pc:sldChg chg="modSp mod">
+        <pc:chgData name="张 智" userId="36bdf691fd3510be" providerId="LiveId" clId="{AE5DED4F-DA00-4450-AB73-450C993BC4FD}" dt="2024-05-13T06:11:43.496" v="10332" actId="20577"/>
+        <pc:sldMkLst>
+          <pc:docMk/>
+          <pc:sldMk cId="56589812" sldId="467"/>
+        </pc:sldMkLst>
+        <pc:spChg chg="mod">
+          <ac:chgData name="张 智" userId="36bdf691fd3510be" providerId="LiveId" clId="{AE5DED4F-DA00-4450-AB73-450C993BC4FD}" dt="2024-05-10T15:12:18.016" v="1219" actId="1076"/>
+          <ac:spMkLst>
+            <pc:docMk/>
+            <pc:sldMk cId="56589812" sldId="467"/>
+            <ac:spMk id="2" creationId="{92B3B218-E6B7-E949-9413-DBDFA9A361B9}"/>
+          </ac:spMkLst>
+        </pc:spChg>
+        <pc:spChg chg="mod">
+          <ac:chgData name="张 智" userId="36bdf691fd3510be" providerId="LiveId" clId="{AE5DED4F-DA00-4450-AB73-450C993BC4FD}" dt="2024-05-13T06:11:43.496" v="10332" actId="20577"/>
+          <ac:spMkLst>
+            <pc:docMk/>
+            <pc:sldMk cId="56589812" sldId="467"/>
+            <ac:spMk id="7" creationId="{75E0A5E3-B5A7-40C6-9FE8-508ABF9E1458}"/>
+          </ac:spMkLst>
+        </pc:spChg>
+      </pc:sldChg>
+      <pc:sldChg chg="modSp mod">
+        <pc:chgData name="张 智" userId="36bdf691fd3510be" providerId="LiveId" clId="{AE5DED4F-DA00-4450-AB73-450C993BC4FD}" dt="2024-05-13T06:13:37.656" v="10346" actId="20577"/>
+        <pc:sldMkLst>
+          <pc:docMk/>
+          <pc:sldMk cId="2017251195" sldId="468"/>
+        </pc:sldMkLst>
+        <pc:spChg chg="mod">
+          <ac:chgData name="张 智" userId="36bdf691fd3510be" providerId="LiveId" clId="{AE5DED4F-DA00-4450-AB73-450C993BC4FD}" dt="2024-05-10T15:13:51.167" v="1231" actId="20577"/>
+          <ac:spMkLst>
+            <pc:docMk/>
+            <pc:sldMk cId="2017251195" sldId="468"/>
+            <ac:spMk id="2" creationId="{92B3B218-E6B7-E949-9413-DBDFA9A361B9}"/>
+          </ac:spMkLst>
+        </pc:spChg>
+        <pc:spChg chg="mod">
+          <ac:chgData name="张 智" userId="36bdf691fd3510be" providerId="LiveId" clId="{AE5DED4F-DA00-4450-AB73-450C993BC4FD}" dt="2024-05-13T06:13:37.656" v="10346" actId="20577"/>
+          <ac:spMkLst>
+            <pc:docMk/>
+            <pc:sldMk cId="2017251195" sldId="468"/>
+            <ac:spMk id="7" creationId="{75E0A5E3-B5A7-40C6-9FE8-508ABF9E1458}"/>
+          </ac:spMkLst>
+        </pc:spChg>
+      </pc:sldChg>
+      <pc:sldChg chg="modSp del mod">
+        <pc:chgData name="张 智" userId="36bdf691fd3510be" providerId="LiveId" clId="{AE5DED4F-DA00-4450-AB73-450C993BC4FD}" dt="2024-05-10T15:16:27.761" v="1265" actId="2696"/>
+        <pc:sldMkLst>
+          <pc:docMk/>
+          <pc:sldMk cId="3286154215" sldId="469"/>
+        </pc:sldMkLst>
+        <pc:spChg chg="mod">
+          <ac:chgData name="张 智" userId="36bdf691fd3510be" providerId="LiveId" clId="{AE5DED4F-DA00-4450-AB73-450C993BC4FD}" dt="2024-05-10T15:13:40.838" v="1228" actId="20577"/>
+          <ac:spMkLst>
+            <pc:docMk/>
+            <pc:sldMk cId="3286154215" sldId="469"/>
+            <ac:spMk id="7" creationId="{75E0A5E3-B5A7-40C6-9FE8-508ABF9E1458}"/>
+          </ac:spMkLst>
+        </pc:spChg>
+      </pc:sldChg>
+      <pc:sldChg chg="del">
+        <pc:chgData name="张 智" userId="36bdf691fd3510be" providerId="LiveId" clId="{AE5DED4F-DA00-4450-AB73-450C993BC4FD}" dt="2024-05-10T15:20:44.775" v="1268" actId="47"/>
+        <pc:sldMkLst>
+          <pc:docMk/>
+          <pc:sldMk cId="1574098949" sldId="470"/>
+        </pc:sldMkLst>
+      </pc:sldChg>
+      <pc:sldChg chg="del">
+        <pc:chgData name="张 智" userId="36bdf691fd3510be" providerId="LiveId" clId="{AE5DED4F-DA00-4450-AB73-450C993BC4FD}" dt="2024-05-10T15:20:45.664" v="1269" actId="47"/>
+        <pc:sldMkLst>
+          <pc:docMk/>
+          <pc:sldMk cId="2544237434" sldId="471"/>
+        </pc:sldMkLst>
+      </pc:sldChg>
+      <pc:sldChg chg="modSp mod modNotesTx">
+        <pc:chgData name="张 智" userId="36bdf691fd3510be" providerId="LiveId" clId="{AE5DED4F-DA00-4450-AB73-450C993BC4FD}" dt="2024-05-13T03:03:18.135" v="9506" actId="20577"/>
+        <pc:sldMkLst>
+          <pc:docMk/>
+          <pc:sldMk cId="500213869" sldId="472"/>
+        </pc:sldMkLst>
+        <pc:spChg chg="mod">
+          <ac:chgData name="张 智" userId="36bdf691fd3510be" providerId="LiveId" clId="{AE5DED4F-DA00-4450-AB73-450C993BC4FD}" dt="2024-05-11T14:19:08.074" v="3120" actId="20577"/>
+          <ac:spMkLst>
+            <pc:docMk/>
+            <pc:sldMk cId="500213869" sldId="472"/>
+            <ac:spMk id="3" creationId="{13DB3674-2D4B-8645-8753-8E30E629B377}"/>
+          </ac:spMkLst>
+        </pc:spChg>
+      </pc:sldChg>
+      <pc:sldChg chg="modSp mod modNotesTx">
+        <pc:chgData name="张 智" userId="36bdf691fd3510be" providerId="LiveId" clId="{AE5DED4F-DA00-4450-AB73-450C993BC4FD}" dt="2024-05-12T15:22:15.760" v="6260" actId="20577"/>
+        <pc:sldMkLst>
+          <pc:docMk/>
+          <pc:sldMk cId="4283821982" sldId="473"/>
+        </pc:sldMkLst>
+        <pc:spChg chg="mod">
+          <ac:chgData name="张 智" userId="36bdf691fd3510be" providerId="LiveId" clId="{AE5DED4F-DA00-4450-AB73-450C993BC4FD}" dt="2024-05-12T15:21:58.437" v="6258" actId="21"/>
+          <ac:spMkLst>
+            <pc:docMk/>
+            <pc:sldMk cId="4283821982" sldId="473"/>
+            <ac:spMk id="3" creationId="{13DB3674-2D4B-8645-8753-8E30E629B377}"/>
+          </ac:spMkLst>
+        </pc:spChg>
+      </pc:sldChg>
+      <pc:sldChg chg="modSp mod">
+        <pc:chgData name="张 智" userId="36bdf691fd3510be" providerId="LiveId" clId="{AE5DED4F-DA00-4450-AB73-450C993BC4FD}" dt="2024-05-11T14:19:13.905" v="3121"/>
+        <pc:sldMkLst>
+          <pc:docMk/>
+          <pc:sldMk cId="1636182554" sldId="474"/>
+        </pc:sldMkLst>
+        <pc:spChg chg="mod">
+          <ac:chgData name="张 智" userId="36bdf691fd3510be" providerId="LiveId" clId="{AE5DED4F-DA00-4450-AB73-450C993BC4FD}" dt="2024-05-11T14:19:13.905" v="3121"/>
+          <ac:spMkLst>
+            <pc:docMk/>
+            <pc:sldMk cId="1636182554" sldId="474"/>
+            <ac:spMk id="3" creationId="{13DB3674-2D4B-8645-8753-8E30E629B377}"/>
+          </ac:spMkLst>
+        </pc:spChg>
+      </pc:sldChg>
+      <pc:sldChg chg="modSp mod">
+        <pc:chgData name="张 智" userId="36bdf691fd3510be" providerId="LiveId" clId="{AE5DED4F-DA00-4450-AB73-450C993BC4FD}" dt="2024-05-11T14:23:06.478" v="3145" actId="20577"/>
+        <pc:sldMkLst>
+          <pc:docMk/>
+          <pc:sldMk cId="3151914030" sldId="475"/>
+        </pc:sldMkLst>
+        <pc:spChg chg="mod">
+          <ac:chgData name="张 智" userId="36bdf691fd3510be" providerId="LiveId" clId="{AE5DED4F-DA00-4450-AB73-450C993BC4FD}" dt="2024-05-11T14:23:06.478" v="3145" actId="20577"/>
+          <ac:spMkLst>
+            <pc:docMk/>
+            <pc:sldMk cId="3151914030" sldId="475"/>
+            <ac:spMk id="3" creationId="{13DB3674-2D4B-8645-8753-8E30E629B377}"/>
+          </ac:spMkLst>
+        </pc:spChg>
+      </pc:sldChg>
+      <pc:sldChg chg="modSp mod modNotesTx">
+        <pc:chgData name="张 智" userId="36bdf691fd3510be" providerId="LiveId" clId="{AE5DED4F-DA00-4450-AB73-450C993BC4FD}" dt="2024-05-13T03:10:01.290" v="9723" actId="20577"/>
+        <pc:sldMkLst>
+          <pc:docMk/>
+          <pc:sldMk cId="97459469" sldId="476"/>
+        </pc:sldMkLst>
+        <pc:spChg chg="mod">
+          <ac:chgData name="张 智" userId="36bdf691fd3510be" providerId="LiveId" clId="{AE5DED4F-DA00-4450-AB73-450C993BC4FD}" dt="2024-05-11T14:23:42.727" v="3155" actId="20577"/>
+          <ac:spMkLst>
+            <pc:docMk/>
+            <pc:sldMk cId="97459469" sldId="476"/>
+            <ac:spMk id="3" creationId="{13DB3674-2D4B-8645-8753-8E30E629B377}"/>
+          </ac:spMkLst>
+        </pc:spChg>
+      </pc:sldChg>
+      <pc:sldChg chg="modSp mod">
+        <pc:chgData name="张 智" userId="36bdf691fd3510be" providerId="LiveId" clId="{AE5DED4F-DA00-4450-AB73-450C993BC4FD}" dt="2024-05-13T03:45:16.488" v="10270" actId="20577"/>
+        <pc:sldMkLst>
+          <pc:docMk/>
+          <pc:sldMk cId="4081096777" sldId="477"/>
+        </pc:sldMkLst>
+        <pc:spChg chg="mod">
+          <ac:chgData name="张 智" userId="36bdf691fd3510be" providerId="LiveId" clId="{AE5DED4F-DA00-4450-AB73-450C993BC4FD}" dt="2024-05-13T03:45:16.488" v="10270" actId="20577"/>
+          <ac:spMkLst>
+            <pc:docMk/>
+            <pc:sldMk cId="4081096777" sldId="477"/>
+            <ac:spMk id="3" creationId="{13DB3674-2D4B-8645-8753-8E30E629B377}"/>
+          </ac:spMkLst>
+        </pc:spChg>
+      </pc:sldChg>
+      <pc:sldChg chg="modSp mod">
+        <pc:chgData name="张 智" userId="36bdf691fd3510be" providerId="LiveId" clId="{AE5DED4F-DA00-4450-AB73-450C993BC4FD}" dt="2024-05-11T14:26:13.764" v="3191" actId="20577"/>
+        <pc:sldMkLst>
+          <pc:docMk/>
+          <pc:sldMk cId="4015799420" sldId="478"/>
+        </pc:sldMkLst>
+        <pc:spChg chg="mod">
+          <ac:chgData name="张 智" userId="36bdf691fd3510be" providerId="LiveId" clId="{AE5DED4F-DA00-4450-AB73-450C993BC4FD}" dt="2024-05-11T14:26:13.764" v="3191" actId="20577"/>
+          <ac:spMkLst>
+            <pc:docMk/>
+            <pc:sldMk cId="4015799420" sldId="478"/>
+            <ac:spMk id="3" creationId="{13DB3674-2D4B-8645-8753-8E30E629B377}"/>
+          </ac:spMkLst>
+        </pc:spChg>
+      </pc:sldChg>
+      <pc:sldChg chg="modSp mod modNotesTx">
+        <pc:chgData name="张 智" userId="36bdf691fd3510be" providerId="LiveId" clId="{AE5DED4F-DA00-4450-AB73-450C993BC4FD}" dt="2024-05-13T06:29:00.470" v="10378" actId="20577"/>
+        <pc:sldMkLst>
+          <pc:docMk/>
+          <pc:sldMk cId="3022655673" sldId="479"/>
+        </pc:sldMkLst>
+        <pc:spChg chg="mod">
+          <ac:chgData name="张 智" userId="36bdf691fd3510be" providerId="LiveId" clId="{AE5DED4F-DA00-4450-AB73-450C993BC4FD}" dt="2024-05-13T06:29:00.470" v="10378" actId="20577"/>
+          <ac:spMkLst>
+            <pc:docMk/>
+            <pc:sldMk cId="3022655673" sldId="479"/>
+            <ac:spMk id="3" creationId="{13DB3674-2D4B-8645-8753-8E30E629B377}"/>
+          </ac:spMkLst>
+        </pc:spChg>
+      </pc:sldChg>
+      <pc:sldChg chg="modSp mod modNotesTx">
+        <pc:chgData name="张 智" userId="36bdf691fd3510be" providerId="LiveId" clId="{AE5DED4F-DA00-4450-AB73-450C993BC4FD}" dt="2024-05-13T06:03:28.958" v="10314" actId="20577"/>
+        <pc:sldMkLst>
+          <pc:docMk/>
+          <pc:sldMk cId="214179768" sldId="480"/>
+        </pc:sldMkLst>
+        <pc:spChg chg="mod">
+          <ac:chgData name="张 智" userId="36bdf691fd3510be" providerId="LiveId" clId="{AE5DED4F-DA00-4450-AB73-450C993BC4FD}" dt="2024-05-10T15:01:04.314" v="1072" actId="20577"/>
+          <ac:spMkLst>
+            <pc:docMk/>
+            <pc:sldMk cId="214179768" sldId="480"/>
+            <ac:spMk id="2" creationId="{92B3B218-E6B7-E949-9413-DBDFA9A361B9}"/>
+          </ac:spMkLst>
+        </pc:spChg>
+        <pc:spChg chg="mod">
+          <ac:chgData name="张 智" userId="36bdf691fd3510be" providerId="LiveId" clId="{AE5DED4F-DA00-4450-AB73-450C993BC4FD}" dt="2024-05-13T06:03:28.958" v="10314" actId="20577"/>
+          <ac:spMkLst>
+            <pc:docMk/>
+            <pc:sldMk cId="214179768" sldId="480"/>
+            <ac:spMk id="7" creationId="{75E0A5E3-B5A7-40C6-9FE8-508ABF9E1458}"/>
+          </ac:spMkLst>
+        </pc:spChg>
+      </pc:sldChg>
+      <pc:sldChg chg="modSp mod modNotesTx">
+        <pc:chgData name="张 智" userId="36bdf691fd3510be" providerId="LiveId" clId="{AE5DED4F-DA00-4450-AB73-450C993BC4FD}" dt="2024-05-12T15:07:29.648" v="6048" actId="20577"/>
+        <pc:sldMkLst>
+          <pc:docMk/>
+          <pc:sldMk cId="2857348335" sldId="481"/>
+        </pc:sldMkLst>
+        <pc:spChg chg="mod">
+          <ac:chgData name="张 智" userId="36bdf691fd3510be" providerId="LiveId" clId="{AE5DED4F-DA00-4450-AB73-450C993BC4FD}" dt="2024-05-10T15:07:45.728" v="1153" actId="20577"/>
+          <ac:spMkLst>
+            <pc:docMk/>
+            <pc:sldMk cId="2857348335" sldId="481"/>
+            <ac:spMk id="2" creationId="{92B3B218-E6B7-E949-9413-DBDFA9A361B9}"/>
+          </ac:spMkLst>
+        </pc:spChg>
+        <pc:spChg chg="mod">
+          <ac:chgData name="张 智" userId="36bdf691fd3510be" providerId="LiveId" clId="{AE5DED4F-DA00-4450-AB73-450C993BC4FD}" dt="2024-05-10T15:07:42.882" v="1151" actId="1076"/>
+          <ac:spMkLst>
+            <pc:docMk/>
+            <pc:sldMk cId="2857348335" sldId="481"/>
+            <ac:spMk id="7" creationId="{75E0A5E3-B5A7-40C6-9FE8-508ABF9E1458}"/>
+          </ac:spMkLst>
+        </pc:spChg>
+      </pc:sldChg>
+      <pc:sldChg chg="del">
+        <pc:chgData name="张 智" userId="36bdf691fd3510be" providerId="LiveId" clId="{AE5DED4F-DA00-4450-AB73-450C993BC4FD}" dt="2024-05-10T15:20:43.959" v="1267" actId="47"/>
+        <pc:sldMkLst>
+          <pc:docMk/>
+          <pc:sldMk cId="1557232649" sldId="482"/>
+        </pc:sldMkLst>
+      </pc:sldChg>
+      <pc:sldChg chg="modSp mod modNotesTx">
+        <pc:chgData name="张 智" userId="36bdf691fd3510be" providerId="LiveId" clId="{AE5DED4F-DA00-4450-AB73-450C993BC4FD}" dt="2024-05-13T06:21:52.847" v="10363" actId="20577"/>
+        <pc:sldMkLst>
+          <pc:docMk/>
+          <pc:sldMk cId="3101025385" sldId="483"/>
+        </pc:sldMkLst>
+        <pc:spChg chg="mod">
+          <ac:chgData name="张 智" userId="36bdf691fd3510be" providerId="LiveId" clId="{AE5DED4F-DA00-4450-AB73-450C993BC4FD}" dt="2024-05-13T06:21:52.847" v="10363" actId="20577"/>
+          <ac:spMkLst>
+            <pc:docMk/>
+            <pc:sldMk cId="3101025385" sldId="483"/>
+            <ac:spMk id="3" creationId="{13DB3674-2D4B-8645-8753-8E30E629B377}"/>
+          </ac:spMkLst>
+        </pc:spChg>
+      </pc:sldChg>
+      <pc:sldChg chg="modSp mod">
+        <pc:chgData name="张 智" userId="36bdf691fd3510be" providerId="LiveId" clId="{AE5DED4F-DA00-4450-AB73-450C993BC4FD}" dt="2024-05-13T06:26:59.480" v="10367" actId="20577"/>
+        <pc:sldMkLst>
+          <pc:docMk/>
+          <pc:sldMk cId="1375948752" sldId="484"/>
+        </pc:sldMkLst>
+        <pc:spChg chg="mod">
+          <ac:chgData name="张 智" userId="36bdf691fd3510be" providerId="LiveId" clId="{AE5DED4F-DA00-4450-AB73-450C993BC4FD}" dt="2024-05-13T06:26:59.480" v="10367" actId="20577"/>
+          <ac:spMkLst>
+            <pc:docMk/>
+            <pc:sldMk cId="1375948752" sldId="484"/>
+            <ac:spMk id="3" creationId="{13DB3674-2D4B-8645-8753-8E30E629B377}"/>
+          </ac:spMkLst>
+        </pc:spChg>
+      </pc:sldChg>
+      <pc:sldChg chg="modSp add del mod">
+        <pc:chgData name="张 智" userId="36bdf691fd3510be" providerId="LiveId" clId="{AE5DED4F-DA00-4450-AB73-450C993BC4FD}" dt="2024-05-10T16:06:39.309" v="2299" actId="2696"/>
+        <pc:sldMkLst>
+          <pc:docMk/>
+          <pc:sldMk cId="177643505" sldId="535"/>
+        </pc:sldMkLst>
+        <pc:spChg chg="mod">
+          <ac:chgData name="张 智" userId="36bdf691fd3510be" providerId="LiveId" clId="{AE5DED4F-DA00-4450-AB73-450C993BC4FD}" dt="2024-05-10T16:06:33.232" v="2298" actId="1036"/>
+          <ac:spMkLst>
+            <pc:docMk/>
+            <pc:sldMk cId="177643505" sldId="535"/>
+            <ac:spMk id="9" creationId="{2E47447F-9D1D-4119-9AC1-89A76461C26E}"/>
+          </ac:spMkLst>
+        </pc:spChg>
+        <pc:spChg chg="mod">
+          <ac:chgData name="张 智" userId="36bdf691fd3510be" providerId="LiveId" clId="{AE5DED4F-DA00-4450-AB73-450C993BC4FD}" dt="2024-05-10T16:06:33.232" v="2298" actId="1036"/>
+          <ac:spMkLst>
+            <pc:docMk/>
+            <pc:sldMk cId="177643505" sldId="535"/>
+            <ac:spMk id="10" creationId="{19F88072-7B73-4C39-85C6-1A390ED9D829}"/>
+          </ac:spMkLst>
+        </pc:spChg>
+        <pc:spChg chg="mod">
+          <ac:chgData name="张 智" userId="36bdf691fd3510be" providerId="LiveId" clId="{AE5DED4F-DA00-4450-AB73-450C993BC4FD}" dt="2024-05-10T16:06:33.232" v="2298" actId="1036"/>
+          <ac:spMkLst>
+            <pc:docMk/>
+            <pc:sldMk cId="177643505" sldId="535"/>
+            <ac:spMk id="12" creationId="{18FA6537-F0CE-44FE-A425-10E0BFC96171}"/>
+          </ac:spMkLst>
+        </pc:spChg>
+        <pc:spChg chg="mod">
+          <ac:chgData name="张 智" userId="36bdf691fd3510be" providerId="LiveId" clId="{AE5DED4F-DA00-4450-AB73-450C993BC4FD}" dt="2024-05-10T16:06:33.232" v="2298" actId="1036"/>
+          <ac:spMkLst>
+            <pc:docMk/>
+            <pc:sldMk cId="177643505" sldId="535"/>
+            <ac:spMk id="13" creationId="{84915FF7-F2B6-4F8F-987F-6E6AE8782CB9}"/>
+          </ac:spMkLst>
+        </pc:spChg>
+        <pc:spChg chg="mod">
+          <ac:chgData name="张 智" userId="36bdf691fd3510be" providerId="LiveId" clId="{AE5DED4F-DA00-4450-AB73-450C993BC4FD}" dt="2024-05-10T16:06:33.232" v="2298" actId="1036"/>
+          <ac:spMkLst>
+            <pc:docMk/>
+            <pc:sldMk cId="177643505" sldId="535"/>
+            <ac:spMk id="14" creationId="{6893BAD6-018F-4A85-AE18-DB743550469F}"/>
+          </ac:spMkLst>
+        </pc:spChg>
+        <pc:spChg chg="mod">
+          <ac:chgData name="张 智" userId="36bdf691fd3510be" providerId="LiveId" clId="{AE5DED4F-DA00-4450-AB73-450C993BC4FD}" dt="2024-05-10T16:06:33.232" v="2298" actId="1036"/>
+          <ac:spMkLst>
+            <pc:docMk/>
+            <pc:sldMk cId="177643505" sldId="535"/>
+            <ac:spMk id="15" creationId="{0ABB9AB2-8480-4BB4-9570-B265C933A8FD}"/>
+          </ac:spMkLst>
+        </pc:spChg>
+        <pc:spChg chg="mod">
+          <ac:chgData name="张 智" userId="36bdf691fd3510be" providerId="LiveId" clId="{AE5DED4F-DA00-4450-AB73-450C993BC4FD}" dt="2024-05-10T16:06:33.232" v="2298" actId="1036"/>
+          <ac:spMkLst>
+            <pc:docMk/>
+            <pc:sldMk cId="177643505" sldId="535"/>
+            <ac:spMk id="16" creationId="{C7B1E7C0-6898-41C6-93BD-D0CD26828926}"/>
+          </ac:spMkLst>
+        </pc:spChg>
+        <pc:spChg chg="mod">
+          <ac:chgData name="张 智" userId="36bdf691fd3510be" providerId="LiveId" clId="{AE5DED4F-DA00-4450-AB73-450C993BC4FD}" dt="2024-05-10T16:06:33.232" v="2298" actId="1036"/>
+          <ac:spMkLst>
+            <pc:docMk/>
+            <pc:sldMk cId="177643505" sldId="535"/>
+            <ac:spMk id="17" creationId="{784693B2-A349-4299-9632-88F7CFA18F08}"/>
+          </ac:spMkLst>
+        </pc:spChg>
+        <pc:spChg chg="mod">
+          <ac:chgData name="张 智" userId="36bdf691fd3510be" providerId="LiveId" clId="{AE5DED4F-DA00-4450-AB73-450C993BC4FD}" dt="2024-05-10T16:06:33.232" v="2298" actId="1036"/>
+          <ac:spMkLst>
+            <pc:docMk/>
+            <pc:sldMk cId="177643505" sldId="535"/>
+            <ac:spMk id="18" creationId="{AF641BBD-1AE1-4473-A3CD-89545BCB14F4}"/>
+          </ac:spMkLst>
+        </pc:spChg>
+        <pc:spChg chg="mod">
+          <ac:chgData name="张 智" userId="36bdf691fd3510be" providerId="LiveId" clId="{AE5DED4F-DA00-4450-AB73-450C993BC4FD}" dt="2024-05-10T16:06:33.232" v="2298" actId="1036"/>
+          <ac:spMkLst>
+            <pc:docMk/>
+            <pc:sldMk cId="177643505" sldId="535"/>
+            <ac:spMk id="19" creationId="{200E62A3-81ED-4367-BA43-A690540067FF}"/>
+          </ac:spMkLst>
+        </pc:spChg>
+        <pc:spChg chg="mod">
+          <ac:chgData name="张 智" userId="36bdf691fd3510be" providerId="LiveId" clId="{AE5DED4F-DA00-4450-AB73-450C993BC4FD}" dt="2024-05-10T16:06:33.232" v="2298" actId="1036"/>
+          <ac:spMkLst>
+            <pc:docMk/>
+            <pc:sldMk cId="177643505" sldId="535"/>
+            <ac:spMk id="20" creationId="{A1A7090F-4A84-420A-89A1-FB5EAA22E34A}"/>
+          </ac:spMkLst>
+        </pc:spChg>
+        <pc:spChg chg="mod">
+          <ac:chgData name="张 智" userId="36bdf691fd3510be" providerId="LiveId" clId="{AE5DED4F-DA00-4450-AB73-450C993BC4FD}" dt="2024-05-10T16:06:33.232" v="2298" actId="1036"/>
+          <ac:spMkLst>
+            <pc:docMk/>
+            <pc:sldMk cId="177643505" sldId="535"/>
+            <ac:spMk id="21" creationId="{F59A7427-3D0B-4B7A-BCF2-2984712EDF7D}"/>
+          </ac:spMkLst>
+        </pc:spChg>
+        <pc:spChg chg="mod">
+          <ac:chgData name="张 智" userId="36bdf691fd3510be" providerId="LiveId" clId="{AE5DED4F-DA00-4450-AB73-450C993BC4FD}" dt="2024-05-10T16:06:33.232" v="2298" actId="1036"/>
+          <ac:spMkLst>
+            <pc:docMk/>
+            <pc:sldMk cId="177643505" sldId="535"/>
+            <ac:spMk id="22" creationId="{B793E604-2507-4B45-8E27-9C0717B9B726}"/>
+          </ac:spMkLst>
+        </pc:spChg>
+        <pc:picChg chg="mod">
+          <ac:chgData name="张 智" userId="36bdf691fd3510be" providerId="LiveId" clId="{AE5DED4F-DA00-4450-AB73-450C993BC4FD}" dt="2024-05-10T16:06:33.232" v="2298" actId="1036"/>
+          <ac:picMkLst>
+            <pc:docMk/>
+            <pc:sldMk cId="177643505" sldId="535"/>
+            <ac:picMk id="4" creationId="{07BA7B64-6AF9-4C08-AAEF-1353B9D28CB3}"/>
+          </ac:picMkLst>
+        </pc:picChg>
+        <pc:picChg chg="mod">
+          <ac:chgData name="张 智" userId="36bdf691fd3510be" providerId="LiveId" clId="{AE5DED4F-DA00-4450-AB73-450C993BC4FD}" dt="2024-05-10T16:06:33.232" v="2298" actId="1036"/>
+          <ac:picMkLst>
+            <pc:docMk/>
+            <pc:sldMk cId="177643505" sldId="535"/>
+            <ac:picMk id="5" creationId="{5E9D4FAE-9EA5-4927-8F70-E90C243EA17E}"/>
+          </ac:picMkLst>
+        </pc:picChg>
+      </pc:sldChg>
+      <pc:sldChg chg="addSp delSp modSp add mod modNotesTx">
+        <pc:chgData name="张 智" userId="36bdf691fd3510be" providerId="LiveId" clId="{AE5DED4F-DA00-4450-AB73-450C993BC4FD}" dt="2024-05-13T01:25:28.323" v="6398" actId="20577"/>
+        <pc:sldMkLst>
+          <pc:docMk/>
+          <pc:sldMk cId="2649076992" sldId="544"/>
+        </pc:sldMkLst>
+        <pc:spChg chg="del">
+          <ac:chgData name="张 智" userId="36bdf691fd3510be" providerId="LiveId" clId="{AE5DED4F-DA00-4450-AB73-450C993BC4FD}" dt="2024-05-10T16:07:04.721" v="2301" actId="478"/>
+          <ac:spMkLst>
+            <pc:docMk/>
+            <pc:sldMk cId="2649076992" sldId="544"/>
+            <ac:spMk id="2" creationId="{753A7AE6-D4A2-4EC7-AB69-D10FDED6791E}"/>
+          </ac:spMkLst>
+        </pc:spChg>
+        <pc:spChg chg="mod">
+          <ac:chgData name="张 智" userId="36bdf691fd3510be" providerId="LiveId" clId="{AE5DED4F-DA00-4450-AB73-450C993BC4FD}" dt="2024-05-10T16:09:15.249" v="2325" actId="20577"/>
+          <ac:spMkLst>
+            <pc:docMk/>
+            <pc:sldMk cId="2649076992" sldId="544"/>
+            <ac:spMk id="6" creationId="{69F92E9A-2B5F-4177-93B9-09916C3328E6}"/>
+          </ac:spMkLst>
+        </pc:spChg>
+        <pc:spChg chg="mod">
+          <ac:chgData name="张 智" userId="36bdf691fd3510be" providerId="LiveId" clId="{AE5DED4F-DA00-4450-AB73-450C993BC4FD}" dt="2024-05-10T16:09:46.390" v="2332" actId="403"/>
+          <ac:spMkLst>
+            <pc:docMk/>
+            <pc:sldMk cId="2649076992" sldId="544"/>
+            <ac:spMk id="7" creationId="{BEB55EFD-BA53-450C-B6F4-2FD9BCBB61F7}"/>
+          </ac:spMkLst>
+        </pc:spChg>
+        <pc:spChg chg="mod">
+          <ac:chgData name="张 智" userId="36bdf691fd3510be" providerId="LiveId" clId="{AE5DED4F-DA00-4450-AB73-450C993BC4FD}" dt="2024-05-10T16:09:05.994" v="2323" actId="1036"/>
+          <ac:spMkLst>
+            <pc:docMk/>
+            <pc:sldMk cId="2649076992" sldId="544"/>
+            <ac:spMk id="8" creationId="{5124B453-7009-4E27-A9F3-CF3B5E9C1FF0}"/>
+          </ac:spMkLst>
+        </pc:spChg>
+        <pc:spChg chg="mod">
+          <ac:chgData name="张 智" userId="36bdf691fd3510be" providerId="LiveId" clId="{AE5DED4F-DA00-4450-AB73-450C993BC4FD}" dt="2024-05-10T16:09:59.441" v="2334" actId="20577"/>
+          <ac:spMkLst>
+            <pc:docMk/>
+            <pc:sldMk cId="2649076992" sldId="544"/>
+            <ac:spMk id="9" creationId="{2E47447F-9D1D-4119-9AC1-89A76461C26E}"/>
+          </ac:spMkLst>
+        </pc:spChg>
+        <pc:spChg chg="mod">
+          <ac:chgData name="张 智" userId="36bdf691fd3510be" providerId="LiveId" clId="{AE5DED4F-DA00-4450-AB73-450C993BC4FD}" dt="2024-05-10T16:10:29.562" v="2344" actId="20577"/>
+          <ac:spMkLst>
+            <pc:docMk/>
+            <pc:sldMk cId="2649076992" sldId="544"/>
+            <ac:spMk id="10" creationId="{19F88072-7B73-4C39-85C6-1A390ED9D829}"/>
+          </ac:spMkLst>
+        </pc:spChg>
+        <pc:spChg chg="add del mod">
+          <ac:chgData name="张 智" userId="36bdf691fd3510be" providerId="LiveId" clId="{AE5DED4F-DA00-4450-AB73-450C993BC4FD}" dt="2024-05-10T16:07:06.654" v="2303" actId="478"/>
+          <ac:spMkLst>
+            <pc:docMk/>
+            <pc:sldMk cId="2649076992" sldId="544"/>
+            <ac:spMk id="11" creationId="{60424823-42B7-41F4-A6D3-341610871183}"/>
+          </ac:spMkLst>
+        </pc:spChg>
+        <pc:spChg chg="mod">
+          <ac:chgData name="张 智" userId="36bdf691fd3510be" providerId="LiveId" clId="{AE5DED4F-DA00-4450-AB73-450C993BC4FD}" dt="2024-05-10T16:10:19.516" v="2341" actId="20577"/>
+          <ac:spMkLst>
+            <pc:docMk/>
+            <pc:sldMk cId="2649076992" sldId="544"/>
+            <ac:spMk id="12" creationId="{18FA6537-F0CE-44FE-A425-10E0BFC96171}"/>
+          </ac:spMkLst>
+        </pc:spChg>
+        <pc:spChg chg="mod">
+          <ac:chgData name="张 智" userId="36bdf691fd3510be" providerId="LiveId" clId="{AE5DED4F-DA00-4450-AB73-450C993BC4FD}" dt="2024-05-10T16:10:22.828" v="2342" actId="20577"/>
+          <ac:spMkLst>
+            <pc:docMk/>
+            <pc:sldMk cId="2649076992" sldId="544"/>
+            <ac:spMk id="14" creationId="{6893BAD6-018F-4A85-AE18-DB743550469F}"/>
+          </ac:spMkLst>
+        </pc:spChg>
+        <pc:spChg chg="mod">
+          <ac:chgData name="张 智" userId="36bdf691fd3510be" providerId="LiveId" clId="{AE5DED4F-DA00-4450-AB73-450C993BC4FD}" dt="2024-05-10T16:10:26.185" v="2343" actId="20577"/>
+          <ac:spMkLst>
+            <pc:docMk/>
+            <pc:sldMk cId="2649076992" sldId="544"/>
+            <ac:spMk id="15" creationId="{0ABB9AB2-8480-4BB4-9570-B265C933A8FD}"/>
+          </ac:spMkLst>
+        </pc:spChg>
+        <pc:spChg chg="mod">
+          <ac:chgData name="张 智" userId="36bdf691fd3510be" providerId="LiveId" clId="{AE5DED4F-DA00-4450-AB73-450C993BC4FD}" dt="2024-05-10T16:10:32.278" v="2345" actId="20577"/>
+          <ac:spMkLst>
+            <pc:docMk/>
+            <pc:sldMk cId="2649076992" sldId="544"/>
+            <ac:spMk id="20" creationId="{7DC8C79B-E10D-4AB0-A536-84D4932177A4}"/>
+          </ac:spMkLst>
+        </pc:spChg>
+        <pc:spChg chg="mod">
+          <ac:chgData name="张 智" userId="36bdf691fd3510be" providerId="LiveId" clId="{AE5DED4F-DA00-4450-AB73-450C993BC4FD}" dt="2024-05-10T16:10:36.085" v="2346" actId="20577"/>
+          <ac:spMkLst>
+            <pc:docMk/>
+            <pc:sldMk cId="2649076992" sldId="544"/>
+            <ac:spMk id="21" creationId="{AD2BE259-8E32-49BB-8B6F-073A6E8E5732}"/>
+          </ac:spMkLst>
+        </pc:spChg>
+        <pc:spChg chg="add mod">
+          <ac:chgData name="张 智" userId="36bdf691fd3510be" providerId="LiveId" clId="{AE5DED4F-DA00-4450-AB73-450C993BC4FD}" dt="2024-05-10T16:07:09.094" v="2304" actId="1076"/>
+          <ac:spMkLst>
+            <pc:docMk/>
+            <pc:sldMk cId="2649076992" sldId="544"/>
+            <ac:spMk id="22" creationId="{22A5540C-AA78-4657-865C-27FF42377EC9}"/>
+          </ac:spMkLst>
+        </pc:spChg>
+        <pc:spChg chg="add mod">
+          <ac:chgData name="张 智" userId="36bdf691fd3510be" providerId="LiveId" clId="{AE5DED4F-DA00-4450-AB73-450C993BC4FD}" dt="2024-05-11T14:28:49.151" v="3207" actId="20577"/>
+          <ac:spMkLst>
+            <pc:docMk/>
+            <pc:sldMk cId="2649076992" sldId="544"/>
+            <ac:spMk id="23" creationId="{FF207394-4D38-4E05-9334-2F8FECB8A095}"/>
+          </ac:spMkLst>
+        </pc:spChg>
+        <pc:picChg chg="mod">
+          <ac:chgData name="张 智" userId="36bdf691fd3510be" providerId="LiveId" clId="{AE5DED4F-DA00-4450-AB73-450C993BC4FD}" dt="2024-05-10T16:07:34.190" v="2310" actId="14100"/>
+          <ac:picMkLst>
+            <pc:docMk/>
+            <pc:sldMk cId="2649076992" sldId="544"/>
+            <ac:picMk id="4" creationId="{07BA7B64-6AF9-4C08-AAEF-1353B9D28CB3}"/>
+          </ac:picMkLst>
+        </pc:picChg>
+        <pc:picChg chg="mod">
+          <ac:chgData name="张 智" userId="36bdf691fd3510be" providerId="LiveId" clId="{AE5DED4F-DA00-4450-AB73-450C993BC4FD}" dt="2024-05-10T16:07:28.729" v="2309" actId="14100"/>
+          <ac:picMkLst>
+            <pc:docMk/>
+            <pc:sldMk cId="2649076992" sldId="544"/>
+            <ac:picMk id="5" creationId="{5E9D4FAE-9EA5-4927-8F70-E90C243EA17E}"/>
+          </ac:picMkLst>
+        </pc:picChg>
+      </pc:sldChg>
+      <pc:sldChg chg="addSp delSp modSp add mod modNotesTx">
+        <pc:chgData name="张 智" userId="36bdf691fd3510be" providerId="LiveId" clId="{AE5DED4F-DA00-4450-AB73-450C993BC4FD}" dt="2024-05-13T06:29:38.338" v="10383" actId="20577"/>
+        <pc:sldMkLst>
+          <pc:docMk/>
+          <pc:sldMk cId="1827031149" sldId="549"/>
+        </pc:sldMkLst>
+        <pc:spChg chg="mod">
+          <ac:chgData name="张 智" userId="36bdf691fd3510be" providerId="LiveId" clId="{AE5DED4F-DA00-4450-AB73-450C993BC4FD}" dt="2024-05-13T06:29:38.338" v="10383" actId="20577"/>
+          <ac:spMkLst>
+            <pc:docMk/>
+            <pc:sldMk cId="1827031149" sldId="549"/>
+            <ac:spMk id="2" creationId="{753A7AE6-D4A2-4EC7-AB69-D10FDED6791E}"/>
+          </ac:spMkLst>
+        </pc:spChg>
+        <pc:spChg chg="add mod">
+          <ac:chgData name="张 智" userId="36bdf691fd3510be" providerId="LiveId" clId="{AE5DED4F-DA00-4450-AB73-450C993BC4FD}" dt="2024-05-11T14:27:02.003" v="3204" actId="20577"/>
+          <ac:spMkLst>
+            <pc:docMk/>
+            <pc:sldMk cId="1827031149" sldId="549"/>
+            <ac:spMk id="5" creationId="{7F5B0894-DE45-40DF-81F4-90CA4E9FF03C}"/>
+          </ac:spMkLst>
+        </pc:spChg>
+        <pc:picChg chg="del">
+          <ac:chgData name="张 智" userId="36bdf691fd3510be" providerId="LiveId" clId="{AE5DED4F-DA00-4450-AB73-450C993BC4FD}" dt="2024-05-10T15:51:47.304" v="1688" actId="478"/>
+          <ac:picMkLst>
+            <pc:docMk/>
+            <pc:sldMk cId="1827031149" sldId="549"/>
+            <ac:picMk id="4" creationId="{FCDA48D8-8047-4D13-B2E8-84CDC9487A22}"/>
+          </ac:picMkLst>
+        </pc:picChg>
+        <pc:picChg chg="add mod">
+          <ac:chgData name="张 智" userId="36bdf691fd3510be" providerId="LiveId" clId="{AE5DED4F-DA00-4450-AB73-450C993BC4FD}" dt="2024-05-10T15:53:02.318" v="1707" actId="1076"/>
+          <ac:picMkLst>
+            <pc:docMk/>
+            <pc:sldMk cId="1827031149" sldId="549"/>
+            <ac:picMk id="6" creationId="{D3320554-657F-4671-ACBB-D0789B7930CB}"/>
+          </ac:picMkLst>
+        </pc:picChg>
+        <pc:picChg chg="del">
+          <ac:chgData name="张 智" userId="36bdf691fd3510be" providerId="LiveId" clId="{AE5DED4F-DA00-4450-AB73-450C993BC4FD}" dt="2024-05-10T15:51:45.805" v="1687" actId="478"/>
+          <ac:picMkLst>
+            <pc:docMk/>
+            <pc:sldMk cId="1827031149" sldId="549"/>
+            <ac:picMk id="24" creationId="{7D770456-6F9F-4C9F-8A1D-53814B8F30E3}"/>
+          </ac:picMkLst>
+        </pc:picChg>
+      </pc:sldChg>
+      <pc:sldChg chg="addSp modSp add mod modNotesTx">
+        <pc:chgData name="张 智" userId="36bdf691fd3510be" providerId="LiveId" clId="{AE5DED4F-DA00-4450-AB73-450C993BC4FD}" dt="2024-05-13T02:26:42.228" v="8552" actId="20577"/>
+        <pc:sldMkLst>
+          <pc:docMk/>
+          <pc:sldMk cId="2891692903" sldId="1556"/>
+        </pc:sldMkLst>
+        <pc:spChg chg="mod">
+          <ac:chgData name="张 智" userId="36bdf691fd3510be" providerId="LiveId" clId="{AE5DED4F-DA00-4450-AB73-450C993BC4FD}" dt="2024-05-09T06:21:58.472" v="329" actId="113"/>
+          <ac:spMkLst>
+            <pc:docMk/>
+            <pc:sldMk cId="2891692903" sldId="1556"/>
+            <ac:spMk id="2" creationId="{62B5F79D-16DD-4439-8342-17CBBB22DF56}"/>
+          </ac:spMkLst>
+        </pc:spChg>
+        <pc:spChg chg="add mod">
+          <ac:chgData name="张 智" userId="36bdf691fd3510be" providerId="LiveId" clId="{AE5DED4F-DA00-4450-AB73-450C993BC4FD}" dt="2024-05-09T06:22:29.389" v="331" actId="20577"/>
+          <ac:spMkLst>
+            <pc:docMk/>
+            <pc:sldMk cId="2891692903" sldId="1556"/>
+            <ac:spMk id="3" creationId="{4ED86F02-6CA1-4157-BC69-AD1E9404270E}"/>
+          </ac:spMkLst>
+        </pc:spChg>
+      </pc:sldChg>
+      <pc:sldChg chg="modSp add mod modNotesTx">
+        <pc:chgData name="张 智" userId="36bdf691fd3510be" providerId="LiveId" clId="{AE5DED4F-DA00-4450-AB73-450C993BC4FD}" dt="2024-05-10T14:59:50.542" v="1051" actId="1035"/>
+        <pc:sldMkLst>
+          <pc:docMk/>
+          <pc:sldMk cId="2109811326" sldId="1557"/>
+        </pc:sldMkLst>
+        <pc:spChg chg="mod">
+          <ac:chgData name="张 智" userId="36bdf691fd3510be" providerId="LiveId" clId="{AE5DED4F-DA00-4450-AB73-450C993BC4FD}" dt="2024-05-10T14:59:50.542" v="1051" actId="1035"/>
+          <ac:spMkLst>
+            <pc:docMk/>
+            <pc:sldMk cId="2109811326" sldId="1557"/>
+            <ac:spMk id="2" creationId="{92B3B218-E6B7-E949-9413-DBDFA9A361B9}"/>
+          </ac:spMkLst>
+        </pc:spChg>
+        <pc:spChg chg="mod">
+          <ac:chgData name="张 智" userId="36bdf691fd3510be" providerId="LiveId" clId="{AE5DED4F-DA00-4450-AB73-450C993BC4FD}" dt="2024-05-10T14:59:39.393" v="1044" actId="1076"/>
+          <ac:spMkLst>
+            <pc:docMk/>
+            <pc:sldMk cId="2109811326" sldId="1557"/>
+            <ac:spMk id="7" creationId="{75E0A5E3-B5A7-40C6-9FE8-508ABF9E1458}"/>
+          </ac:spMkLst>
+        </pc:spChg>
+      </pc:sldChg>
+      <pc:sldChg chg="modSp add mod">
+        <pc:chgData name="张 智" userId="36bdf691fd3510be" providerId="LiveId" clId="{AE5DED4F-DA00-4450-AB73-450C993BC4FD}" dt="2024-05-09T07:32:13.606" v="643" actId="20577"/>
+        <pc:sldMkLst>
+          <pc:docMk/>
+          <pc:sldMk cId="967945687" sldId="1558"/>
+        </pc:sldMkLst>
+        <pc:spChg chg="mod">
+          <ac:chgData name="张 智" userId="36bdf691fd3510be" providerId="LiveId" clId="{AE5DED4F-DA00-4450-AB73-450C993BC4FD}" dt="2024-05-09T07:32:13.606" v="643" actId="20577"/>
+          <ac:spMkLst>
+            <pc:docMk/>
+            <pc:sldMk cId="967945687" sldId="1558"/>
+            <ac:spMk id="7" creationId="{75E0A5E3-B5A7-40C6-9FE8-508ABF9E1458}"/>
+          </ac:spMkLst>
+        </pc:spChg>
+      </pc:sldChg>
+      <pc:sldChg chg="modSp add mod">
+        <pc:chgData name="张 智" userId="36bdf691fd3510be" providerId="LiveId" clId="{AE5DED4F-DA00-4450-AB73-450C993BC4FD}" dt="2024-05-09T07:33:47.740" v="676" actId="20577"/>
+        <pc:sldMkLst>
+          <pc:docMk/>
+          <pc:sldMk cId="3427740812" sldId="1559"/>
+        </pc:sldMkLst>
+        <pc:spChg chg="mod">
+          <ac:chgData name="张 智" userId="36bdf691fd3510be" providerId="LiveId" clId="{AE5DED4F-DA00-4450-AB73-450C993BC4FD}" dt="2024-05-09T07:33:47.740" v="676" actId="20577"/>
+          <ac:spMkLst>
+            <pc:docMk/>
+            <pc:sldMk cId="3427740812" sldId="1559"/>
+            <ac:spMk id="7" creationId="{75E0A5E3-B5A7-40C6-9FE8-508ABF9E1458}"/>
+          </ac:spMkLst>
+        </pc:spChg>
+      </pc:sldChg>
+      <pc:sldChg chg="modSp add mod">
+        <pc:chgData name="张 智" userId="36bdf691fd3510be" providerId="LiveId" clId="{AE5DED4F-DA00-4450-AB73-450C993BC4FD}" dt="2024-05-09T07:34:12.483" v="678"/>
+        <pc:sldMkLst>
+          <pc:docMk/>
+          <pc:sldMk cId="3288724058" sldId="1560"/>
+        </pc:sldMkLst>
+        <pc:spChg chg="mod">
+          <ac:chgData name="张 智" userId="36bdf691fd3510be" providerId="LiveId" clId="{AE5DED4F-DA00-4450-AB73-450C993BC4FD}" dt="2024-05-09T07:34:12.483" v="678"/>
+          <ac:spMkLst>
+            <pc:docMk/>
+            <pc:sldMk cId="3288724058" sldId="1560"/>
+            <ac:spMk id="7" creationId="{75E0A5E3-B5A7-40C6-9FE8-508ABF9E1458}"/>
+          </ac:spMkLst>
+        </pc:spChg>
+      </pc:sldChg>
+      <pc:sldChg chg="addSp delSp modSp add mod modNotesTx">
+        <pc:chgData name="张 智" userId="36bdf691fd3510be" providerId="LiveId" clId="{AE5DED4F-DA00-4450-AB73-450C993BC4FD}" dt="2024-05-13T05:51:51.154" v="10313" actId="20577"/>
+        <pc:sldMkLst>
+          <pc:docMk/>
+          <pc:sldMk cId="2129605611" sldId="1561"/>
+        </pc:sldMkLst>
+        <pc:spChg chg="add mod">
+          <ac:chgData name="张 智" userId="36bdf691fd3510be" providerId="LiveId" clId="{AE5DED4F-DA00-4450-AB73-450C993BC4FD}" dt="2024-05-13T05:51:51.154" v="10313" actId="20577"/>
+          <ac:spMkLst>
+            <pc:docMk/>
+            <pc:sldMk cId="2129605611" sldId="1561"/>
+            <ac:spMk id="4" creationId="{B60C46B0-C120-4431-98AB-2D674C3631DB}"/>
+          </ac:spMkLst>
+        </pc:spChg>
+        <pc:spChg chg="del">
+          <ac:chgData name="张 智" userId="36bdf691fd3510be" providerId="LiveId" clId="{AE5DED4F-DA00-4450-AB73-450C993BC4FD}" dt="2024-05-09T07:34:49.560" v="683" actId="478"/>
+          <ac:spMkLst>
+            <pc:docMk/>
+            <pc:sldMk cId="2129605611" sldId="1561"/>
+            <ac:spMk id="7" creationId="{75E0A5E3-B5A7-40C6-9FE8-508ABF9E1458}"/>
+          </ac:spMkLst>
+        </pc:spChg>
+      </pc:sldChg>
+      <pc:sldChg chg="modSp add mod modNotesTx">
+        <pc:chgData name="张 智" userId="36bdf691fd3510be" providerId="LiveId" clId="{AE5DED4F-DA00-4450-AB73-450C993BC4FD}" dt="2024-05-12T14:23:03.034" v="5164"/>
+        <pc:sldMkLst>
+          <pc:docMk/>
+          <pc:sldMk cId="1421017218" sldId="1562"/>
+        </pc:sldMkLst>
+        <pc:spChg chg="mod">
+          <ac:chgData name="张 智" userId="36bdf691fd3510be" providerId="LiveId" clId="{AE5DED4F-DA00-4450-AB73-450C993BC4FD}" dt="2024-05-09T07:59:34.488" v="939" actId="20577"/>
+          <ac:spMkLst>
+            <pc:docMk/>
+            <pc:sldMk cId="1421017218" sldId="1562"/>
+            <ac:spMk id="7" creationId="{75E0A5E3-B5A7-40C6-9FE8-508ABF9E1458}"/>
+          </ac:spMkLst>
+        </pc:spChg>
+      </pc:sldChg>
+      <pc:sldChg chg="modSp add mod modNotesTx">
+        <pc:chgData name="张 智" userId="36bdf691fd3510be" providerId="LiveId" clId="{AE5DED4F-DA00-4450-AB73-450C993BC4FD}" dt="2024-05-12T14:28:21.818" v="5685" actId="20577"/>
+        <pc:sldMkLst>
+          <pc:docMk/>
+          <pc:sldMk cId="1834362957" sldId="1563"/>
+        </pc:sldMkLst>
+        <pc:spChg chg="mod">
+          <ac:chgData name="张 智" userId="36bdf691fd3510be" providerId="LiveId" clId="{AE5DED4F-DA00-4450-AB73-450C993BC4FD}" dt="2024-05-09T07:56:31.940" v="928" actId="14100"/>
+          <ac:spMkLst>
+            <pc:docMk/>
+            <pc:sldMk cId="1834362957" sldId="1563"/>
+            <ac:spMk id="2" creationId="{92B3B218-E6B7-E949-9413-DBDFA9A361B9}"/>
+          </ac:spMkLst>
+        </pc:spChg>
+        <pc:spChg chg="mod">
+          <ac:chgData name="张 智" userId="36bdf691fd3510be" providerId="LiveId" clId="{AE5DED4F-DA00-4450-AB73-450C993BC4FD}" dt="2024-05-12T14:25:27.672" v="5296" actId="20577"/>
+          <ac:spMkLst>
+            <pc:docMk/>
+            <pc:sldMk cId="1834362957" sldId="1563"/>
+            <ac:spMk id="4" creationId="{B60C46B0-C120-4431-98AB-2D674C3631DB}"/>
+          </ac:spMkLst>
+        </pc:spChg>
+      </pc:sldChg>
+      <pc:sldChg chg="modSp add del mod modNotesTx">
+        <pc:chgData name="张 智" userId="36bdf691fd3510be" providerId="LiveId" clId="{AE5DED4F-DA00-4450-AB73-450C993BC4FD}" dt="2024-05-13T03:32:20.652" v="10154" actId="20577"/>
+        <pc:sldMkLst>
+          <pc:docMk/>
+          <pc:sldMk cId="1217545385" sldId="1564"/>
+        </pc:sldMkLst>
+        <pc:spChg chg="mod">
+          <ac:chgData name="张 智" userId="36bdf691fd3510be" providerId="LiveId" clId="{AE5DED4F-DA00-4450-AB73-450C993BC4FD}" dt="2024-05-11T15:29:11.058" v="4220" actId="20577"/>
+          <ac:spMkLst>
+            <pc:docMk/>
+            <pc:sldMk cId="1217545385" sldId="1564"/>
+            <ac:spMk id="2" creationId="{92B3B218-E6B7-E949-9413-DBDFA9A361B9}"/>
+          </ac:spMkLst>
+        </pc:spChg>
+        <pc:spChg chg="mod">
+          <ac:chgData name="张 智" userId="36bdf691fd3510be" providerId="LiveId" clId="{AE5DED4F-DA00-4450-AB73-450C993BC4FD}" dt="2024-05-13T03:32:20.652" v="10154" actId="20577"/>
+          <ac:spMkLst>
+            <pc:docMk/>
+            <pc:sldMk cId="1217545385" sldId="1564"/>
+            <ac:spMk id="7" creationId="{75E0A5E3-B5A7-40C6-9FE8-508ABF9E1458}"/>
+          </ac:spMkLst>
+        </pc:spChg>
+      </pc:sldChg>
+      <pc:sldChg chg="addSp delSp modSp add del mod">
+        <pc:chgData name="张 智" userId="36bdf691fd3510be" providerId="LiveId" clId="{AE5DED4F-DA00-4450-AB73-450C993BC4FD}" dt="2024-05-10T15:44:19.941" v="1474" actId="2696"/>
+        <pc:sldMkLst>
+          <pc:docMk/>
+          <pc:sldMk cId="4261175508" sldId="1564"/>
+        </pc:sldMkLst>
+        <pc:spChg chg="del">
+          <ac:chgData name="张 智" userId="36bdf691fd3510be" providerId="LiveId" clId="{AE5DED4F-DA00-4450-AB73-450C993BC4FD}" dt="2024-05-10T15:30:50.125" v="1332" actId="478"/>
+          <ac:spMkLst>
+            <pc:docMk/>
+            <pc:sldMk cId="4261175508" sldId="1564"/>
+            <ac:spMk id="5" creationId="{212FFFC4-E00C-455E-BA6A-697EE9560C2D}"/>
+          </ac:spMkLst>
+        </pc:spChg>
+        <pc:spChg chg="add del mod">
+          <ac:chgData name="张 智" userId="36bdf691fd3510be" providerId="LiveId" clId="{AE5DED4F-DA00-4450-AB73-450C993BC4FD}" dt="2024-05-10T15:31:58.595" v="1337" actId="478"/>
+          <ac:spMkLst>
+            <pc:docMk/>
+            <pc:sldMk cId="4261175508" sldId="1564"/>
+            <ac:spMk id="6" creationId="{CBD776A4-5C43-4C23-BB91-C9EDF14D3927}"/>
+          </ac:spMkLst>
+        </pc:spChg>
+        <pc:spChg chg="mod">
+          <ac:chgData name="张 智" userId="36bdf691fd3510be" providerId="LiveId" clId="{AE5DED4F-DA00-4450-AB73-450C993BC4FD}" dt="2024-05-10T15:33:02.538" v="1357" actId="108"/>
+          <ac:spMkLst>
+            <pc:docMk/>
+            <pc:sldMk cId="4261175508" sldId="1564"/>
+            <ac:spMk id="7" creationId="{75E0A5E3-B5A7-40C6-9FE8-508ABF9E1458}"/>
+          </ac:spMkLst>
+        </pc:spChg>
+        <pc:picChg chg="del">
+          <ac:chgData name="张 智" userId="36bdf691fd3510be" providerId="LiveId" clId="{AE5DED4F-DA00-4450-AB73-450C993BC4FD}" dt="2024-05-10T15:30:51.512" v="1333" actId="478"/>
+          <ac:picMkLst>
+            <pc:docMk/>
+            <pc:sldMk cId="4261175508" sldId="1564"/>
+            <ac:picMk id="1026" creationId="{91BB2D63-9A43-4A70-94A6-83ACD9DA0AEE}"/>
+          </ac:picMkLst>
+        </pc:picChg>
+      </pc:sldChg>
+      <pc:sldChg chg="modSp add del mod">
+        <pc:chgData name="张 智" userId="36bdf691fd3510be" providerId="LiveId" clId="{AE5DED4F-DA00-4450-AB73-450C993BC4FD}" dt="2024-05-10T15:44:19.941" v="1474" actId="2696"/>
+        <pc:sldMkLst>
+          <pc:docMk/>
+          <pc:sldMk cId="743561615" sldId="1565"/>
+        </pc:sldMkLst>
+        <pc:spChg chg="mod">
+          <ac:chgData name="张 智" userId="36bdf691fd3510be" providerId="LiveId" clId="{AE5DED4F-DA00-4450-AB73-450C993BC4FD}" dt="2024-05-10T15:40:26.120" v="1405" actId="20577"/>
+          <ac:spMkLst>
+            <pc:docMk/>
+            <pc:sldMk cId="743561615" sldId="1565"/>
+            <ac:spMk id="7" creationId="{75E0A5E3-B5A7-40C6-9FE8-508ABF9E1458}"/>
+          </ac:spMkLst>
+        </pc:spChg>
+      </pc:sldChg>
+      <pc:sldChg chg="modSp add del mod">
+        <pc:chgData name="张 智" userId="36bdf691fd3510be" providerId="LiveId" clId="{AE5DED4F-DA00-4450-AB73-450C993BC4FD}" dt="2024-05-13T02:06:41.473" v="7515" actId="2696"/>
+        <pc:sldMkLst>
+          <pc:docMk/>
+          <pc:sldMk cId="3764889077" sldId="1565"/>
+        </pc:sldMkLst>
+        <pc:spChg chg="mod">
+          <ac:chgData name="张 智" userId="36bdf691fd3510be" providerId="LiveId" clId="{AE5DED4F-DA00-4450-AB73-450C993BC4FD}" dt="2024-05-11T15:29:15.211" v="4223" actId="20577"/>
+          <ac:spMkLst>
+            <pc:docMk/>
+            <pc:sldMk cId="3764889077" sldId="1565"/>
+            <ac:spMk id="2" creationId="{92B3B218-E6B7-E949-9413-DBDFA9A361B9}"/>
+          </ac:spMkLst>
+        </pc:spChg>
+      </pc:sldChg>
+      <pc:sldChg chg="modSp add mod">
+        <pc:chgData name="张 智" userId="36bdf691fd3510be" providerId="LiveId" clId="{AE5DED4F-DA00-4450-AB73-450C993BC4FD}" dt="2024-05-13T02:25:50.446" v="8549" actId="20577"/>
+        <pc:sldMkLst>
+          <pc:docMk/>
+          <pc:sldMk cId="693837114" sldId="1566"/>
+        </pc:sldMkLst>
+        <pc:spChg chg="mod">
+          <ac:chgData name="张 智" userId="36bdf691fd3510be" providerId="LiveId" clId="{AE5DED4F-DA00-4450-AB73-450C993BC4FD}" dt="2024-05-11T15:29:21.030" v="4224" actId="20577"/>
+          <ac:spMkLst>
+            <pc:docMk/>
+            <pc:sldMk cId="693837114" sldId="1566"/>
+            <ac:spMk id="2" creationId="{92B3B218-E6B7-E949-9413-DBDFA9A361B9}"/>
+          </ac:spMkLst>
+        </pc:spChg>
+        <pc:spChg chg="mod">
+          <ac:chgData name="张 智" userId="36bdf691fd3510be" providerId="LiveId" clId="{AE5DED4F-DA00-4450-AB73-450C993BC4FD}" dt="2024-05-13T02:25:50.446" v="8549" actId="20577"/>
+          <ac:spMkLst>
+            <pc:docMk/>
+            <pc:sldMk cId="693837114" sldId="1566"/>
+            <ac:spMk id="7" creationId="{75E0A5E3-B5A7-40C6-9FE8-508ABF9E1458}"/>
+          </ac:spMkLst>
+        </pc:spChg>
+      </pc:sldChg>
+      <pc:sldChg chg="modSp add del mod">
+        <pc:chgData name="张 智" userId="36bdf691fd3510be" providerId="LiveId" clId="{AE5DED4F-DA00-4450-AB73-450C993BC4FD}" dt="2024-05-10T15:44:19.941" v="1474" actId="2696"/>
+        <pc:sldMkLst>
+          <pc:docMk/>
+          <pc:sldMk cId="1707628157" sldId="1566"/>
+        </pc:sldMkLst>
+        <pc:spChg chg="mod">
+          <ac:chgData name="张 智" userId="36bdf691fd3510be" providerId="LiveId" clId="{AE5DED4F-DA00-4450-AB73-450C993BC4FD}" dt="2024-05-10T15:42:34.767" v="1467" actId="20577"/>
+          <ac:spMkLst>
+            <pc:docMk/>
+            <pc:sldMk cId="1707628157" sldId="1566"/>
+            <ac:spMk id="7" creationId="{75E0A5E3-B5A7-40C6-9FE8-508ABF9E1458}"/>
+          </ac:spMkLst>
+        </pc:spChg>
+      </pc:sldChg>
+      <pc:sldChg chg="modSp add mod modNotesTx">
+        <pc:chgData name="张 智" userId="36bdf691fd3510be" providerId="LiveId" clId="{AE5DED4F-DA00-4450-AB73-450C993BC4FD}" dt="2024-05-13T02:25:47.634" v="8548" actId="20577"/>
+        <pc:sldMkLst>
+          <pc:docMk/>
+          <pc:sldMk cId="1208814414" sldId="1567"/>
+        </pc:sldMkLst>
+        <pc:spChg chg="mod">
+          <ac:chgData name="张 智" userId="36bdf691fd3510be" providerId="LiveId" clId="{AE5DED4F-DA00-4450-AB73-450C993BC4FD}" dt="2024-05-11T15:29:23.006" v="4225" actId="20577"/>
+          <ac:spMkLst>
+            <pc:docMk/>
+            <pc:sldMk cId="1208814414" sldId="1567"/>
+            <ac:spMk id="2" creationId="{92B3B218-E6B7-E949-9413-DBDFA9A361B9}"/>
+          </ac:spMkLst>
+        </pc:spChg>
+        <pc:spChg chg="mod">
+          <ac:chgData name="张 智" userId="36bdf691fd3510be" providerId="LiveId" clId="{AE5DED4F-DA00-4450-AB73-450C993BC4FD}" dt="2024-05-13T02:25:47.634" v="8548" actId="20577"/>
+          <ac:spMkLst>
+            <pc:docMk/>
+            <pc:sldMk cId="1208814414" sldId="1567"/>
+            <ac:spMk id="7" creationId="{75E0A5E3-B5A7-40C6-9FE8-508ABF9E1458}"/>
+          </ac:spMkLst>
+        </pc:spChg>
+      </pc:sldChg>
+      <pc:sldChg chg="modSp add del mod modNotesTx">
+        <pc:chgData name="张 智" userId="36bdf691fd3510be" providerId="LiveId" clId="{AE5DED4F-DA00-4450-AB73-450C993BC4FD}" dt="2024-05-10T15:44:19.941" v="1474" actId="2696"/>
+        <pc:sldMkLst>
+          <pc:docMk/>
+          <pc:sldMk cId="3930504212" sldId="1567"/>
+        </pc:sldMkLst>
+        <pc:spChg chg="mod">
+          <ac:chgData name="张 智" userId="36bdf691fd3510be" providerId="LiveId" clId="{AE5DED4F-DA00-4450-AB73-450C993BC4FD}" dt="2024-05-10T15:43:06.503" v="1468" actId="21"/>
+          <ac:spMkLst>
+            <pc:docMk/>
+            <pc:sldMk cId="3930504212" sldId="1567"/>
+            <ac:spMk id="7" creationId="{75E0A5E3-B5A7-40C6-9FE8-508ABF9E1458}"/>
+          </ac:spMkLst>
+        </pc:spChg>
+      </pc:sldChg>
+      <pc:sldChg chg="addSp delSp modSp add mod modNotesTx">
+        <pc:chgData name="张 智" userId="36bdf691fd3510be" providerId="LiveId" clId="{AE5DED4F-DA00-4450-AB73-450C993BC4FD}" dt="2024-05-13T01:23:35.103" v="6299" actId="20577"/>
+        <pc:sldMkLst>
+          <pc:docMk/>
+          <pc:sldMk cId="1160980038" sldId="1568"/>
+        </pc:sldMkLst>
+        <pc:spChg chg="mod">
+          <ac:chgData name="张 智" userId="36bdf691fd3510be" providerId="LiveId" clId="{AE5DED4F-DA00-4450-AB73-450C993BC4FD}" dt="2024-05-10T16:06:00.309" v="2277" actId="20577"/>
+          <ac:spMkLst>
+            <pc:docMk/>
+            <pc:sldMk cId="1160980038" sldId="1568"/>
+            <ac:spMk id="2" creationId="{753A7AE6-D4A2-4EC7-AB69-D10FDED6791E}"/>
+          </ac:spMkLst>
+        </pc:spChg>
+        <pc:spChg chg="mod">
+          <ac:chgData name="张 智" userId="36bdf691fd3510be" providerId="LiveId" clId="{AE5DED4F-DA00-4450-AB73-450C993BC4FD}" dt="2024-05-11T14:28:43.144" v="3206" actId="20577"/>
+          <ac:spMkLst>
+            <pc:docMk/>
+            <pc:sldMk cId="1160980038" sldId="1568"/>
+            <ac:spMk id="5" creationId="{7F5B0894-DE45-40DF-81F4-90CA4E9FF03C}"/>
+          </ac:spMkLst>
+        </pc:spChg>
+        <pc:spChg chg="add del mod">
+          <ac:chgData name="张 智" userId="36bdf691fd3510be" providerId="LiveId" clId="{AE5DED4F-DA00-4450-AB73-450C993BC4FD}" dt="2024-05-10T16:05:25.648" v="2255" actId="478"/>
+          <ac:spMkLst>
+            <pc:docMk/>
+            <pc:sldMk cId="1160980038" sldId="1568"/>
+            <ac:spMk id="10" creationId="{8C022637-2CAB-4043-AD36-DD092A3715C7}"/>
+          </ac:spMkLst>
+        </pc:spChg>
+        <pc:spChg chg="add del mod">
+          <ac:chgData name="张 智" userId="36bdf691fd3510be" providerId="LiveId" clId="{AE5DED4F-DA00-4450-AB73-450C993BC4FD}" dt="2024-05-10T16:05:25.648" v="2255" actId="478"/>
+          <ac:spMkLst>
+            <pc:docMk/>
+            <pc:sldMk cId="1160980038" sldId="1568"/>
+            <ac:spMk id="11" creationId="{6A0B8B0F-21CB-411C-8E3C-AF37BE26A61D}"/>
+          </ac:spMkLst>
+        </pc:spChg>
+        <pc:spChg chg="add del mod">
+          <ac:chgData name="张 智" userId="36bdf691fd3510be" providerId="LiveId" clId="{AE5DED4F-DA00-4450-AB73-450C993BC4FD}" dt="2024-05-10T16:05:25.648" v="2255" actId="478"/>
+          <ac:spMkLst>
+            <pc:docMk/>
+            <pc:sldMk cId="1160980038" sldId="1568"/>
+            <ac:spMk id="12" creationId="{1333E6F0-577D-4F2D-922F-99A65DDA6AAE}"/>
+          </ac:spMkLst>
+        </pc:spChg>
+        <pc:spChg chg="add del mod">
+          <ac:chgData name="张 智" userId="36bdf691fd3510be" providerId="LiveId" clId="{AE5DED4F-DA00-4450-AB73-450C993BC4FD}" dt="2024-05-10T16:05:25.648" v="2255" actId="478"/>
+          <ac:spMkLst>
+            <pc:docMk/>
+            <pc:sldMk cId="1160980038" sldId="1568"/>
+            <ac:spMk id="13" creationId="{DDB5479B-B7C5-490F-8B02-9D812A5AE2FC}"/>
+          </ac:spMkLst>
+        </pc:spChg>
+        <pc:spChg chg="add del mod">
+          <ac:chgData name="张 智" userId="36bdf691fd3510be" providerId="LiveId" clId="{AE5DED4F-DA00-4450-AB73-450C993BC4FD}" dt="2024-05-10T16:05:25.648" v="2255" actId="478"/>
+          <ac:spMkLst>
+            <pc:docMk/>
+            <pc:sldMk cId="1160980038" sldId="1568"/>
+            <ac:spMk id="14" creationId="{039FEB61-FC61-49EB-91FA-E6CC5463D258}"/>
+          </ac:spMkLst>
+        </pc:spChg>
+        <pc:spChg chg="add del mod">
+          <ac:chgData name="张 智" userId="36bdf691fd3510be" providerId="LiveId" clId="{AE5DED4F-DA00-4450-AB73-450C993BC4FD}" dt="2024-05-10T16:05:25.648" v="2255" actId="478"/>
+          <ac:spMkLst>
+            <pc:docMk/>
+            <pc:sldMk cId="1160980038" sldId="1568"/>
+            <ac:spMk id="15" creationId="{81C3D0F7-AAC4-447A-8D4F-3D7EAC0EFEAC}"/>
+          </ac:spMkLst>
+        </pc:spChg>
+        <pc:spChg chg="add del mod">
+          <ac:chgData name="张 智" userId="36bdf691fd3510be" providerId="LiveId" clId="{AE5DED4F-DA00-4450-AB73-450C993BC4FD}" dt="2024-05-10T16:05:25.648" v="2255" actId="478"/>
+          <ac:spMkLst>
+            <pc:docMk/>
+            <pc:sldMk cId="1160980038" sldId="1568"/>
+            <ac:spMk id="16" creationId="{54A1E37B-392D-443A-B60C-D906C5F95C32}"/>
+          </ac:spMkLst>
+        </pc:spChg>
+        <pc:spChg chg="add del mod">
+          <ac:chgData name="张 智" userId="36bdf691fd3510be" providerId="LiveId" clId="{AE5DED4F-DA00-4450-AB73-450C993BC4FD}" dt="2024-05-10T16:05:25.648" v="2255" actId="478"/>
+          <ac:spMkLst>
+            <pc:docMk/>
+            <pc:sldMk cId="1160980038" sldId="1568"/>
+            <ac:spMk id="17" creationId="{DEB08144-363C-47EA-B39D-BEA137E64D76}"/>
+          </ac:spMkLst>
+        </pc:spChg>
+        <pc:spChg chg="add del mod">
+          <ac:chgData name="张 智" userId="36bdf691fd3510be" providerId="LiveId" clId="{AE5DED4F-DA00-4450-AB73-450C993BC4FD}" dt="2024-05-10T16:05:25.648" v="2255" actId="478"/>
+          <ac:spMkLst>
+            <pc:docMk/>
+            <pc:sldMk cId="1160980038" sldId="1568"/>
+            <ac:spMk id="18" creationId="{0AFF0BAA-EE06-4D5D-B369-1993A8883B51}"/>
+          </ac:spMkLst>
+        </pc:spChg>
+        <pc:spChg chg="add del mod">
+          <ac:chgData name="张 智" userId="36bdf691fd3510be" providerId="LiveId" clId="{AE5DED4F-DA00-4450-AB73-450C993BC4FD}" dt="2024-05-10T16:05:25.648" v="2255" actId="478"/>
+          <ac:spMkLst>
+            <pc:docMk/>
+            <pc:sldMk cId="1160980038" sldId="1568"/>
+            <ac:spMk id="19" creationId="{1AE1FC47-3DFF-449E-BF3C-146287CF7819}"/>
+          </ac:spMkLst>
+        </pc:spChg>
+        <pc:spChg chg="add del mod">
+          <ac:chgData name="张 智" userId="36bdf691fd3510be" providerId="LiveId" clId="{AE5DED4F-DA00-4450-AB73-450C993BC4FD}" dt="2024-05-10T16:05:25.648" v="2255" actId="478"/>
+          <ac:spMkLst>
+            <pc:docMk/>
+            <pc:sldMk cId="1160980038" sldId="1568"/>
+            <ac:spMk id="20" creationId="{A188EA56-FB3A-47E5-9684-40D238E3F6E2}"/>
+          </ac:spMkLst>
+        </pc:spChg>
+        <pc:spChg chg="add del mod">
+          <ac:chgData name="张 智" userId="36bdf691fd3510be" providerId="LiveId" clId="{AE5DED4F-DA00-4450-AB73-450C993BC4FD}" dt="2024-05-10T16:05:25.648" v="2255" actId="478"/>
+          <ac:spMkLst>
+            <pc:docMk/>
+            <pc:sldMk cId="1160980038" sldId="1568"/>
+            <ac:spMk id="21" creationId="{C89C2E8B-EC1F-42B5-806D-D132EC77D3D9}"/>
+          </ac:spMkLst>
+        </pc:spChg>
+        <pc:spChg chg="add del mod">
+          <ac:chgData name="张 智" userId="36bdf691fd3510be" providerId="LiveId" clId="{AE5DED4F-DA00-4450-AB73-450C993BC4FD}" dt="2024-05-10T16:05:25.648" v="2255" actId="478"/>
+          <ac:spMkLst>
+            <pc:docMk/>
+            <pc:sldMk cId="1160980038" sldId="1568"/>
+            <ac:spMk id="22" creationId="{6FA3106A-2659-484E-AA9A-CDFEE19EBFD0}"/>
+          </ac:spMkLst>
+        </pc:spChg>
+        <pc:spChg chg="add del mod">
+          <ac:chgData name="张 智" userId="36bdf691fd3510be" providerId="LiveId" clId="{AE5DED4F-DA00-4450-AB73-450C993BC4FD}" dt="2024-05-10T16:05:25.648" v="2255" actId="478"/>
+          <ac:spMkLst>
+            <pc:docMk/>
+            <pc:sldMk cId="1160980038" sldId="1568"/>
+            <ac:spMk id="23" creationId="{147B4DDC-8B92-4C37-9EC4-33C8D51E6F8F}"/>
+          </ac:spMkLst>
+        </pc:spChg>
+        <pc:spChg chg="add del mod">
+          <ac:chgData name="张 智" userId="36bdf691fd3510be" providerId="LiveId" clId="{AE5DED4F-DA00-4450-AB73-450C993BC4FD}" dt="2024-05-10T16:05:25.648" v="2255" actId="478"/>
+          <ac:spMkLst>
+            <pc:docMk/>
+            <pc:sldMk cId="1160980038" sldId="1568"/>
+            <ac:spMk id="24" creationId="{41E92CFE-FC77-4042-A1AE-FA715DEC27BC}"/>
+          </ac:spMkLst>
+        </pc:spChg>
+        <pc:picChg chg="del">
+          <ac:chgData name="张 智" userId="36bdf691fd3510be" providerId="LiveId" clId="{AE5DED4F-DA00-4450-AB73-450C993BC4FD}" dt="2024-05-10T15:57:34.534" v="2122" actId="478"/>
+          <ac:picMkLst>
+            <pc:docMk/>
+            <pc:sldMk cId="1160980038" sldId="1568"/>
+            <ac:picMk id="6" creationId="{D3320554-657F-4671-ACBB-D0789B7930CB}"/>
+          </ac:picMkLst>
+        </pc:picChg>
+        <pc:picChg chg="add del mod">
+          <ac:chgData name="张 智" userId="36bdf691fd3510be" providerId="LiveId" clId="{AE5DED4F-DA00-4450-AB73-450C993BC4FD}" dt="2024-05-10T16:03:56.453" v="2239" actId="478"/>
+          <ac:picMkLst>
+            <pc:docMk/>
+            <pc:sldMk cId="1160980038" sldId="1568"/>
+            <ac:picMk id="7" creationId="{D5E4ABB9-AA0E-4744-A795-742FFAFFCF5D}"/>
+          </ac:picMkLst>
+        </pc:picChg>
+        <pc:picChg chg="add del mod">
+          <ac:chgData name="张 智" userId="36bdf691fd3510be" providerId="LiveId" clId="{AE5DED4F-DA00-4450-AB73-450C993BC4FD}" dt="2024-05-10T16:05:21.036" v="2254" actId="478"/>
+          <ac:picMkLst>
+            <pc:docMk/>
+            <pc:sldMk cId="1160980038" sldId="1568"/>
+            <ac:picMk id="8" creationId="{32E93B20-23EF-4B55-93A9-A5AB11260DEF}"/>
+          </ac:picMkLst>
+        </pc:picChg>
+        <pc:picChg chg="add del mod">
+          <ac:chgData name="张 智" userId="36bdf691fd3510be" providerId="LiveId" clId="{AE5DED4F-DA00-4450-AB73-450C993BC4FD}" dt="2024-05-10T16:05:25.648" v="2255" actId="478"/>
+          <ac:picMkLst>
+            <pc:docMk/>
+            <pc:sldMk cId="1160980038" sldId="1568"/>
+            <ac:picMk id="9" creationId="{7241FE12-F380-4D00-9044-2BA554046EFF}"/>
+          </ac:picMkLst>
+        </pc:picChg>
+      </pc:sldChg>
+      <pc:sldChg chg="addSp delSp modSp add del mod modNotesTx">
+        <pc:chgData name="张 智" userId="36bdf691fd3510be" providerId="LiveId" clId="{AE5DED4F-DA00-4450-AB73-450C993BC4FD}" dt="2024-05-10T15:51:51.546" v="1689" actId="2696"/>
+        <pc:sldMkLst>
+          <pc:docMk/>
+          <pc:sldMk cId="3289623412" sldId="1568"/>
+        </pc:sldMkLst>
+        <pc:spChg chg="del">
+          <ac:chgData name="张 智" userId="36bdf691fd3510be" providerId="LiveId" clId="{AE5DED4F-DA00-4450-AB73-450C993BC4FD}" dt="2024-05-10T15:50:49.257" v="1638" actId="21"/>
+          <ac:spMkLst>
+            <pc:docMk/>
+            <pc:sldMk cId="3289623412" sldId="1568"/>
+            <ac:spMk id="2" creationId="{92B3B218-E6B7-E949-9413-DBDFA9A361B9}"/>
+          </ac:spMkLst>
+        </pc:spChg>
+        <pc:spChg chg="add mod">
+          <ac:chgData name="张 智" userId="36bdf691fd3510be" providerId="LiveId" clId="{AE5DED4F-DA00-4450-AB73-450C993BC4FD}" dt="2024-05-10T15:50:49.257" v="1638" actId="21"/>
+          <ac:spMkLst>
+            <pc:docMk/>
+            <pc:sldMk cId="3289623412" sldId="1568"/>
+            <ac:spMk id="4" creationId="{BD6B69A5-E0E4-49FF-8C57-B680279270DD}"/>
+          </ac:spMkLst>
+        </pc:spChg>
+        <pc:spChg chg="del">
+          <ac:chgData name="张 智" userId="36bdf691fd3510be" providerId="LiveId" clId="{AE5DED4F-DA00-4450-AB73-450C993BC4FD}" dt="2024-05-10T15:50:37.841" v="1636" actId="478"/>
+          <ac:spMkLst>
+            <pc:docMk/>
+            <pc:sldMk cId="3289623412" sldId="1568"/>
+            <ac:spMk id="5" creationId="{212FFFC4-E00C-455E-BA6A-697EE9560C2D}"/>
+          </ac:spMkLst>
+        </pc:spChg>
+        <pc:spChg chg="del">
+          <ac:chgData name="张 智" userId="36bdf691fd3510be" providerId="LiveId" clId="{AE5DED4F-DA00-4450-AB73-450C993BC4FD}" dt="2024-05-10T15:50:36.060" v="1634" actId="478"/>
+          <ac:spMkLst>
+            <pc:docMk/>
+            <pc:sldMk cId="3289623412" sldId="1568"/>
+            <ac:spMk id="7" creationId="{75E0A5E3-B5A7-40C6-9FE8-508ABF9E1458}"/>
+          </ac:spMkLst>
+        </pc:spChg>
+        <pc:picChg chg="del">
+          <ac:chgData name="张 智" userId="36bdf691fd3510be" providerId="LiveId" clId="{AE5DED4F-DA00-4450-AB73-450C993BC4FD}" dt="2024-05-10T15:50:36.900" v="1635" actId="478"/>
+          <ac:picMkLst>
+            <pc:docMk/>
+            <pc:sldMk cId="3289623412" sldId="1568"/>
+            <ac:picMk id="1026" creationId="{91BB2D63-9A43-4A70-94A6-83ACD9DA0AEE}"/>
+          </ac:picMkLst>
+        </pc:picChg>
+      </pc:sldChg>
+      <pc:sldChg chg="modSp add del mod">
+        <pc:chgData name="张 智" userId="36bdf691fd3510be" providerId="LiveId" clId="{AE5DED4F-DA00-4450-AB73-450C993BC4FD}" dt="2024-05-10T16:07:15.848" v="2306" actId="2696"/>
+        <pc:sldMkLst>
+          <pc:docMk/>
+          <pc:sldMk cId="2700984908" sldId="1569"/>
+        </pc:sldMkLst>
+        <pc:spChg chg="mod">
+          <ac:chgData name="张 智" userId="36bdf691fd3510be" providerId="LiveId" clId="{AE5DED4F-DA00-4450-AB73-450C993BC4FD}" dt="2024-05-10T16:06:14.598" v="2280" actId="14100"/>
+          <ac:spMkLst>
+            <pc:docMk/>
+            <pc:sldMk cId="2700984908" sldId="1569"/>
+            <ac:spMk id="2" creationId="{753A7AE6-D4A2-4EC7-AB69-D10FDED6791E}"/>
+          </ac:spMkLst>
+        </pc:spChg>
+      </pc:sldChg>
+      <pc:sldChg chg="modSp add mod modNotesTx">
+        <pc:chgData name="张 智" userId="36bdf691fd3510be" providerId="LiveId" clId="{AE5DED4F-DA00-4450-AB73-450C993BC4FD}" dt="2024-05-13T03:17:18.299" v="9775" actId="20577"/>
+        <pc:sldMkLst>
+          <pc:docMk/>
+          <pc:sldMk cId="3127478266" sldId="1569"/>
+        </pc:sldMkLst>
+        <pc:spChg chg="mod">
+          <ac:chgData name="张 智" userId="36bdf691fd3510be" providerId="LiveId" clId="{AE5DED4F-DA00-4450-AB73-450C993BC4FD}" dt="2024-05-11T14:29:21.866" v="3209" actId="20577"/>
+          <ac:spMkLst>
+            <pc:docMk/>
+            <pc:sldMk cId="3127478266" sldId="1569"/>
+            <ac:spMk id="2" creationId="{92B3B218-E6B7-E949-9413-DBDFA9A361B9}"/>
+          </ac:spMkLst>
+        </pc:spChg>
+        <pc:spChg chg="mod">
+          <ac:chgData name="张 智" userId="36bdf691fd3510be" providerId="LiveId" clId="{AE5DED4F-DA00-4450-AB73-450C993BC4FD}" dt="2024-05-11T14:31:19.493" v="3228" actId="27636"/>
+          <ac:spMkLst>
+            <pc:docMk/>
+            <pc:sldMk cId="3127478266" sldId="1569"/>
+            <ac:spMk id="3" creationId="{13DB3674-2D4B-8645-8753-8E30E629B377}"/>
+          </ac:spMkLst>
+        </pc:spChg>
+      </pc:sldChg>
+      <pc:sldChg chg="modSp add mod modNotesTx">
+        <pc:chgData name="张 智" userId="36bdf691fd3510be" providerId="LiveId" clId="{AE5DED4F-DA00-4450-AB73-450C993BC4FD}" dt="2024-05-13T06:31:31.889" v="10384" actId="20577"/>
+        <pc:sldMkLst>
+          <pc:docMk/>
+          <pc:sldMk cId="3661408518" sldId="1570"/>
+        </pc:sldMkLst>
+        <pc:spChg chg="mod">
+          <ac:chgData name="张 智" userId="36bdf691fd3510be" providerId="LiveId" clId="{AE5DED4F-DA00-4450-AB73-450C993BC4FD}" dt="2024-05-11T14:45:26.728" v="3230" actId="20577"/>
+          <ac:spMkLst>
+            <pc:docMk/>
+            <pc:sldMk cId="3661408518" sldId="1570"/>
+            <ac:spMk id="2" creationId="{92B3B218-E6B7-E949-9413-DBDFA9A361B9}"/>
+          </ac:spMkLst>
+        </pc:spChg>
+        <pc:spChg chg="mod">
+          <ac:chgData name="张 智" userId="36bdf691fd3510be" providerId="LiveId" clId="{AE5DED4F-DA00-4450-AB73-450C993BC4FD}" dt="2024-05-11T14:45:48.138" v="3238" actId="14100"/>
+          <ac:spMkLst>
+            <pc:docMk/>
+            <pc:sldMk cId="3661408518" sldId="1570"/>
+            <ac:spMk id="3" creationId="{13DB3674-2D4B-8645-8753-8E30E629B377}"/>
+          </ac:spMkLst>
+        </pc:spChg>
+      </pc:sldChg>
+      <pc:sldChg chg="modSp add mod modNotesTx">
+        <pc:chgData name="张 智" userId="36bdf691fd3510be" providerId="LiveId" clId="{AE5DED4F-DA00-4450-AB73-450C993BC4FD}" dt="2024-05-13T01:27:53.707" v="6404" actId="20577"/>
+        <pc:sldMkLst>
+          <pc:docMk/>
+          <pc:sldMk cId="3120467212" sldId="1571"/>
+        </pc:sldMkLst>
+        <pc:spChg chg="mod">
+          <ac:chgData name="张 智" userId="36bdf691fd3510be" providerId="LiveId" clId="{AE5DED4F-DA00-4450-AB73-450C993BC4FD}" dt="2024-05-11T14:48:50.168" v="3298" actId="1076"/>
+          <ac:spMkLst>
+            <pc:docMk/>
+            <pc:sldMk cId="3120467212" sldId="1571"/>
+            <ac:spMk id="2" creationId="{92B3B218-E6B7-E949-9413-DBDFA9A361B9}"/>
+          </ac:spMkLst>
+        </pc:spChg>
+        <pc:spChg chg="mod">
+          <ac:chgData name="张 智" userId="36bdf691fd3510be" providerId="LiveId" clId="{AE5DED4F-DA00-4450-AB73-450C993BC4FD}" dt="2024-05-13T01:27:53.707" v="6404" actId="20577"/>
+          <ac:spMkLst>
+            <pc:docMk/>
+            <pc:sldMk cId="3120467212" sldId="1571"/>
+            <ac:spMk id="3" creationId="{13DB3674-2D4B-8645-8753-8E30E629B377}"/>
+          </ac:spMkLst>
+        </pc:spChg>
+      </pc:sldChg>
+      <pc:sldChg chg="modSp add mod modNotesTx">
+        <pc:chgData name="张 智" userId="36bdf691fd3510be" providerId="LiveId" clId="{AE5DED4F-DA00-4450-AB73-450C993BC4FD}" dt="2024-05-13T01:29:53.013" v="6455" actId="20577"/>
+        <pc:sldMkLst>
+          <pc:docMk/>
+          <pc:sldMk cId="3497431990" sldId="1572"/>
+        </pc:sldMkLst>
+        <pc:spChg chg="mod">
+          <ac:chgData name="张 智" userId="36bdf691fd3510be" providerId="LiveId" clId="{AE5DED4F-DA00-4450-AB73-450C993BC4FD}" dt="2024-05-11T14:51:30.839" v="3322" actId="20577"/>
+          <ac:spMkLst>
+            <pc:docMk/>
+            <pc:sldMk cId="3497431990" sldId="1572"/>
+            <ac:spMk id="3" creationId="{13DB3674-2D4B-8645-8753-8E30E629B377}"/>
+          </ac:spMkLst>
+        </pc:spChg>
+      </pc:sldChg>
+      <pc:sldChg chg="modSp add mod modNotesTx">
+        <pc:chgData name="张 智" userId="36bdf691fd3510be" providerId="LiveId" clId="{AE5DED4F-DA00-4450-AB73-450C993BC4FD}" dt="2024-05-13T01:31:11.678" v="6619" actId="20577"/>
+        <pc:sldMkLst>
+          <pc:docMk/>
+          <pc:sldMk cId="4069697500" sldId="1573"/>
+        </pc:sldMkLst>
+        <pc:spChg chg="mod">
+          <ac:chgData name="张 智" userId="36bdf691fd3510be" providerId="LiveId" clId="{AE5DED4F-DA00-4450-AB73-450C993BC4FD}" dt="2024-05-11T14:58:27.514" v="3674" actId="20577"/>
+          <ac:spMkLst>
+            <pc:docMk/>
+            <pc:sldMk cId="4069697500" sldId="1573"/>
+            <ac:spMk id="3" creationId="{13DB3674-2D4B-8645-8753-8E30E629B377}"/>
+          </ac:spMkLst>
+        </pc:spChg>
+      </pc:sldChg>
+      <pc:sldChg chg="modSp add mod">
+        <pc:chgData name="张 智" userId="36bdf691fd3510be" providerId="LiveId" clId="{AE5DED4F-DA00-4450-AB73-450C993BC4FD}" dt="2024-05-13T03:20:43.289" v="9777" actId="20577"/>
+        <pc:sldMkLst>
+          <pc:docMk/>
+          <pc:sldMk cId="1676628065" sldId="1574"/>
+        </pc:sldMkLst>
+        <pc:spChg chg="mod">
+          <ac:chgData name="张 智" userId="36bdf691fd3510be" providerId="LiveId" clId="{AE5DED4F-DA00-4450-AB73-450C993BC4FD}" dt="2024-05-11T15:02:27.981" v="3677" actId="20577"/>
+          <ac:spMkLst>
+            <pc:docMk/>
+            <pc:sldMk cId="1676628065" sldId="1574"/>
+            <ac:spMk id="2" creationId="{92B3B218-E6B7-E949-9413-DBDFA9A361B9}"/>
+          </ac:spMkLst>
+        </pc:spChg>
+        <pc:spChg chg="mod">
+          <ac:chgData name="张 智" userId="36bdf691fd3510be" providerId="LiveId" clId="{AE5DED4F-DA00-4450-AB73-450C993BC4FD}" dt="2024-05-13T03:20:43.289" v="9777" actId="20577"/>
+          <ac:spMkLst>
+            <pc:docMk/>
+            <pc:sldMk cId="1676628065" sldId="1574"/>
+            <ac:spMk id="3" creationId="{13DB3674-2D4B-8645-8753-8E30E629B377}"/>
+          </ac:spMkLst>
+        </pc:spChg>
+      </pc:sldChg>
+      <pc:sldChg chg="modSp add mod modNotesTx">
+        <pc:chgData name="张 智" userId="36bdf691fd3510be" providerId="LiveId" clId="{AE5DED4F-DA00-4450-AB73-450C993BC4FD}" dt="2024-05-13T03:24:21.202" v="9817" actId="20577"/>
+        <pc:sldMkLst>
+          <pc:docMk/>
+          <pc:sldMk cId="2183489948" sldId="1575"/>
+        </pc:sldMkLst>
+        <pc:spChg chg="mod">
+          <ac:chgData name="张 智" userId="36bdf691fd3510be" providerId="LiveId" clId="{AE5DED4F-DA00-4450-AB73-450C993BC4FD}" dt="2024-05-11T15:19:54.986" v="4011" actId="20577"/>
+          <ac:spMkLst>
+            <pc:docMk/>
+            <pc:sldMk cId="2183489948" sldId="1575"/>
+            <ac:spMk id="2" creationId="{92B3B218-E6B7-E949-9413-DBDFA9A361B9}"/>
+          </ac:spMkLst>
+        </pc:spChg>
+        <pc:spChg chg="mod">
+          <ac:chgData name="张 智" userId="36bdf691fd3510be" providerId="LiveId" clId="{AE5DED4F-DA00-4450-AB73-450C993BC4FD}" dt="2024-05-11T15:27:04.711" v="4217" actId="20577"/>
+          <ac:spMkLst>
+            <pc:docMk/>
+            <pc:sldMk cId="2183489948" sldId="1575"/>
+            <ac:spMk id="3" creationId="{13DB3674-2D4B-8645-8753-8E30E629B377}"/>
+          </ac:spMkLst>
+        </pc:spChg>
+      </pc:sldChg>
+      <pc:sldChg chg="modSp add del mod">
+        <pc:chgData name="张 智" userId="36bdf691fd3510be" providerId="LiveId" clId="{AE5DED4F-DA00-4450-AB73-450C993BC4FD}" dt="2024-05-11T15:16:06.244" v="3994" actId="2696"/>
+        <pc:sldMkLst>
+          <pc:docMk/>
+          <pc:sldMk cId="4271803376" sldId="1575"/>
+        </pc:sldMkLst>
+        <pc:spChg chg="mod">
+          <ac:chgData name="张 智" userId="36bdf691fd3510be" providerId="LiveId" clId="{AE5DED4F-DA00-4450-AB73-450C993BC4FD}" dt="2024-05-11T15:07:24.034" v="3782"/>
+          <ac:spMkLst>
+            <pc:docMk/>
+            <pc:sldMk cId="4271803376" sldId="1575"/>
+            <ac:spMk id="3" creationId="{13DB3674-2D4B-8645-8753-8E30E629B377}"/>
+          </ac:spMkLst>
+        </pc:spChg>
+      </pc:sldChg>
+      <pc:sldChg chg="modSp add mod">
+        <pc:chgData name="张 智" userId="36bdf691fd3510be" providerId="LiveId" clId="{AE5DED4F-DA00-4450-AB73-450C993BC4FD}" dt="2024-05-13T01:34:47.337" v="6675" actId="20577"/>
+        <pc:sldMkLst>
+          <pc:docMk/>
+          <pc:sldMk cId="1028791141" sldId="1576"/>
+        </pc:sldMkLst>
+        <pc:spChg chg="mod">
+          <ac:chgData name="张 智" userId="36bdf691fd3510be" providerId="LiveId" clId="{AE5DED4F-DA00-4450-AB73-450C993BC4FD}" dt="2024-05-11T15:19:44.539" v="4009" actId="20577"/>
+          <ac:spMkLst>
+            <pc:docMk/>
+            <pc:sldMk cId="1028791141" sldId="1576"/>
+            <ac:spMk id="2" creationId="{92B3B218-E6B7-E949-9413-DBDFA9A361B9}"/>
+          </ac:spMkLst>
+        </pc:spChg>
+        <pc:spChg chg="mod">
+          <ac:chgData name="张 智" userId="36bdf691fd3510be" providerId="LiveId" clId="{AE5DED4F-DA00-4450-AB73-450C993BC4FD}" dt="2024-05-13T01:34:47.337" v="6675" actId="20577"/>
+          <ac:spMkLst>
+            <pc:docMk/>
+            <pc:sldMk cId="1028791141" sldId="1576"/>
+            <ac:spMk id="3" creationId="{13DB3674-2D4B-8645-8753-8E30E629B377}"/>
+          </ac:spMkLst>
+        </pc:spChg>
+      </pc:sldChg>
+      <pc:sldChg chg="add del">
+        <pc:chgData name="张 智" userId="36bdf691fd3510be" providerId="LiveId" clId="{AE5DED4F-DA00-4450-AB73-450C993BC4FD}" dt="2024-05-11T15:16:32.479" v="3996" actId="2696"/>
+        <pc:sldMkLst>
+          <pc:docMk/>
+          <pc:sldMk cId="1352202657" sldId="1576"/>
+        </pc:sldMkLst>
+      </pc:sldChg>
+      <pc:sldChg chg="modSp add del mod modNotesTx">
+        <pc:chgData name="张 智" userId="36bdf691fd3510be" providerId="LiveId" clId="{AE5DED4F-DA00-4450-AB73-450C993BC4FD}" dt="2024-05-11T15:16:06.244" v="3994" actId="2696"/>
+        <pc:sldMkLst>
+          <pc:docMk/>
+          <pc:sldMk cId="3214735365" sldId="1576"/>
+        </pc:sldMkLst>
+        <pc:spChg chg="mod">
+          <ac:chgData name="张 智" userId="36bdf691fd3510be" providerId="LiveId" clId="{AE5DED4F-DA00-4450-AB73-450C993BC4FD}" dt="2024-05-11T15:14:55.969" v="3984" actId="20577"/>
+          <ac:spMkLst>
+            <pc:docMk/>
+            <pc:sldMk cId="3214735365" sldId="1576"/>
+            <ac:spMk id="3" creationId="{13DB3674-2D4B-8645-8753-8E30E629B377}"/>
+          </ac:spMkLst>
+        </pc:spChg>
+      </pc:sldChg>
+      <pc:sldChg chg="modSp add mod modNotesTx">
+        <pc:chgData name="张 智" userId="36bdf691fd3510be" providerId="LiveId" clId="{AE5DED4F-DA00-4450-AB73-450C993BC4FD}" dt="2024-05-13T01:41:03.703" v="6677" actId="20577"/>
+        <pc:sldMkLst>
+          <pc:docMk/>
+          <pc:sldMk cId="3674712720" sldId="1577"/>
+        </pc:sldMkLst>
+        <pc:spChg chg="mod">
+          <ac:chgData name="张 智" userId="36bdf691fd3510be" providerId="LiveId" clId="{AE5DED4F-DA00-4450-AB73-450C993BC4FD}" dt="2024-05-11T15:19:49.680" v="4010" actId="20577"/>
+          <ac:spMkLst>
+            <pc:docMk/>
+            <pc:sldMk cId="3674712720" sldId="1577"/>
+            <ac:spMk id="2" creationId="{92B3B218-E6B7-E949-9413-DBDFA9A361B9}"/>
+          </ac:spMkLst>
+        </pc:spChg>
+        <pc:spChg chg="mod">
+          <ac:chgData name="张 智" userId="36bdf691fd3510be" providerId="LiveId" clId="{AE5DED4F-DA00-4450-AB73-450C993BC4FD}" dt="2024-05-13T01:41:03.703" v="6677" actId="20577"/>
+          <ac:spMkLst>
+            <pc:docMk/>
+            <pc:sldMk cId="3674712720" sldId="1577"/>
+            <ac:spMk id="3" creationId="{13DB3674-2D4B-8645-8753-8E30E629B377}"/>
+          </ac:spMkLst>
+        </pc:spChg>
+      </pc:sldChg>
+      <pc:sldChg chg="modSp add mod modNotesTx">
+        <pc:chgData name="张 智" userId="36bdf691fd3510be" providerId="LiveId" clId="{AE5DED4F-DA00-4450-AB73-450C993BC4FD}" dt="2024-05-13T01:43:37.222" v="6713" actId="20577"/>
+        <pc:sldMkLst>
+          <pc:docMk/>
+          <pc:sldMk cId="2614465481" sldId="1578"/>
+        </pc:sldMkLst>
+        <pc:spChg chg="mod">
+          <ac:chgData name="张 智" userId="36bdf691fd3510be" providerId="LiveId" clId="{AE5DED4F-DA00-4450-AB73-450C993BC4FD}" dt="2024-05-11T15:19:59.956" v="4012" actId="20577"/>
+          <ac:spMkLst>
+            <pc:docMk/>
+            <pc:sldMk cId="2614465481" sldId="1578"/>
+            <ac:spMk id="2" creationId="{92B3B218-E6B7-E949-9413-DBDFA9A361B9}"/>
+          </ac:spMkLst>
+        </pc:spChg>
+        <pc:spChg chg="mod">
+          <ac:chgData name="张 智" userId="36bdf691fd3510be" providerId="LiveId" clId="{AE5DED4F-DA00-4450-AB73-450C993BC4FD}" dt="2024-05-11T15:26:57.618" v="4214" actId="20577"/>
+          <ac:spMkLst>
+            <pc:docMk/>
+            <pc:sldMk cId="2614465481" sldId="1578"/>
+            <ac:spMk id="3" creationId="{13DB3674-2D4B-8645-8753-8E30E629B377}"/>
+          </ac:spMkLst>
+        </pc:spChg>
+      </pc:sldChg>
+      <pc:sldChg chg="modSp add del mod">
+        <pc:chgData name="张 智" userId="36bdf691fd3510be" providerId="LiveId" clId="{AE5DED4F-DA00-4450-AB73-450C993BC4FD}" dt="2024-05-11T15:18:14.781" v="3999" actId="2696"/>
+        <pc:sldMkLst>
+          <pc:docMk/>
+          <pc:sldMk cId="2765866733" sldId="1578"/>
+        </pc:sldMkLst>
+        <pc:spChg chg="mod">
+          <ac:chgData name="张 智" userId="36bdf691fd3510be" providerId="LiveId" clId="{AE5DED4F-DA00-4450-AB73-450C993BC4FD}" dt="2024-05-11T15:15:27.101" v="3988" actId="20577"/>
+          <ac:spMkLst>
+            <pc:docMk/>
+            <pc:sldMk cId="2765866733" sldId="1578"/>
+            <ac:spMk id="3" creationId="{13DB3674-2D4B-8645-8753-8E30E629B377}"/>
+          </ac:spMkLst>
+        </pc:spChg>
+      </pc:sldChg>
+      <pc:sldChg chg="modSp add mod modNotesTx">
+        <pc:chgData name="张 智" userId="36bdf691fd3510be" providerId="LiveId" clId="{AE5DED4F-DA00-4450-AB73-450C993BC4FD}" dt="2024-05-13T01:33:47.891" v="6673" actId="20577"/>
+        <pc:sldMkLst>
+          <pc:docMk/>
+          <pc:sldMk cId="11049585" sldId="1579"/>
+        </pc:sldMkLst>
+        <pc:spChg chg="mod">
+          <ac:chgData name="张 智" userId="36bdf691fd3510be" providerId="LiveId" clId="{AE5DED4F-DA00-4450-AB73-450C993BC4FD}" dt="2024-05-11T15:19:40.967" v="4008" actId="20577"/>
+          <ac:spMkLst>
+            <pc:docMk/>
+            <pc:sldMk cId="11049585" sldId="1579"/>
+            <ac:spMk id="2" creationId="{92B3B218-E6B7-E949-9413-DBDFA9A361B9}"/>
+          </ac:spMkLst>
+        </pc:spChg>
+        <pc:spChg chg="mod">
+          <ac:chgData name="张 智" userId="36bdf691fd3510be" providerId="LiveId" clId="{AE5DED4F-DA00-4450-AB73-450C993BC4FD}" dt="2024-05-13T01:32:57.273" v="6628" actId="20577"/>
+          <ac:spMkLst>
+            <pc:docMk/>
+            <pc:sldMk cId="11049585" sldId="1579"/>
+            <ac:spMk id="3" creationId="{13DB3674-2D4B-8645-8753-8E30E629B377}"/>
+          </ac:spMkLst>
+        </pc:spChg>
+      </pc:sldChg>
+      <pc:sldChg chg="modSp add mod">
+        <pc:chgData name="张 智" userId="36bdf691fd3510be" providerId="LiveId" clId="{AE5DED4F-DA00-4450-AB73-450C993BC4FD}" dt="2024-05-27T07:09:53.833" v="10408" actId="207"/>
+        <pc:sldMkLst>
+          <pc:docMk/>
+          <pc:sldMk cId="35181850" sldId="1580"/>
+        </pc:sldMkLst>
+        <pc:spChg chg="mod">
+          <ac:chgData name="张 智" userId="36bdf691fd3510be" providerId="LiveId" clId="{AE5DED4F-DA00-4450-AB73-450C993BC4FD}" dt="2024-05-27T07:09:36.189" v="10397" actId="207"/>
+          <ac:spMkLst>
+            <pc:docMk/>
+            <pc:sldMk cId="35181850" sldId="1580"/>
+            <ac:spMk id="2" creationId="{5C4F01C5-5333-2248-B03B-703C97F7CC69}"/>
+          </ac:spMkLst>
+        </pc:spChg>
+        <pc:spChg chg="mod">
+          <ac:chgData name="张 智" userId="36bdf691fd3510be" providerId="LiveId" clId="{AE5DED4F-DA00-4450-AB73-450C993BC4FD}" dt="2024-05-27T07:09:53.833" v="10408" actId="207"/>
+          <ac:spMkLst>
+            <pc:docMk/>
+            <pc:sldMk cId="35181850" sldId="1580"/>
+            <ac:spMk id="3" creationId="{F7DD7DCB-C7E2-1B4F-BD83-3B7AF005DD76}"/>
+          </ac:spMkLst>
+        </pc:spChg>
+      </pc:sldChg>
+    </pc:docChg>
+  </pc:docChgLst>
+  <pc:docChgLst>
+    <pc:chgData name="张 智" userId="36bdf691fd3510be" providerId="LiveId" clId="{8D485A30-9296-4C7B-A56F-774F846EFEC2}"/>
+    <pc:docChg chg="modSld">
+      <pc:chgData name="张 智" userId="36bdf691fd3510be" providerId="LiveId" clId="{8D485A30-9296-4C7B-A56F-774F846EFEC2}" dt="2024-04-11T03:16:28.923" v="1" actId="20577"/>
+      <pc:docMkLst>
+        <pc:docMk/>
+      </pc:docMkLst>
+      <pc:sldChg chg="modSp mod">
+        <pc:chgData name="张 智" userId="36bdf691fd3510be" providerId="LiveId" clId="{8D485A30-9296-4C7B-A56F-774F846EFEC2}" dt="2024-04-11T03:16:10.457" v="0" actId="20577"/>
+        <pc:sldMkLst>
+          <pc:docMk/>
+          <pc:sldMk cId="3667523257" sldId="452"/>
+        </pc:sldMkLst>
+        <pc:spChg chg="mod">
+          <ac:chgData name="张 智" userId="36bdf691fd3510be" providerId="LiveId" clId="{8D485A30-9296-4C7B-A56F-774F846EFEC2}" dt="2024-04-11T03:16:10.457" v="0" actId="20577"/>
+          <ac:spMkLst>
+            <pc:docMk/>
+            <pc:sldMk cId="3667523257" sldId="452"/>
+            <ac:spMk id="7" creationId="{75E0A5E3-B5A7-40C6-9FE8-508ABF9E1458}"/>
+          </ac:spMkLst>
+        </pc:spChg>
+      </pc:sldChg>
+      <pc:sldChg chg="modSp mod">
+        <pc:chgData name="张 智" userId="36bdf691fd3510be" providerId="LiveId" clId="{8D485A30-9296-4C7B-A56F-774F846EFEC2}" dt="2024-04-11T03:16:28.923" v="1" actId="20577"/>
+        <pc:sldMkLst>
+          <pc:docMk/>
+          <pc:sldMk cId="1628170773" sldId="462"/>
+        </pc:sldMkLst>
+        <pc:spChg chg="mod">
+          <ac:chgData name="张 智" userId="36bdf691fd3510be" providerId="LiveId" clId="{8D485A30-9296-4C7B-A56F-774F846EFEC2}" dt="2024-04-11T03:16:28.923" v="1" actId="20577"/>
+          <ac:spMkLst>
+            <pc:docMk/>
+            <pc:sldMk cId="1628170773" sldId="462"/>
+            <ac:spMk id="7" creationId="{75E0A5E3-B5A7-40C6-9FE8-508ABF9E1458}"/>
+          </ac:spMkLst>
+        </pc:spChg>
+      </pc:sldChg>
+    </pc:docChg>
+  </pc:docChgLst>
+  <pc:docChgLst>
+    <pc:chgData name="zhi zhang" userId="36bdf691fd3510be" providerId="LiveId" clId="{5BC97996-095E-49A7-A797-DB2E422DD13D}"/>
+    <pc:docChg chg="undo custSel addSld delSld modSld sldOrd">
+      <pc:chgData name="zhi zhang" userId="36bdf691fd3510be" providerId="LiveId" clId="{5BC97996-095E-49A7-A797-DB2E422DD13D}" dt="2025-05-12T05:55:42.451" v="9191" actId="6549"/>
+      <pc:docMkLst>
+        <pc:docMk/>
+      </pc:docMkLst>
+      <pc:sldChg chg="modSp mod modNotesTx">
+        <pc:chgData name="zhi zhang" userId="36bdf691fd3510be" providerId="LiveId" clId="{5BC97996-095E-49A7-A797-DB2E422DD13D}" dt="2025-05-12T05:12:24.153" v="8920" actId="20577"/>
+        <pc:sldMkLst>
+          <pc:docMk/>
+          <pc:sldMk cId="1077586671" sldId="256"/>
+        </pc:sldMkLst>
+        <pc:spChg chg="mod">
+          <ac:chgData name="zhi zhang" userId="36bdf691fd3510be" providerId="LiveId" clId="{5BC97996-095E-49A7-A797-DB2E422DD13D}" dt="2025-05-08T07:16:22.241" v="0" actId="20577"/>
+          <ac:spMkLst>
+            <pc:docMk/>
+            <pc:sldMk cId="1077586671" sldId="256"/>
+            <ac:spMk id="2" creationId="{A7F2B5DE-6445-CC49-9F8E-7C9072991AF6}"/>
+          </ac:spMkLst>
+        </pc:spChg>
+      </pc:sldChg>
+      <pc:sldChg chg="modNotesTx">
+        <pc:chgData name="zhi zhang" userId="36bdf691fd3510be" providerId="LiveId" clId="{5BC97996-095E-49A7-A797-DB2E422DD13D}" dt="2025-05-11T14:16:41.377" v="3933" actId="20577"/>
+        <pc:sldMkLst>
+          <pc:docMk/>
+          <pc:sldMk cId="1112541085" sldId="260"/>
+        </pc:sldMkLst>
+      </pc:sldChg>
+      <pc:sldChg chg="modSp mod modNotesTx">
+        <pc:chgData name="zhi zhang" userId="36bdf691fd3510be" providerId="LiveId" clId="{5BC97996-095E-49A7-A797-DB2E422DD13D}" dt="2025-05-11T14:45:49.249" v="5163" actId="20577"/>
+        <pc:sldMkLst>
+          <pc:docMk/>
+          <pc:sldMk cId="182683393" sldId="272"/>
+        </pc:sldMkLst>
+        <pc:spChg chg="mod">
+          <ac:chgData name="zhi zhang" userId="36bdf691fd3510be" providerId="LiveId" clId="{5BC97996-095E-49A7-A797-DB2E422DD13D}" dt="2025-05-09T00:53:40.270" v="2068" actId="1036"/>
+          <ac:spMkLst>
+            <pc:docMk/>
+            <pc:sldMk cId="182683393" sldId="272"/>
+            <ac:spMk id="2" creationId="{92B3B218-E6B7-E949-9413-DBDFA9A361B9}"/>
+          </ac:spMkLst>
+        </pc:spChg>
+        <pc:spChg chg="mod">
+          <ac:chgData name="zhi zhang" userId="36bdf691fd3510be" providerId="LiveId" clId="{5BC97996-095E-49A7-A797-DB2E422DD13D}" dt="2025-05-09T00:53:36.595" v="2064" actId="1036"/>
+          <ac:spMkLst>
+            <pc:docMk/>
+            <pc:sldMk cId="182683393" sldId="272"/>
+            <ac:spMk id="7" creationId="{75E0A5E3-B5A7-40C6-9FE8-508ABF9E1458}"/>
+          </ac:spMkLst>
+        </pc:spChg>
+      </pc:sldChg>
+      <pc:sldChg chg="modSp mod modNotesTx">
+        <pc:chgData name="zhi zhang" userId="36bdf691fd3510be" providerId="LiveId" clId="{5BC97996-095E-49A7-A797-DB2E422DD13D}" dt="2025-05-12T05:11:15.957" v="8918" actId="20577"/>
+        <pc:sldMkLst>
+          <pc:docMk/>
+          <pc:sldMk cId="1836985979" sldId="386"/>
+        </pc:sldMkLst>
+        <pc:spChg chg="mod">
+          <ac:chgData name="zhi zhang" userId="36bdf691fd3510be" providerId="LiveId" clId="{5BC97996-095E-49A7-A797-DB2E422DD13D}" dt="2025-05-08T07:29:00.602" v="748" actId="20577"/>
+          <ac:spMkLst>
+            <pc:docMk/>
+            <pc:sldMk cId="1836985979" sldId="386"/>
+            <ac:spMk id="3" creationId="{BF67693E-A48F-4F32-8586-A906B0CE6024}"/>
+          </ac:spMkLst>
+        </pc:spChg>
+      </pc:sldChg>
+      <pc:sldChg chg="modSp mod modNotesTx">
+        <pc:chgData name="zhi zhang" userId="36bdf691fd3510be" providerId="LiveId" clId="{5BC97996-095E-49A7-A797-DB2E422DD13D}" dt="2025-05-12T01:53:07.069" v="6843" actId="20577"/>
+        <pc:sldMkLst>
+          <pc:docMk/>
+          <pc:sldMk cId="1629619534" sldId="388"/>
+        </pc:sldMkLst>
+        <pc:spChg chg="mod">
+          <ac:chgData name="zhi zhang" userId="36bdf691fd3510be" providerId="LiveId" clId="{5BC97996-095E-49A7-A797-DB2E422DD13D}" dt="2025-05-12T01:53:07.069" v="6843" actId="20577"/>
+          <ac:spMkLst>
+            <pc:docMk/>
+            <pc:sldMk cId="1629619534" sldId="388"/>
+            <ac:spMk id="3" creationId="{13DB3674-2D4B-8645-8753-8E30E629B377}"/>
+          </ac:spMkLst>
+        </pc:spChg>
+      </pc:sldChg>
+      <pc:sldChg chg="modSp mod modNotesTx">
+        <pc:chgData name="zhi zhang" userId="36bdf691fd3510be" providerId="LiveId" clId="{5BC97996-095E-49A7-A797-DB2E422DD13D}" dt="2025-05-12T05:19:02.866" v="8927" actId="20577"/>
+        <pc:sldMkLst>
+          <pc:docMk/>
+          <pc:sldMk cId="4009072888" sldId="443"/>
+        </pc:sldMkLst>
+        <pc:spChg chg="mod">
+          <ac:chgData name="zhi zhang" userId="36bdf691fd3510be" providerId="LiveId" clId="{5BC97996-095E-49A7-A797-DB2E422DD13D}" dt="2025-05-09T00:53:18.644" v="2043" actId="20577"/>
+          <ac:spMkLst>
+            <pc:docMk/>
+            <pc:sldMk cId="4009072888" sldId="443"/>
+            <ac:spMk id="2" creationId="{5C4F01C5-5333-2248-B03B-703C97F7CC69}"/>
+          </ac:spMkLst>
+        </pc:spChg>
+        <pc:spChg chg="mod">
+          <ac:chgData name="zhi zhang" userId="36bdf691fd3510be" providerId="LiveId" clId="{5BC97996-095E-49A7-A797-DB2E422DD13D}" dt="2025-05-11T14:18:55.798" v="3984" actId="20577"/>
+          <ac:spMkLst>
+            <pc:docMk/>
+            <pc:sldMk cId="4009072888" sldId="443"/>
+            <ac:spMk id="3" creationId="{F7DD7DCB-C7E2-1B4F-BD83-3B7AF005DD76}"/>
+          </ac:spMkLst>
+        </pc:spChg>
+      </pc:sldChg>
+      <pc:sldChg chg="modSp mod">
+        <pc:chgData name="zhi zhang" userId="36bdf691fd3510be" providerId="LiveId" clId="{5BC97996-095E-49A7-A797-DB2E422DD13D}" dt="2025-05-11T15:03:03.565" v="5794" actId="20577"/>
+        <pc:sldMkLst>
+          <pc:docMk/>
+          <pc:sldMk cId="3392029162" sldId="450"/>
+        </pc:sldMkLst>
+        <pc:spChg chg="mod">
+          <ac:chgData name="zhi zhang" userId="36bdf691fd3510be" providerId="LiveId" clId="{5BC97996-095E-49A7-A797-DB2E422DD13D}" dt="2025-05-11T15:03:03.565" v="5794" actId="20577"/>
+          <ac:spMkLst>
+            <pc:docMk/>
+            <pc:sldMk cId="3392029162" sldId="450"/>
+            <ac:spMk id="7" creationId="{75E0A5E3-B5A7-40C6-9FE8-508ABF9E1458}"/>
+          </ac:spMkLst>
+        </pc:spChg>
+      </pc:sldChg>
+      <pc:sldChg chg="modSp mod">
+        <pc:chgData name="zhi zhang" userId="36bdf691fd3510be" providerId="LiveId" clId="{5BC97996-095E-49A7-A797-DB2E422DD13D}" dt="2025-05-12T05:34:12.654" v="9142" actId="20577"/>
+        <pc:sldMkLst>
+          <pc:docMk/>
+          <pc:sldMk cId="3890419788" sldId="451"/>
+        </pc:sldMkLst>
+        <pc:spChg chg="mod">
+          <ac:chgData name="zhi zhang" userId="36bdf691fd3510be" providerId="LiveId" clId="{5BC97996-095E-49A7-A797-DB2E422DD13D}" dt="2025-05-12T05:34:12.654" v="9142" actId="20577"/>
+          <ac:spMkLst>
+            <pc:docMk/>
+            <pc:sldMk cId="3890419788" sldId="451"/>
+            <ac:spMk id="7" creationId="{75E0A5E3-B5A7-40C6-9FE8-508ABF9E1458}"/>
+          </ac:spMkLst>
+        </pc:spChg>
+      </pc:sldChg>
+      <pc:sldChg chg="modSp mod modNotesTx">
+        <pc:chgData name="zhi zhang" userId="36bdf691fd3510be" providerId="LiveId" clId="{5BC97996-095E-49A7-A797-DB2E422DD13D}" dt="2025-05-12T05:37:10.642" v="9157" actId="20577"/>
+        <pc:sldMkLst>
+          <pc:docMk/>
+          <pc:sldMk cId="3667523257" sldId="452"/>
+        </pc:sldMkLst>
+        <pc:spChg chg="mod">
+          <ac:chgData name="zhi zhang" userId="36bdf691fd3510be" providerId="LiveId" clId="{5BC97996-095E-49A7-A797-DB2E422DD13D}" dt="2025-05-12T05:37:10.642" v="9157" actId="20577"/>
+          <ac:spMkLst>
+            <pc:docMk/>
+            <pc:sldMk cId="3667523257" sldId="452"/>
+            <ac:spMk id="7" creationId="{75E0A5E3-B5A7-40C6-9FE8-508ABF9E1458}"/>
+          </ac:spMkLst>
+        </pc:spChg>
+      </pc:sldChg>
+      <pc:sldChg chg="modSp mod modNotesTx">
+        <pc:chgData name="zhi zhang" userId="36bdf691fd3510be" providerId="LiveId" clId="{5BC97996-095E-49A7-A797-DB2E422DD13D}" dt="2025-05-11T15:08:26.375" v="5811" actId="20577"/>
+        <pc:sldMkLst>
+          <pc:docMk/>
+          <pc:sldMk cId="3592248448" sldId="453"/>
+        </pc:sldMkLst>
+        <pc:spChg chg="mod">
+          <ac:chgData name="zhi zhang" userId="36bdf691fd3510be" providerId="LiveId" clId="{5BC97996-095E-49A7-A797-DB2E422DD13D}" dt="2025-05-10T07:47:33.098" v="2378" actId="20577"/>
+          <ac:spMkLst>
+            <pc:docMk/>
+            <pc:sldMk cId="3592248448" sldId="453"/>
+            <ac:spMk id="7" creationId="{75E0A5E3-B5A7-40C6-9FE8-508ABF9E1458}"/>
+          </ac:spMkLst>
+        </pc:spChg>
+      </pc:sldChg>
+      <pc:sldChg chg="ord">
+        <pc:chgData name="zhi zhang" userId="36bdf691fd3510be" providerId="LiveId" clId="{5BC97996-095E-49A7-A797-DB2E422DD13D}" dt="2025-05-12T01:03:38.021" v="5814" actId="20578"/>
+        <pc:sldMkLst>
+          <pc:docMk/>
+          <pc:sldMk cId="110243109" sldId="454"/>
+        </pc:sldMkLst>
+      </pc:sldChg>
+      <pc:sldChg chg="modSp mod modNotesTx">
+        <pc:chgData name="zhi zhang" userId="36bdf691fd3510be" providerId="LiveId" clId="{5BC97996-095E-49A7-A797-DB2E422DD13D}" dt="2025-05-12T01:23:08.076" v="6335" actId="20577"/>
+        <pc:sldMkLst>
+          <pc:docMk/>
+          <pc:sldMk cId="2414964948" sldId="455"/>
+        </pc:sldMkLst>
+        <pc:spChg chg="mod">
+          <ac:chgData name="zhi zhang" userId="36bdf691fd3510be" providerId="LiveId" clId="{5BC97996-095E-49A7-A797-DB2E422DD13D}" dt="2025-05-12T01:23:08.076" v="6335" actId="20577"/>
+          <ac:spMkLst>
+            <pc:docMk/>
+            <pc:sldMk cId="2414964948" sldId="455"/>
+            <ac:spMk id="7" creationId="{75E0A5E3-B5A7-40C6-9FE8-508ABF9E1458}"/>
+          </ac:spMkLst>
+        </pc:spChg>
+      </pc:sldChg>
+      <pc:sldChg chg="modNotesTx">
+        <pc:chgData name="zhi zhang" userId="36bdf691fd3510be" providerId="LiveId" clId="{5BC97996-095E-49A7-A797-DB2E422DD13D}" dt="2025-05-12T01:24:23.532" v="6383" actId="20577"/>
+        <pc:sldMkLst>
+          <pc:docMk/>
+          <pc:sldMk cId="1468594782" sldId="456"/>
+        </pc:sldMkLst>
+      </pc:sldChg>
+      <pc:sldChg chg="addSp delSp modSp mod modNotesTx">
+        <pc:chgData name="zhi zhang" userId="36bdf691fd3510be" providerId="LiveId" clId="{5BC97996-095E-49A7-A797-DB2E422DD13D}" dt="2025-05-11T00:53:34.058" v="3539" actId="20577"/>
+        <pc:sldMkLst>
+          <pc:docMk/>
+          <pc:sldMk cId="3535288268" sldId="457"/>
+        </pc:sldMkLst>
+        <pc:spChg chg="add del">
+          <ac:chgData name="zhi zhang" userId="36bdf691fd3510be" providerId="LiveId" clId="{5BC97996-095E-49A7-A797-DB2E422DD13D}" dt="2025-05-10T12:18:07.715" v="3223" actId="478"/>
+          <ac:spMkLst>
+            <pc:docMk/>
+            <pc:sldMk cId="3535288268" sldId="457"/>
+            <ac:spMk id="5" creationId="{212FFFC4-E00C-455E-BA6A-697EE9560C2D}"/>
+          </ac:spMkLst>
+        </pc:spChg>
+        <pc:spChg chg="mod">
+          <ac:chgData name="zhi zhang" userId="36bdf691fd3510be" providerId="LiveId" clId="{5BC97996-095E-49A7-A797-DB2E422DD13D}" dt="2025-05-11T00:53:34.058" v="3539" actId="20577"/>
+          <ac:spMkLst>
+            <pc:docMk/>
+            <pc:sldMk cId="3535288268" sldId="457"/>
+            <ac:spMk id="7" creationId="{75E0A5E3-B5A7-40C6-9FE8-508ABF9E1458}"/>
+          </ac:spMkLst>
+        </pc:spChg>
+        <pc:picChg chg="mod">
+          <ac:chgData name="zhi zhang" userId="36bdf691fd3510be" providerId="LiveId" clId="{5BC97996-095E-49A7-A797-DB2E422DD13D}" dt="2025-05-10T12:18:07.242" v="3222" actId="1076"/>
+          <ac:picMkLst>
+            <pc:docMk/>
+            <pc:sldMk cId="3535288268" sldId="457"/>
+            <ac:picMk id="1026" creationId="{91BB2D63-9A43-4A70-94A6-83ACD9DA0AEE}"/>
+          </ac:picMkLst>
+        </pc:picChg>
+      </pc:sldChg>
+      <pc:sldChg chg="modSp mod modNotesTx">
+        <pc:chgData name="zhi zhang" userId="36bdf691fd3510be" providerId="LiveId" clId="{5BC97996-095E-49A7-A797-DB2E422DD13D}" dt="2025-05-12T01:34:34.660" v="6565"/>
+        <pc:sldMkLst>
+          <pc:docMk/>
+          <pc:sldMk cId="2410610366" sldId="459"/>
+        </pc:sldMkLst>
+        <pc:spChg chg="mod">
+          <ac:chgData name="zhi zhang" userId="36bdf691fd3510be" providerId="LiveId" clId="{5BC97996-095E-49A7-A797-DB2E422DD13D}" dt="2025-05-10T08:03:26.083" v="2551" actId="20577"/>
+          <ac:spMkLst>
+            <pc:docMk/>
+            <pc:sldMk cId="2410610366" sldId="459"/>
+            <ac:spMk id="3" creationId="{13DB3674-2D4B-8645-8753-8E30E629B377}"/>
+          </ac:spMkLst>
+        </pc:spChg>
+      </pc:sldChg>
+      <pc:sldChg chg="modSp mod modNotesTx">
+        <pc:chgData name="zhi zhang" userId="36bdf691fd3510be" providerId="LiveId" clId="{5BC97996-095E-49A7-A797-DB2E422DD13D}" dt="2025-05-12T01:39:23.792" v="6791" actId="313"/>
+        <pc:sldMkLst>
+          <pc:docMk/>
+          <pc:sldMk cId="1436142334" sldId="460"/>
+        </pc:sldMkLst>
+        <pc:spChg chg="mod">
+          <ac:chgData name="zhi zhang" userId="36bdf691fd3510be" providerId="LiveId" clId="{5BC97996-095E-49A7-A797-DB2E422DD13D}" dt="2025-05-10T08:05:08.392" v="2564" actId="20577"/>
+          <ac:spMkLst>
+            <pc:docMk/>
+            <pc:sldMk cId="1436142334" sldId="460"/>
+            <ac:spMk id="3" creationId="{13DB3674-2D4B-8645-8753-8E30E629B377}"/>
+          </ac:spMkLst>
+        </pc:spChg>
+      </pc:sldChg>
+      <pc:sldChg chg="modSp mod modNotesTx">
+        <pc:chgData name="zhi zhang" userId="36bdf691fd3510be" providerId="LiveId" clId="{5BC97996-095E-49A7-A797-DB2E422DD13D}" dt="2025-05-11T15:02:05.760" v="5782" actId="20577"/>
+        <pc:sldMkLst>
+          <pc:docMk/>
+          <pc:sldMk cId="3626462958" sldId="461"/>
+        </pc:sldMkLst>
+        <pc:spChg chg="mod">
+          <ac:chgData name="zhi zhang" userId="36bdf691fd3510be" providerId="LiveId" clId="{5BC97996-095E-49A7-A797-DB2E422DD13D}" dt="2025-05-11T15:02:05.760" v="5782" actId="20577"/>
+          <ac:spMkLst>
+            <pc:docMk/>
+            <pc:sldMk cId="3626462958" sldId="461"/>
+            <ac:spMk id="7" creationId="{75E0A5E3-B5A7-40C6-9FE8-508ABF9E1458}"/>
+          </ac:spMkLst>
+        </pc:spChg>
+      </pc:sldChg>
+      <pc:sldChg chg="modSp mod">
+        <pc:chgData name="zhi zhang" userId="36bdf691fd3510be" providerId="LiveId" clId="{5BC97996-095E-49A7-A797-DB2E422DD13D}" dt="2025-05-12T05:37:21.084" v="9175" actId="14100"/>
+        <pc:sldMkLst>
+          <pc:docMk/>
+          <pc:sldMk cId="1628170773" sldId="462"/>
+        </pc:sldMkLst>
+        <pc:spChg chg="mod">
+          <ac:chgData name="zhi zhang" userId="36bdf691fd3510be" providerId="LiveId" clId="{5BC97996-095E-49A7-A797-DB2E422DD13D}" dt="2025-05-12T05:37:21.084" v="9175" actId="14100"/>
+          <ac:spMkLst>
+            <pc:docMk/>
+            <pc:sldMk cId="1628170773" sldId="462"/>
+            <ac:spMk id="7" creationId="{75E0A5E3-B5A7-40C6-9FE8-508ABF9E1458}"/>
+          </ac:spMkLst>
+        </pc:spChg>
+      </pc:sldChg>
+      <pc:sldChg chg="modSp mod modNotesTx">
+        <pc:chgData name="zhi zhang" userId="36bdf691fd3510be" providerId="LiveId" clId="{5BC97996-095E-49A7-A797-DB2E422DD13D}" dt="2025-05-10T07:49:02.156" v="2406" actId="20577"/>
+        <pc:sldMkLst>
+          <pc:docMk/>
+          <pc:sldMk cId="3533530707" sldId="463"/>
+        </pc:sldMkLst>
+        <pc:spChg chg="mod">
+          <ac:chgData name="zhi zhang" userId="36bdf691fd3510be" providerId="LiveId" clId="{5BC97996-095E-49A7-A797-DB2E422DD13D}" dt="2025-05-10T07:48:50.616" v="2405" actId="20577"/>
+          <ac:spMkLst>
+            <pc:docMk/>
+            <pc:sldMk cId="3533530707" sldId="463"/>
+            <ac:spMk id="7" creationId="{75E0A5E3-B5A7-40C6-9FE8-508ABF9E1458}"/>
+          </ac:spMkLst>
+        </pc:spChg>
+      </pc:sldChg>
+      <pc:sldChg chg="modNotesTx">
+        <pc:chgData name="zhi zhang" userId="36bdf691fd3510be" providerId="LiveId" clId="{5BC97996-095E-49A7-A797-DB2E422DD13D}" dt="2025-05-12T01:09:12.901" v="6271" actId="20577"/>
+        <pc:sldMkLst>
+          <pc:docMk/>
+          <pc:sldMk cId="1690056961" sldId="464"/>
+        </pc:sldMkLst>
+      </pc:sldChg>
+      <pc:sldChg chg="modNotesTx">
+        <pc:chgData name="zhi zhang" userId="36bdf691fd3510be" providerId="LiveId" clId="{5BC97996-095E-49A7-A797-DB2E422DD13D}" dt="2025-05-12T01:10:53.504" v="6333" actId="20577"/>
+        <pc:sldMkLst>
+          <pc:docMk/>
+          <pc:sldMk cId="1462745473" sldId="466"/>
+        </pc:sldMkLst>
+      </pc:sldChg>
+      <pc:sldChg chg="modSp mod">
+        <pc:chgData name="zhi zhang" userId="36bdf691fd3510be" providerId="LiveId" clId="{5BC97996-095E-49A7-A797-DB2E422DD13D}" dt="2025-05-12T01:23:36.280" v="6345" actId="20577"/>
+        <pc:sldMkLst>
+          <pc:docMk/>
+          <pc:sldMk cId="2017251195" sldId="468"/>
+        </pc:sldMkLst>
+        <pc:spChg chg="mod">
+          <ac:chgData name="zhi zhang" userId="36bdf691fd3510be" providerId="LiveId" clId="{5BC97996-095E-49A7-A797-DB2E422DD13D}" dt="2025-05-12T01:23:36.280" v="6345" actId="20577"/>
+          <ac:spMkLst>
+            <pc:docMk/>
+            <pc:sldMk cId="2017251195" sldId="468"/>
+            <ac:spMk id="7" creationId="{75E0A5E3-B5A7-40C6-9FE8-508ABF9E1458}"/>
+          </ac:spMkLst>
+        </pc:spChg>
+      </pc:sldChg>
+      <pc:sldChg chg="modSp del mod">
+        <pc:chgData name="zhi zhang" userId="36bdf691fd3510be" providerId="LiveId" clId="{5BC97996-095E-49A7-A797-DB2E422DD13D}" dt="2025-05-12T01:52:06.056" v="6799" actId="2696"/>
+        <pc:sldMkLst>
+          <pc:docMk/>
+          <pc:sldMk cId="500213869" sldId="472"/>
+        </pc:sldMkLst>
+        <pc:spChg chg="mod">
+          <ac:chgData name="zhi zhang" userId="36bdf691fd3510be" providerId="LiveId" clId="{5BC97996-095E-49A7-A797-DB2E422DD13D}" dt="2025-05-10T08:05:36.714" v="2570" actId="20577"/>
+          <ac:spMkLst>
+            <pc:docMk/>
+            <pc:sldMk cId="500213869" sldId="472"/>
+            <ac:spMk id="3" creationId="{13DB3674-2D4B-8645-8753-8E30E629B377}"/>
+          </ac:spMkLst>
+        </pc:spChg>
+      </pc:sldChg>
+      <pc:sldChg chg="modSp mod modNotesTx">
+        <pc:chgData name="zhi zhang" userId="36bdf691fd3510be" providerId="LiveId" clId="{5BC97996-095E-49A7-A797-DB2E422DD13D}" dt="2025-05-12T01:50:18.922" v="6797" actId="20577"/>
+        <pc:sldMkLst>
+          <pc:docMk/>
+          <pc:sldMk cId="4283821982" sldId="473"/>
+        </pc:sldMkLst>
+        <pc:spChg chg="mod">
+          <ac:chgData name="zhi zhang" userId="36bdf691fd3510be" providerId="LiveId" clId="{5BC97996-095E-49A7-A797-DB2E422DD13D}" dt="2025-05-12T01:50:18.922" v="6797" actId="20577"/>
+          <ac:spMkLst>
+            <pc:docMk/>
+            <pc:sldMk cId="4283821982" sldId="473"/>
+            <ac:spMk id="3" creationId="{13DB3674-2D4B-8645-8753-8E30E629B377}"/>
+          </ac:spMkLst>
+        </pc:spChg>
+      </pc:sldChg>
+      <pc:sldChg chg="modSp del mod">
+        <pc:chgData name="zhi zhang" userId="36bdf691fd3510be" providerId="LiveId" clId="{5BC97996-095E-49A7-A797-DB2E422DD13D}" dt="2025-05-12T01:52:02.216" v="6798" actId="2696"/>
+        <pc:sldMkLst>
+          <pc:docMk/>
+          <pc:sldMk cId="1636182554" sldId="474"/>
+        </pc:sldMkLst>
+        <pc:spChg chg="mod">
+          <ac:chgData name="zhi zhang" userId="36bdf691fd3510be" providerId="LiveId" clId="{5BC97996-095E-49A7-A797-DB2E422DD13D}" dt="2025-05-10T08:05:42.607" v="2575" actId="20577"/>
+          <ac:spMkLst>
+            <pc:docMk/>
+            <pc:sldMk cId="1636182554" sldId="474"/>
+            <ac:spMk id="3" creationId="{13DB3674-2D4B-8645-8753-8E30E629B377}"/>
+          </ac:spMkLst>
+        </pc:spChg>
+      </pc:sldChg>
+      <pc:sldChg chg="modNotesTx">
+        <pc:chgData name="zhi zhang" userId="36bdf691fd3510be" providerId="LiveId" clId="{5BC97996-095E-49A7-A797-DB2E422DD13D}" dt="2025-05-12T01:56:26.874" v="6946" actId="20577"/>
+        <pc:sldMkLst>
+          <pc:docMk/>
+          <pc:sldMk cId="3151914030" sldId="475"/>
+        </pc:sldMkLst>
+      </pc:sldChg>
+      <pc:sldChg chg="modNotesTx">
+        <pc:chgData name="zhi zhang" userId="36bdf691fd3510be" providerId="LiveId" clId="{5BC97996-095E-49A7-A797-DB2E422DD13D}" dt="2025-05-12T01:58:21.270" v="6990" actId="20577"/>
+        <pc:sldMkLst>
+          <pc:docMk/>
+          <pc:sldMk cId="97459469" sldId="476"/>
+        </pc:sldMkLst>
+      </pc:sldChg>
+      <pc:sldChg chg="modNotesTx">
+        <pc:chgData name="zhi zhang" userId="36bdf691fd3510be" providerId="LiveId" clId="{5BC97996-095E-49A7-A797-DB2E422DD13D}" dt="2025-05-12T02:01:31.877" v="7274" actId="20577"/>
+        <pc:sldMkLst>
+          <pc:docMk/>
+          <pc:sldMk cId="4015799420" sldId="478"/>
+        </pc:sldMkLst>
+      </pc:sldChg>
+      <pc:sldChg chg="modNotesTx">
+        <pc:chgData name="zhi zhang" userId="36bdf691fd3510be" providerId="LiveId" clId="{5BC97996-095E-49A7-A797-DB2E422DD13D}" dt="2025-05-12T02:02:17.697" v="7275" actId="20577"/>
+        <pc:sldMkLst>
+          <pc:docMk/>
+          <pc:sldMk cId="3022655673" sldId="479"/>
+        </pc:sldMkLst>
+      </pc:sldChg>
+      <pc:sldChg chg="modSp mod">
+        <pc:chgData name="zhi zhang" userId="36bdf691fd3510be" providerId="LiveId" clId="{5BC97996-095E-49A7-A797-DB2E422DD13D}" dt="2025-05-12T05:33:26.603" v="9140" actId="20577"/>
+        <pc:sldMkLst>
+          <pc:docMk/>
+          <pc:sldMk cId="214179768" sldId="480"/>
+        </pc:sldMkLst>
+        <pc:spChg chg="mod">
+          <ac:chgData name="zhi zhang" userId="36bdf691fd3510be" providerId="LiveId" clId="{5BC97996-095E-49A7-A797-DB2E422DD13D}" dt="2025-05-12T05:33:26.603" v="9140" actId="20577"/>
+          <ac:spMkLst>
+            <pc:docMk/>
+            <pc:sldMk cId="214179768" sldId="480"/>
+            <ac:spMk id="7" creationId="{75E0A5E3-B5A7-40C6-9FE8-508ABF9E1458}"/>
+          </ac:spMkLst>
+        </pc:spChg>
+      </pc:sldChg>
+      <pc:sldChg chg="modNotesTx">
+        <pc:chgData name="zhi zhang" userId="36bdf691fd3510be" providerId="LiveId" clId="{5BC97996-095E-49A7-A797-DB2E422DD13D}" dt="2025-05-12T01:05:42.344" v="5926" actId="20577"/>
+        <pc:sldMkLst>
+          <pc:docMk/>
+          <pc:sldMk cId="2857348335" sldId="481"/>
+        </pc:sldMkLst>
+      </pc:sldChg>
+      <pc:sldChg chg="modSp mod">
+        <pc:chgData name="zhi zhang" userId="36bdf691fd3510be" providerId="LiveId" clId="{5BC97996-095E-49A7-A797-DB2E422DD13D}" dt="2025-05-10T08:05:05.031" v="2563" actId="20577"/>
+        <pc:sldMkLst>
+          <pc:docMk/>
+          <pc:sldMk cId="3101025385" sldId="483"/>
+        </pc:sldMkLst>
+        <pc:spChg chg="mod">
+          <ac:chgData name="zhi zhang" userId="36bdf691fd3510be" providerId="LiveId" clId="{5BC97996-095E-49A7-A797-DB2E422DD13D}" dt="2025-05-10T08:05:05.031" v="2563" actId="20577"/>
+          <ac:spMkLst>
+            <pc:docMk/>
+            <pc:sldMk cId="3101025385" sldId="483"/>
+            <ac:spMk id="3" creationId="{13DB3674-2D4B-8645-8753-8E30E629B377}"/>
+          </ac:spMkLst>
+        </pc:spChg>
+      </pc:sldChg>
+      <pc:sldChg chg="modSp mod">
+        <pc:chgData name="zhi zhang" userId="36bdf691fd3510be" providerId="LiveId" clId="{5BC97996-095E-49A7-A797-DB2E422DD13D}" dt="2025-05-12T01:55:33.297" v="6844" actId="20577"/>
+        <pc:sldMkLst>
+          <pc:docMk/>
+          <pc:sldMk cId="1375948752" sldId="484"/>
+        </pc:sldMkLst>
+        <pc:spChg chg="mod">
+          <ac:chgData name="zhi zhang" userId="36bdf691fd3510be" providerId="LiveId" clId="{5BC97996-095E-49A7-A797-DB2E422DD13D}" dt="2025-05-12T01:55:33.297" v="6844" actId="20577"/>
+          <ac:spMkLst>
+            <pc:docMk/>
+            <pc:sldMk cId="1375948752" sldId="484"/>
+            <ac:spMk id="3" creationId="{13DB3674-2D4B-8645-8753-8E30E629B377}"/>
+          </ac:spMkLst>
+        </pc:spChg>
+      </pc:sldChg>
+      <pc:sldChg chg="addSp delSp modSp mod modNotesTx">
+        <pc:chgData name="zhi zhang" userId="36bdf691fd3510be" providerId="LiveId" clId="{5BC97996-095E-49A7-A797-DB2E422DD13D}" dt="2025-05-12T02:18:58.660" v="7734" actId="20577"/>
+        <pc:sldMkLst>
+          <pc:docMk/>
+          <pc:sldMk cId="2649076992" sldId="544"/>
+        </pc:sldMkLst>
+        <pc:spChg chg="del">
+          <ac:chgData name="zhi zhang" userId="36bdf691fd3510be" providerId="LiveId" clId="{5BC97996-095E-49A7-A797-DB2E422DD13D}" dt="2025-05-12T02:11:04.788" v="7439" actId="478"/>
+          <ac:spMkLst>
+            <pc:docMk/>
+            <pc:sldMk cId="2649076992" sldId="544"/>
+            <ac:spMk id="6" creationId="{69F92E9A-2B5F-4177-93B9-09916C3328E6}"/>
+          </ac:spMkLst>
+        </pc:spChg>
+        <pc:spChg chg="del">
+          <ac:chgData name="zhi zhang" userId="36bdf691fd3510be" providerId="LiveId" clId="{5BC97996-095E-49A7-A797-DB2E422DD13D}" dt="2025-05-12T02:11:04.788" v="7439" actId="478"/>
+          <ac:spMkLst>
+            <pc:docMk/>
+            <pc:sldMk cId="2649076992" sldId="544"/>
+            <ac:spMk id="7" creationId="{BEB55EFD-BA53-450C-B6F4-2FD9BCBB61F7}"/>
+          </ac:spMkLst>
+        </pc:spChg>
+        <pc:spChg chg="del">
+          <ac:chgData name="zhi zhang" userId="36bdf691fd3510be" providerId="LiveId" clId="{5BC97996-095E-49A7-A797-DB2E422DD13D}" dt="2025-05-12T02:11:04.788" v="7439" actId="478"/>
+          <ac:spMkLst>
+            <pc:docMk/>
+            <pc:sldMk cId="2649076992" sldId="544"/>
+            <ac:spMk id="8" creationId="{5124B453-7009-4E27-A9F3-CF3B5E9C1FF0}"/>
+          </ac:spMkLst>
+        </pc:spChg>
+        <pc:spChg chg="del">
+          <ac:chgData name="zhi zhang" userId="36bdf691fd3510be" providerId="LiveId" clId="{5BC97996-095E-49A7-A797-DB2E422DD13D}" dt="2025-05-12T02:11:04.788" v="7439" actId="478"/>
+          <ac:spMkLst>
+            <pc:docMk/>
+            <pc:sldMk cId="2649076992" sldId="544"/>
+            <ac:spMk id="9" creationId="{2E47447F-9D1D-4119-9AC1-89A76461C26E}"/>
+          </ac:spMkLst>
+        </pc:spChg>
+        <pc:spChg chg="del">
+          <ac:chgData name="zhi zhang" userId="36bdf691fd3510be" providerId="LiveId" clId="{5BC97996-095E-49A7-A797-DB2E422DD13D}" dt="2025-05-12T02:11:04.788" v="7439" actId="478"/>
+          <ac:spMkLst>
+            <pc:docMk/>
+            <pc:sldMk cId="2649076992" sldId="544"/>
+            <ac:spMk id="10" creationId="{19F88072-7B73-4C39-85C6-1A390ED9D829}"/>
+          </ac:spMkLst>
+        </pc:spChg>
+        <pc:spChg chg="del">
+          <ac:chgData name="zhi zhang" userId="36bdf691fd3510be" providerId="LiveId" clId="{5BC97996-095E-49A7-A797-DB2E422DD13D}" dt="2025-05-12T02:11:04.788" v="7439" actId="478"/>
+          <ac:spMkLst>
+            <pc:docMk/>
+            <pc:sldMk cId="2649076992" sldId="544"/>
+            <ac:spMk id="12" creationId="{18FA6537-F0CE-44FE-A425-10E0BFC96171}"/>
+          </ac:spMkLst>
+        </pc:spChg>
+        <pc:spChg chg="del">
+          <ac:chgData name="zhi zhang" userId="36bdf691fd3510be" providerId="LiveId" clId="{5BC97996-095E-49A7-A797-DB2E422DD13D}" dt="2025-05-12T02:11:04.788" v="7439" actId="478"/>
+          <ac:spMkLst>
+            <pc:docMk/>
+            <pc:sldMk cId="2649076992" sldId="544"/>
+            <ac:spMk id="13" creationId="{84915FF7-F2B6-4F8F-987F-6E6AE8782CB9}"/>
+          </ac:spMkLst>
+        </pc:spChg>
+        <pc:spChg chg="del">
+          <ac:chgData name="zhi zhang" userId="36bdf691fd3510be" providerId="LiveId" clId="{5BC97996-095E-49A7-A797-DB2E422DD13D}" dt="2025-05-12T02:11:04.788" v="7439" actId="478"/>
+          <ac:spMkLst>
+            <pc:docMk/>
+            <pc:sldMk cId="2649076992" sldId="544"/>
+            <ac:spMk id="14" creationId="{6893BAD6-018F-4A85-AE18-DB743550469F}"/>
+          </ac:spMkLst>
+        </pc:spChg>
+        <pc:spChg chg="del">
+          <ac:chgData name="zhi zhang" userId="36bdf691fd3510be" providerId="LiveId" clId="{5BC97996-095E-49A7-A797-DB2E422DD13D}" dt="2025-05-12T02:11:04.788" v="7439" actId="478"/>
+          <ac:spMkLst>
+            <pc:docMk/>
+            <pc:sldMk cId="2649076992" sldId="544"/>
+            <ac:spMk id="15" creationId="{0ABB9AB2-8480-4BB4-9570-B265C933A8FD}"/>
+          </ac:spMkLst>
+        </pc:spChg>
+        <pc:spChg chg="del">
+          <ac:chgData name="zhi zhang" userId="36bdf691fd3510be" providerId="LiveId" clId="{5BC97996-095E-49A7-A797-DB2E422DD13D}" dt="2025-05-12T02:11:04.788" v="7439" actId="478"/>
+          <ac:spMkLst>
+            <pc:docMk/>
+            <pc:sldMk cId="2649076992" sldId="544"/>
+            <ac:spMk id="16" creationId="{4D8EB549-C67B-4E5F-AE5A-E138D56FAB02}"/>
+          </ac:spMkLst>
+        </pc:spChg>
+        <pc:spChg chg="del">
+          <ac:chgData name="zhi zhang" userId="36bdf691fd3510be" providerId="LiveId" clId="{5BC97996-095E-49A7-A797-DB2E422DD13D}" dt="2025-05-12T02:11:04.788" v="7439" actId="478"/>
+          <ac:spMkLst>
+            <pc:docMk/>
+            <pc:sldMk cId="2649076992" sldId="544"/>
+            <ac:spMk id="17" creationId="{D8F6E3F1-1584-4907-914A-09F741A77C52}"/>
+          </ac:spMkLst>
+        </pc:spChg>
+        <pc:spChg chg="del">
+          <ac:chgData name="zhi zhang" userId="36bdf691fd3510be" providerId="LiveId" clId="{5BC97996-095E-49A7-A797-DB2E422DD13D}" dt="2025-05-12T02:11:04.788" v="7439" actId="478"/>
+          <ac:spMkLst>
+            <pc:docMk/>
+            <pc:sldMk cId="2649076992" sldId="544"/>
+            <ac:spMk id="18" creationId="{AF641BBD-1AE1-4473-A3CD-89545BCB14F4}"/>
+          </ac:spMkLst>
+        </pc:spChg>
+        <pc:spChg chg="del">
+          <ac:chgData name="zhi zhang" userId="36bdf691fd3510be" providerId="LiveId" clId="{5BC97996-095E-49A7-A797-DB2E422DD13D}" dt="2025-05-12T02:11:04.788" v="7439" actId="478"/>
+          <ac:spMkLst>
+            <pc:docMk/>
+            <pc:sldMk cId="2649076992" sldId="544"/>
+            <ac:spMk id="19" creationId="{566A02E2-2EBE-43BF-B9BB-09D39BA01D4C}"/>
+          </ac:spMkLst>
+        </pc:spChg>
+        <pc:spChg chg="del">
+          <ac:chgData name="zhi zhang" userId="36bdf691fd3510be" providerId="LiveId" clId="{5BC97996-095E-49A7-A797-DB2E422DD13D}" dt="2025-05-12T02:11:04.788" v="7439" actId="478"/>
+          <ac:spMkLst>
+            <pc:docMk/>
+            <pc:sldMk cId="2649076992" sldId="544"/>
+            <ac:spMk id="20" creationId="{7DC8C79B-E10D-4AB0-A536-84D4932177A4}"/>
+          </ac:spMkLst>
+        </pc:spChg>
+        <pc:spChg chg="del">
+          <ac:chgData name="zhi zhang" userId="36bdf691fd3510be" providerId="LiveId" clId="{5BC97996-095E-49A7-A797-DB2E422DD13D}" dt="2025-05-12T02:11:04.788" v="7439" actId="478"/>
+          <ac:spMkLst>
+            <pc:docMk/>
+            <pc:sldMk cId="2649076992" sldId="544"/>
+            <ac:spMk id="21" creationId="{AD2BE259-8E32-49BB-8B6F-073A6E8E5732}"/>
+          </ac:spMkLst>
+        </pc:spChg>
+        <pc:spChg chg="add mod">
+          <ac:chgData name="zhi zhang" userId="36bdf691fd3510be" providerId="LiveId" clId="{5BC97996-095E-49A7-A797-DB2E422DD13D}" dt="2025-05-12T02:17:22.509" v="7482" actId="404"/>
+          <ac:spMkLst>
+            <pc:docMk/>
+            <pc:sldMk cId="2649076992" sldId="544"/>
+            <ac:spMk id="24" creationId="{250C0F0F-822B-4337-9AF3-C49E4E825FB1}"/>
+          </ac:spMkLst>
+        </pc:spChg>
+        <pc:picChg chg="ord">
+          <ac:chgData name="zhi zhang" userId="36bdf691fd3510be" providerId="LiveId" clId="{5BC97996-095E-49A7-A797-DB2E422DD13D}" dt="2025-05-12T02:11:25.411" v="7447" actId="166"/>
+          <ac:picMkLst>
+            <pc:docMk/>
+            <pc:sldMk cId="2649076992" sldId="544"/>
+            <ac:picMk id="4" creationId="{07BA7B64-6AF9-4C08-AAEF-1353B9D28CB3}"/>
+          </ac:picMkLst>
+        </pc:picChg>
+        <pc:picChg chg="add del">
+          <ac:chgData name="zhi zhang" userId="36bdf691fd3510be" providerId="LiveId" clId="{5BC97996-095E-49A7-A797-DB2E422DD13D}" dt="2025-05-12T02:11:01.515" v="7438" actId="478"/>
+          <ac:picMkLst>
+            <pc:docMk/>
+            <pc:sldMk cId="2649076992" sldId="544"/>
+            <ac:picMk id="5" creationId="{5E9D4FAE-9EA5-4927-8F70-E90C243EA17E}"/>
+          </ac:picMkLst>
+        </pc:picChg>
+        <pc:picChg chg="add mod">
+          <ac:chgData name="zhi zhang" userId="36bdf691fd3510be" providerId="LiveId" clId="{5BC97996-095E-49A7-A797-DB2E422DD13D}" dt="2025-05-12T02:11:21.832" v="7446" actId="1076"/>
+          <ac:picMkLst>
+            <pc:docMk/>
+            <pc:sldMk cId="2649076992" sldId="544"/>
+            <ac:picMk id="2050" creationId="{9CE5D691-1CE7-4B11-8A13-D88B3127CD36}"/>
+          </ac:picMkLst>
+        </pc:picChg>
+      </pc:sldChg>
+      <pc:sldChg chg="addSp delSp modSp mod modNotesTx">
+        <pc:chgData name="zhi zhang" userId="36bdf691fd3510be" providerId="LiveId" clId="{5BC97996-095E-49A7-A797-DB2E422DD13D}" dt="2025-05-12T05:55:42.451" v="9191" actId="6549"/>
+        <pc:sldMkLst>
+          <pc:docMk/>
+          <pc:sldMk cId="1827031149" sldId="549"/>
+        </pc:sldMkLst>
+        <pc:picChg chg="del">
+          <ac:chgData name="zhi zhang" userId="36bdf691fd3510be" providerId="LiveId" clId="{5BC97996-095E-49A7-A797-DB2E422DD13D}" dt="2025-05-12T02:06:03.082" v="7305" actId="478"/>
+          <ac:picMkLst>
+            <pc:docMk/>
+            <pc:sldMk cId="1827031149" sldId="549"/>
+            <ac:picMk id="6" creationId="{D3320554-657F-4671-ACBB-D0789B7930CB}"/>
+          </ac:picMkLst>
+        </pc:picChg>
+        <pc:picChg chg="add mod">
+          <ac:chgData name="zhi zhang" userId="36bdf691fd3510be" providerId="LiveId" clId="{5BC97996-095E-49A7-A797-DB2E422DD13D}" dt="2025-05-12T02:06:27.892" v="7312" actId="1076"/>
+          <ac:picMkLst>
+            <pc:docMk/>
+            <pc:sldMk cId="1827031149" sldId="549"/>
+            <ac:picMk id="1026" creationId="{59E29EA4-D58B-42FE-A83E-329DFC32C13E}"/>
+          </ac:picMkLst>
+        </pc:picChg>
+      </pc:sldChg>
+      <pc:sldChg chg="modSp mod">
+        <pc:chgData name="zhi zhang" userId="36bdf691fd3510be" providerId="LiveId" clId="{5BC97996-095E-49A7-A797-DB2E422DD13D}" dt="2025-05-10T08:58:35.431" v="3072" actId="27636"/>
+        <pc:sldMkLst>
+          <pc:docMk/>
+          <pc:sldMk cId="2891692903" sldId="1556"/>
+        </pc:sldMkLst>
+        <pc:spChg chg="mod">
+          <ac:chgData name="zhi zhang" userId="36bdf691fd3510be" providerId="LiveId" clId="{5BC97996-095E-49A7-A797-DB2E422DD13D}" dt="2025-05-10T08:58:35.431" v="3072" actId="27636"/>
+          <ac:spMkLst>
+            <pc:docMk/>
+            <pc:sldMk cId="2891692903" sldId="1556"/>
+            <ac:spMk id="2" creationId="{62B5F79D-16DD-4439-8342-17CBBB22DF56}"/>
+          </ac:spMkLst>
+        </pc:spChg>
+      </pc:sldChg>
+      <pc:sldChg chg="addSp delSp modSp mod modNotesTx">
+        <pc:chgData name="zhi zhang" userId="36bdf691fd3510be" providerId="LiveId" clId="{5BC97996-095E-49A7-A797-DB2E422DD13D}" dt="2025-05-12T05:37:39.709" v="9190" actId="20577"/>
+        <pc:sldMkLst>
+          <pc:docMk/>
+          <pc:sldMk cId="2109811326" sldId="1557"/>
+        </pc:sldMkLst>
+        <pc:spChg chg="add del">
+          <ac:chgData name="zhi zhang" userId="36bdf691fd3510be" providerId="LiveId" clId="{5BC97996-095E-49A7-A797-DB2E422DD13D}" dt="2025-05-10T07:42:11.213" v="2307"/>
+          <ac:spMkLst>
+            <pc:docMk/>
+            <pc:sldMk cId="2109811326" sldId="1557"/>
+            <ac:spMk id="3" creationId="{4EE0BE10-1C0C-4545-AC64-DD4888F4E421}"/>
+          </ac:spMkLst>
+        </pc:spChg>
+        <pc:spChg chg="add del">
+          <ac:chgData name="zhi zhang" userId="36bdf691fd3510be" providerId="LiveId" clId="{5BC97996-095E-49A7-A797-DB2E422DD13D}" dt="2025-05-10T07:42:24.638" v="2312"/>
+          <ac:spMkLst>
+            <pc:docMk/>
+            <pc:sldMk cId="2109811326" sldId="1557"/>
+            <ac:spMk id="4" creationId="{8CFAC18B-3C7C-49DF-8C46-E08781F9D9F4}"/>
+          </ac:spMkLst>
+        </pc:spChg>
+        <pc:spChg chg="mod">
+          <ac:chgData name="zhi zhang" userId="36bdf691fd3510be" providerId="LiveId" clId="{5BC97996-095E-49A7-A797-DB2E422DD13D}" dt="2025-05-12T05:37:39.709" v="9190" actId="20577"/>
+          <ac:spMkLst>
+            <pc:docMk/>
+            <pc:sldMk cId="2109811326" sldId="1557"/>
+            <ac:spMk id="7" creationId="{75E0A5E3-B5A7-40C6-9FE8-508ABF9E1458}"/>
+          </ac:spMkLst>
+        </pc:spChg>
+      </pc:sldChg>
+      <pc:sldChg chg="modNotesTx">
+        <pc:chgData name="zhi zhang" userId="36bdf691fd3510be" providerId="LiveId" clId="{5BC97996-095E-49A7-A797-DB2E422DD13D}" dt="2025-05-11T14:46:43.101" v="5196" actId="20577"/>
+        <pc:sldMkLst>
+          <pc:docMk/>
+          <pc:sldMk cId="967945687" sldId="1558"/>
+        </pc:sldMkLst>
+      </pc:sldChg>
+      <pc:sldChg chg="modSp mod">
+        <pc:chgData name="zhi zhang" userId="36bdf691fd3510be" providerId="LiveId" clId="{5BC97996-095E-49A7-A797-DB2E422DD13D}" dt="2025-05-11T14:46:23.878" v="5164" actId="20577"/>
+        <pc:sldMkLst>
+          <pc:docMk/>
+          <pc:sldMk cId="3427740812" sldId="1559"/>
+        </pc:sldMkLst>
+        <pc:spChg chg="mod">
+          <ac:chgData name="zhi zhang" userId="36bdf691fd3510be" providerId="LiveId" clId="{5BC97996-095E-49A7-A797-DB2E422DD13D}" dt="2025-05-11T14:46:23.878" v="5164" actId="20577"/>
+          <ac:spMkLst>
+            <pc:docMk/>
+            <pc:sldMk cId="3427740812" sldId="1559"/>
+            <ac:spMk id="7" creationId="{75E0A5E3-B5A7-40C6-9FE8-508ABF9E1458}"/>
+          </ac:spMkLst>
+        </pc:spChg>
+      </pc:sldChg>
+      <pc:sldChg chg="modNotesTx">
+        <pc:chgData name="zhi zhang" userId="36bdf691fd3510be" providerId="LiveId" clId="{5BC97996-095E-49A7-A797-DB2E422DD13D}" dt="2025-05-11T14:52:35.792" v="5441" actId="20577"/>
+        <pc:sldMkLst>
+          <pc:docMk/>
+          <pc:sldMk cId="3288724058" sldId="1560"/>
+        </pc:sldMkLst>
+      </pc:sldChg>
+      <pc:sldChg chg="modNotesTx">
+        <pc:chgData name="zhi zhang" userId="36bdf691fd3510be" providerId="LiveId" clId="{5BC97996-095E-49A7-A797-DB2E422DD13D}" dt="2025-05-11T14:53:31.523" v="5574" actId="20577"/>
+        <pc:sldMkLst>
+          <pc:docMk/>
+          <pc:sldMk cId="2129605611" sldId="1561"/>
+        </pc:sldMkLst>
+      </pc:sldChg>
+      <pc:sldChg chg="modNotesTx">
+        <pc:chgData name="zhi zhang" userId="36bdf691fd3510be" providerId="LiveId" clId="{5BC97996-095E-49A7-A797-DB2E422DD13D}" dt="2025-05-12T05:30:33.881" v="9111" actId="20577"/>
+        <pc:sldMkLst>
+          <pc:docMk/>
+          <pc:sldMk cId="1421017218" sldId="1562"/>
+        </pc:sldMkLst>
+      </pc:sldChg>
+      <pc:sldChg chg="modNotesTx">
+        <pc:chgData name="zhi zhang" userId="36bdf691fd3510be" providerId="LiveId" clId="{5BC97996-095E-49A7-A797-DB2E422DD13D}" dt="2025-05-11T14:57:34.130" v="5770" actId="20577"/>
+        <pc:sldMkLst>
+          <pc:docMk/>
+          <pc:sldMk cId="1834362957" sldId="1563"/>
+        </pc:sldMkLst>
+      </pc:sldChg>
+      <pc:sldChg chg="modSp mod modNotesTx">
+        <pc:chgData name="zhi zhang" userId="36bdf691fd3510be" providerId="LiveId" clId="{5BC97996-095E-49A7-A797-DB2E422DD13D}" dt="2025-05-11T00:57:26.825" v="3611"/>
+        <pc:sldMkLst>
+          <pc:docMk/>
+          <pc:sldMk cId="1217545385" sldId="1564"/>
+        </pc:sldMkLst>
+        <pc:spChg chg="mod">
+          <ac:chgData name="zhi zhang" userId="36bdf691fd3510be" providerId="LiveId" clId="{5BC97996-095E-49A7-A797-DB2E422DD13D}" dt="2025-05-11T00:57:26.825" v="3611"/>
+          <ac:spMkLst>
+            <pc:docMk/>
+            <pc:sldMk cId="1217545385" sldId="1564"/>
+            <ac:spMk id="7" creationId="{75E0A5E3-B5A7-40C6-9FE8-508ABF9E1458}"/>
+          </ac:spMkLst>
+        </pc:spChg>
+      </pc:sldChg>
+      <pc:sldChg chg="modNotesTx">
+        <pc:chgData name="zhi zhang" userId="36bdf691fd3510be" providerId="LiveId" clId="{5BC97996-095E-49A7-A797-DB2E422DD13D}" dt="2025-05-12T03:20:03.344" v="8658" actId="20577"/>
+        <pc:sldMkLst>
+          <pc:docMk/>
+          <pc:sldMk cId="693837114" sldId="1566"/>
+        </pc:sldMkLst>
+      </pc:sldChg>
+      <pc:sldChg chg="modSp mod modNotesTx">
+        <pc:chgData name="zhi zhang" userId="36bdf691fd3510be" providerId="LiveId" clId="{5BC97996-095E-49A7-A797-DB2E422DD13D}" dt="2025-05-12T03:21:08.790" v="8786" actId="20577"/>
+        <pc:sldMkLst>
+          <pc:docMk/>
+          <pc:sldMk cId="1208814414" sldId="1567"/>
+        </pc:sldMkLst>
+        <pc:spChg chg="mod">
+          <ac:chgData name="zhi zhang" userId="36bdf691fd3510be" providerId="LiveId" clId="{5BC97996-095E-49A7-A797-DB2E422DD13D}" dt="2025-05-11T01:01:02.679" v="3646" actId="20577"/>
+          <ac:spMkLst>
+            <pc:docMk/>
+            <pc:sldMk cId="1208814414" sldId="1567"/>
+            <ac:spMk id="7" creationId="{75E0A5E3-B5A7-40C6-9FE8-508ABF9E1458}"/>
+          </ac:spMkLst>
+        </pc:spChg>
+      </pc:sldChg>
+      <pc:sldChg chg="modSp mod modNotesTx">
+        <pc:chgData name="zhi zhang" userId="36bdf691fd3510be" providerId="LiveId" clId="{5BC97996-095E-49A7-A797-DB2E422DD13D}" dt="2025-05-10T08:36:04.597" v="2789" actId="20577"/>
+        <pc:sldMkLst>
+          <pc:docMk/>
+          <pc:sldMk cId="3127478266" sldId="1569"/>
+        </pc:sldMkLst>
+        <pc:spChg chg="mod">
+          <ac:chgData name="zhi zhang" userId="36bdf691fd3510be" providerId="LiveId" clId="{5BC97996-095E-49A7-A797-DB2E422DD13D}" dt="2025-05-10T08:36:04.597" v="2789" actId="20577"/>
+          <ac:spMkLst>
+            <pc:docMk/>
+            <pc:sldMk cId="3127478266" sldId="1569"/>
+            <ac:spMk id="3" creationId="{13DB3674-2D4B-8645-8753-8E30E629B377}"/>
+          </ac:spMkLst>
+        </pc:spChg>
+      </pc:sldChg>
+      <pc:sldChg chg="modSp mod">
+        <pc:chgData name="zhi zhang" userId="36bdf691fd3510be" providerId="LiveId" clId="{5BC97996-095E-49A7-A797-DB2E422DD13D}" dt="2025-05-10T08:24:00.399" v="2614" actId="20577"/>
+        <pc:sldMkLst>
+          <pc:docMk/>
+          <pc:sldMk cId="3661408518" sldId="1570"/>
+        </pc:sldMkLst>
+        <pc:spChg chg="mod">
+          <ac:chgData name="zhi zhang" userId="36bdf691fd3510be" providerId="LiveId" clId="{5BC97996-095E-49A7-A797-DB2E422DD13D}" dt="2025-05-10T08:24:00.399" v="2614" actId="20577"/>
+          <ac:spMkLst>
+            <pc:docMk/>
+            <pc:sldMk cId="3661408518" sldId="1570"/>
+            <ac:spMk id="3" creationId="{13DB3674-2D4B-8645-8753-8E30E629B377}"/>
+          </ac:spMkLst>
+        </pc:spChg>
+      </pc:sldChg>
+      <pc:sldChg chg="modSp mod modNotesTx">
+        <pc:chgData name="zhi zhang" userId="36bdf691fd3510be" providerId="LiveId" clId="{5BC97996-095E-49A7-A797-DB2E422DD13D}" dt="2025-05-12T02:28:41.713" v="8207" actId="20577"/>
+        <pc:sldMkLst>
+          <pc:docMk/>
+          <pc:sldMk cId="3120467212" sldId="1571"/>
+        </pc:sldMkLst>
+        <pc:spChg chg="mod">
+          <ac:chgData name="zhi zhang" userId="36bdf691fd3510be" providerId="LiveId" clId="{5BC97996-095E-49A7-A797-DB2E422DD13D}" dt="2025-05-11T07:59:10.592" v="3683" actId="20577"/>
+          <ac:spMkLst>
+            <pc:docMk/>
+            <pc:sldMk cId="3120467212" sldId="1571"/>
+            <ac:spMk id="3" creationId="{13DB3674-2D4B-8645-8753-8E30E629B377}"/>
+          </ac:spMkLst>
+        </pc:spChg>
+      </pc:sldChg>
+      <pc:sldChg chg="modSp mod modNotesTx">
+        <pc:chgData name="zhi zhang" userId="36bdf691fd3510be" providerId="LiveId" clId="{5BC97996-095E-49A7-A797-DB2E422DD13D}" dt="2025-05-11T07:58:35.709" v="3681" actId="20577"/>
+        <pc:sldMkLst>
+          <pc:docMk/>
+          <pc:sldMk cId="3497431990" sldId="1572"/>
+        </pc:sldMkLst>
+        <pc:spChg chg="mod">
+          <ac:chgData name="zhi zhang" userId="36bdf691fd3510be" providerId="LiveId" clId="{5BC97996-095E-49A7-A797-DB2E422DD13D}" dt="2025-05-10T08:36:27.370" v="2790" actId="20577"/>
+          <ac:spMkLst>
+            <pc:docMk/>
+            <pc:sldMk cId="3497431990" sldId="1572"/>
+            <ac:spMk id="3" creationId="{13DB3674-2D4B-8645-8753-8E30E629B377}"/>
+          </ac:spMkLst>
+        </pc:spChg>
+      </pc:sldChg>
+      <pc:sldChg chg="modSp mod">
+        <pc:chgData name="zhi zhang" userId="36bdf691fd3510be" providerId="LiveId" clId="{5BC97996-095E-49A7-A797-DB2E422DD13D}" dt="2025-05-10T08:36:30.535" v="2791" actId="20577"/>
+        <pc:sldMkLst>
+          <pc:docMk/>
+          <pc:sldMk cId="4069697500" sldId="1573"/>
+        </pc:sldMkLst>
+        <pc:spChg chg="mod">
+          <ac:chgData name="zhi zhang" userId="36bdf691fd3510be" providerId="LiveId" clId="{5BC97996-095E-49A7-A797-DB2E422DD13D}" dt="2025-05-10T08:36:30.535" v="2791" actId="20577"/>
+          <ac:spMkLst>
+            <pc:docMk/>
+            <pc:sldMk cId="4069697500" sldId="1573"/>
+            <ac:spMk id="3" creationId="{13DB3674-2D4B-8645-8753-8E30E629B377}"/>
+          </ac:spMkLst>
+        </pc:spChg>
+      </pc:sldChg>
+      <pc:sldChg chg="modSp mod">
+        <pc:chgData name="zhi zhang" userId="36bdf691fd3510be" providerId="LiveId" clId="{5BC97996-095E-49A7-A797-DB2E422DD13D}" dt="2025-05-12T02:35:06.501" v="8231"/>
+        <pc:sldMkLst>
+          <pc:docMk/>
+          <pc:sldMk cId="1676628065" sldId="1574"/>
+        </pc:sldMkLst>
+        <pc:spChg chg="mod">
+          <ac:chgData name="zhi zhang" userId="36bdf691fd3510be" providerId="LiveId" clId="{5BC97996-095E-49A7-A797-DB2E422DD13D}" dt="2025-05-12T02:35:06.501" v="8231"/>
+          <ac:spMkLst>
+            <pc:docMk/>
+            <pc:sldMk cId="1676628065" sldId="1574"/>
+            <ac:spMk id="3" creationId="{13DB3674-2D4B-8645-8753-8E30E629B377}"/>
+          </ac:spMkLst>
+        </pc:spChg>
+      </pc:sldChg>
+      <pc:sldChg chg="modSp mod">
+        <pc:chgData name="zhi zhang" userId="36bdf691fd3510be" providerId="LiveId" clId="{5BC97996-095E-49A7-A797-DB2E422DD13D}" dt="2025-05-10T08:55:07.277" v="2936" actId="14100"/>
+        <pc:sldMkLst>
+          <pc:docMk/>
+          <pc:sldMk cId="2183489948" sldId="1575"/>
+        </pc:sldMkLst>
+        <pc:spChg chg="mod">
+          <ac:chgData name="zhi zhang" userId="36bdf691fd3510be" providerId="LiveId" clId="{5BC97996-095E-49A7-A797-DB2E422DD13D}" dt="2025-05-10T08:55:07.277" v="2936" actId="14100"/>
+          <ac:spMkLst>
+            <pc:docMk/>
+            <pc:sldMk cId="2183489948" sldId="1575"/>
+            <ac:spMk id="3" creationId="{13DB3674-2D4B-8645-8753-8E30E629B377}"/>
+          </ac:spMkLst>
+        </pc:spChg>
+      </pc:sldChg>
+      <pc:sldChg chg="modSp mod modNotesTx">
+        <pc:chgData name="zhi zhang" userId="36bdf691fd3510be" providerId="LiveId" clId="{5BC97996-095E-49A7-A797-DB2E422DD13D}" dt="2025-05-12T03:24:36.961" v="8879" actId="20577"/>
+        <pc:sldMkLst>
+          <pc:docMk/>
+          <pc:sldMk cId="1028791141" sldId="1576"/>
+        </pc:sldMkLst>
+        <pc:spChg chg="mod">
+          <ac:chgData name="zhi zhang" userId="36bdf691fd3510be" providerId="LiveId" clId="{5BC97996-095E-49A7-A797-DB2E422DD13D}" dt="2025-05-12T02:36:14.928" v="8242" actId="108"/>
+          <ac:spMkLst>
+            <pc:docMk/>
+            <pc:sldMk cId="1028791141" sldId="1576"/>
+            <ac:spMk id="3" creationId="{13DB3674-2D4B-8645-8753-8E30E629B377}"/>
+          </ac:spMkLst>
+        </pc:spChg>
+      </pc:sldChg>
+      <pc:sldChg chg="modSp mod">
+        <pc:chgData name="zhi zhang" userId="36bdf691fd3510be" providerId="LiveId" clId="{5BC97996-095E-49A7-A797-DB2E422DD13D}" dt="2025-05-12T02:36:50.308" v="8247"/>
+        <pc:sldMkLst>
+          <pc:docMk/>
+          <pc:sldMk cId="3674712720" sldId="1577"/>
+        </pc:sldMkLst>
+        <pc:spChg chg="mod">
+          <ac:chgData name="zhi zhang" userId="36bdf691fd3510be" providerId="LiveId" clId="{5BC97996-095E-49A7-A797-DB2E422DD13D}" dt="2025-05-12T02:36:50.308" v="8247"/>
+          <ac:spMkLst>
+            <pc:docMk/>
+            <pc:sldMk cId="3674712720" sldId="1577"/>
+            <ac:spMk id="3" creationId="{13DB3674-2D4B-8645-8753-8E30E629B377}"/>
+          </ac:spMkLst>
+        </pc:spChg>
+      </pc:sldChg>
+      <pc:sldChg chg="modSp mod modNotesTx">
+        <pc:chgData name="zhi zhang" userId="36bdf691fd3510be" providerId="LiveId" clId="{5BC97996-095E-49A7-A797-DB2E422DD13D}" dt="2025-05-10T08:57:14.994" v="3065"/>
+        <pc:sldMkLst>
+          <pc:docMk/>
+          <pc:sldMk cId="2614465481" sldId="1578"/>
+        </pc:sldMkLst>
+        <pc:spChg chg="mod">
+          <ac:chgData name="zhi zhang" userId="36bdf691fd3510be" providerId="LiveId" clId="{5BC97996-095E-49A7-A797-DB2E422DD13D}" dt="2025-05-10T08:54:52.299" v="2934" actId="20577"/>
+          <ac:spMkLst>
+            <pc:docMk/>
+            <pc:sldMk cId="2614465481" sldId="1578"/>
+            <ac:spMk id="3" creationId="{13DB3674-2D4B-8645-8753-8E30E629B377}"/>
+          </ac:spMkLst>
+        </pc:spChg>
+      </pc:sldChg>
+      <pc:sldChg chg="modSp mod modNotesTx">
+        <pc:chgData name="zhi zhang" userId="36bdf691fd3510be" providerId="LiveId" clId="{5BC97996-095E-49A7-A797-DB2E422DD13D}" dt="2025-05-12T02:35:33.681" v="8235"/>
+        <pc:sldMkLst>
+          <pc:docMk/>
+          <pc:sldMk cId="11049585" sldId="1579"/>
+        </pc:sldMkLst>
+        <pc:spChg chg="mod">
+          <ac:chgData name="zhi zhang" userId="36bdf691fd3510be" providerId="LiveId" clId="{5BC97996-095E-49A7-A797-DB2E422DD13D}" dt="2025-05-12T02:35:25.631" v="8234"/>
+          <ac:spMkLst>
+            <pc:docMk/>
+            <pc:sldMk cId="11049585" sldId="1579"/>
+            <ac:spMk id="3" creationId="{13DB3674-2D4B-8645-8753-8E30E629B377}"/>
+          </ac:spMkLst>
+        </pc:spChg>
+      </pc:sldChg>
+      <pc:sldChg chg="modSp add del mod modNotesTx">
+        <pc:chgData name="zhi zhang" userId="36bdf691fd3510be" providerId="LiveId" clId="{5BC97996-095E-49A7-A797-DB2E422DD13D}" dt="2025-05-11T14:40:29.517" v="4838" actId="20577"/>
+        <pc:sldMkLst>
+          <pc:docMk/>
+          <pc:sldMk cId="35181850" sldId="1580"/>
+        </pc:sldMkLst>
+        <pc:spChg chg="mod">
+          <ac:chgData name="zhi zhang" userId="36bdf691fd3510be" providerId="LiveId" clId="{5BC97996-095E-49A7-A797-DB2E422DD13D}" dt="2025-05-09T00:53:28.584" v="2057" actId="20577"/>
+          <ac:spMkLst>
+            <pc:docMk/>
+            <pc:sldMk cId="35181850" sldId="1580"/>
+            <ac:spMk id="2" creationId="{5C4F01C5-5333-2248-B03B-703C97F7CC69}"/>
+          </ac:spMkLst>
+        </pc:spChg>
+        <pc:spChg chg="mod">
+          <ac:chgData name="zhi zhang" userId="36bdf691fd3510be" providerId="LiveId" clId="{5BC97996-095E-49A7-A797-DB2E422DD13D}" dt="2025-05-08T12:33:57.735" v="1548" actId="20577"/>
+          <ac:spMkLst>
+            <pc:docMk/>
+            <pc:sldMk cId="35181850" sldId="1580"/>
+            <ac:spMk id="3" creationId="{F7DD7DCB-C7E2-1B4F-BD83-3B7AF005DD76}"/>
+          </ac:spMkLst>
+        </pc:spChg>
+      </pc:sldChg>
+      <pc:sldChg chg="add del">
+        <pc:chgData name="zhi zhang" userId="36bdf691fd3510be" providerId="LiveId" clId="{5BC97996-095E-49A7-A797-DB2E422DD13D}" dt="2025-05-08T12:35:49.707" v="1559" actId="2696"/>
+        <pc:sldMkLst>
+          <pc:docMk/>
+          <pc:sldMk cId="161618191" sldId="1581"/>
+        </pc:sldMkLst>
+      </pc:sldChg>
+      <pc:sldChg chg="modSp add mod modNotesTx">
+        <pc:chgData name="zhi zhang" userId="36bdf691fd3510be" providerId="LiveId" clId="{5BC97996-095E-49A7-A797-DB2E422DD13D}" dt="2025-05-11T14:38:59.691" v="4657" actId="20577"/>
+        <pc:sldMkLst>
+          <pc:docMk/>
+          <pc:sldMk cId="2084434708" sldId="1582"/>
+        </pc:sldMkLst>
+        <pc:spChg chg="mod">
+          <ac:chgData name="zhi zhang" userId="36bdf691fd3510be" providerId="LiveId" clId="{5BC97996-095E-49A7-A797-DB2E422DD13D}" dt="2025-05-09T00:53:23.781" v="2050" actId="20577"/>
+          <ac:spMkLst>
+            <pc:docMk/>
+            <pc:sldMk cId="2084434708" sldId="1582"/>
+            <ac:spMk id="2" creationId="{5C4F01C5-5333-2248-B03B-703C97F7CC69}"/>
+          </ac:spMkLst>
+        </pc:spChg>
+        <pc:spChg chg="mod">
+          <ac:chgData name="zhi zhang" userId="36bdf691fd3510be" providerId="LiveId" clId="{5BC97996-095E-49A7-A797-DB2E422DD13D}" dt="2025-05-08T12:45:10.228" v="1600" actId="20577"/>
+          <ac:spMkLst>
+            <pc:docMk/>
+            <pc:sldMk cId="2084434708" sldId="1582"/>
+            <ac:spMk id="3" creationId="{F7DD7DCB-C7E2-1B4F-BD83-3B7AF005DD76}"/>
+          </ac:spMkLst>
+        </pc:spChg>
+      </pc:sldChg>
+      <pc:sldChg chg="modSp add mod modNotesTx">
+        <pc:chgData name="zhi zhang" userId="36bdf691fd3510be" providerId="LiveId" clId="{5BC97996-095E-49A7-A797-DB2E422DD13D}" dt="2025-05-12T05:20:39.047" v="9031" actId="20577"/>
+        <pc:sldMkLst>
+          <pc:docMk/>
+          <pc:sldMk cId="3730813260" sldId="1583"/>
+        </pc:sldMkLst>
+        <pc:spChg chg="mod">
+          <ac:chgData name="zhi zhang" userId="36bdf691fd3510be" providerId="LiveId" clId="{5BC97996-095E-49A7-A797-DB2E422DD13D}" dt="2025-05-12T05:20:15.132" v="8978" actId="20577"/>
+          <ac:spMkLst>
+            <pc:docMk/>
+            <pc:sldMk cId="3730813260" sldId="1583"/>
+            <ac:spMk id="3" creationId="{F7DD7DCB-C7E2-1B4F-BD83-3B7AF005DD76}"/>
+          </ac:spMkLst>
+        </pc:spChg>
+      </pc:sldChg>
+      <pc:sldChg chg="modSp add mod modNotesTx">
+        <pc:chgData name="zhi zhang" userId="36bdf691fd3510be" providerId="LiveId" clId="{5BC97996-095E-49A7-A797-DB2E422DD13D}" dt="2025-05-12T01:36:56.329" v="6731" actId="20577"/>
+        <pc:sldMkLst>
+          <pc:docMk/>
+          <pc:sldMk cId="1444907551" sldId="1584"/>
+        </pc:sldMkLst>
+        <pc:spChg chg="mod">
+          <ac:chgData name="zhi zhang" userId="36bdf691fd3510be" providerId="LiveId" clId="{5BC97996-095E-49A7-A797-DB2E422DD13D}" dt="2025-05-10T08:03:32.185" v="2552" actId="20577"/>
+          <ac:spMkLst>
+            <pc:docMk/>
+            <pc:sldMk cId="1444907551" sldId="1584"/>
+            <ac:spMk id="3" creationId="{13DB3674-2D4B-8645-8753-8E30E629B377}"/>
+          </ac:spMkLst>
+        </pc:spChg>
+      </pc:sldChg>
+      <pc:sldChg chg="add del">
+        <pc:chgData name="zhi zhang" userId="36bdf691fd3510be" providerId="LiveId" clId="{5BC97996-095E-49A7-A797-DB2E422DD13D}" dt="2025-05-10T08:03:58.443" v="2555" actId="2696"/>
+        <pc:sldMkLst>
+          <pc:docMk/>
+          <pc:sldMk cId="3962721779" sldId="1585"/>
+        </pc:sldMkLst>
+      </pc:sldChg>
+      <pc:sldChg chg="modSp add mod modNotesTx">
+        <pc:chgData name="zhi zhang" userId="36bdf691fd3510be" providerId="LiveId" clId="{5BC97996-095E-49A7-A797-DB2E422DD13D}" dt="2025-05-12T01:34:27.629" v="6562" actId="20577"/>
+        <pc:sldMkLst>
+          <pc:docMk/>
+          <pc:sldMk cId="2598505152" sldId="1586"/>
+        </pc:sldMkLst>
+        <pc:spChg chg="mod">
+          <ac:chgData name="zhi zhang" userId="36bdf691fd3510be" providerId="LiveId" clId="{5BC97996-095E-49A7-A797-DB2E422DD13D}" dt="2025-05-12T01:34:21.481" v="6558" actId="20577"/>
+          <ac:spMkLst>
+            <pc:docMk/>
+            <pc:sldMk cId="2598505152" sldId="1586"/>
+            <ac:spMk id="3" creationId="{13DB3674-2D4B-8645-8753-8E30E629B377}"/>
+          </ac:spMkLst>
+        </pc:spChg>
+      </pc:sldChg>
+      <pc:sldChg chg="modSp add mod modNotesTx">
+        <pc:chgData name="zhi zhang" userId="36bdf691fd3510be" providerId="LiveId" clId="{5BC97996-095E-49A7-A797-DB2E422DD13D}" dt="2025-05-12T02:27:01.357" v="8206" actId="20577"/>
+        <pc:sldMkLst>
+          <pc:docMk/>
+          <pc:sldMk cId="2243414391" sldId="1587"/>
+        </pc:sldMkLst>
+        <pc:spChg chg="mod">
+          <ac:chgData name="zhi zhang" userId="36bdf691fd3510be" providerId="LiveId" clId="{5BC97996-095E-49A7-A797-DB2E422DD13D}" dt="2025-05-10T08:29:17.627" v="2682" actId="20577"/>
+          <ac:spMkLst>
+            <pc:docMk/>
+            <pc:sldMk cId="2243414391" sldId="1587"/>
+            <ac:spMk id="3" creationId="{13DB3674-2D4B-8645-8753-8E30E629B377}"/>
+          </ac:spMkLst>
+        </pc:spChg>
+      </pc:sldChg>
+      <pc:sldChg chg="modSp add mod modNotesTx">
+        <pc:chgData name="zhi zhang" userId="36bdf691fd3510be" providerId="LiveId" clId="{5BC97996-095E-49A7-A797-DB2E422DD13D}" dt="2025-05-12T02:24:41.336" v="8178" actId="20577"/>
+        <pc:sldMkLst>
+          <pc:docMk/>
+          <pc:sldMk cId="3216884329" sldId="1588"/>
+        </pc:sldMkLst>
+        <pc:spChg chg="mod">
+          <ac:chgData name="zhi zhang" userId="36bdf691fd3510be" providerId="LiveId" clId="{5BC97996-095E-49A7-A797-DB2E422DD13D}" dt="2025-05-10T08:33:29.112" v="2755" actId="20577"/>
+          <ac:spMkLst>
+            <pc:docMk/>
+            <pc:sldMk cId="3216884329" sldId="1588"/>
+            <ac:spMk id="3" creationId="{13DB3674-2D4B-8645-8753-8E30E629B377}"/>
+          </ac:spMkLst>
+        </pc:spChg>
+      </pc:sldChg>
+      <pc:sldChg chg="modSp add mod modNotesTx">
+        <pc:chgData name="zhi zhang" userId="36bdf691fd3510be" providerId="LiveId" clId="{5BC97996-095E-49A7-A797-DB2E422DD13D}" dt="2025-05-12T02:31:47.459" v="8208"/>
+        <pc:sldMkLst>
+          <pc:docMk/>
+          <pc:sldMk cId="3016498909" sldId="1589"/>
+        </pc:sldMkLst>
+        <pc:spChg chg="mod">
+          <ac:chgData name="zhi zhang" userId="36bdf691fd3510be" providerId="LiveId" clId="{5BC97996-095E-49A7-A797-DB2E422DD13D}" dt="2025-05-10T08:37:15.359" v="2813" actId="20577"/>
+          <ac:spMkLst>
+            <pc:docMk/>
+            <pc:sldMk cId="3016498909" sldId="1589"/>
+            <ac:spMk id="3" creationId="{13DB3674-2D4B-8645-8753-8E30E629B377}"/>
+          </ac:spMkLst>
+        </pc:spChg>
+      </pc:sldChg>
+      <pc:sldChg chg="modSp add mod modNotesTx">
+        <pc:chgData name="zhi zhang" userId="36bdf691fd3510be" providerId="LiveId" clId="{5BC97996-095E-49A7-A797-DB2E422DD13D}" dt="2025-05-12T02:32:25.334" v="8212" actId="20577"/>
+        <pc:sldMkLst>
+          <pc:docMk/>
+          <pc:sldMk cId="885590572" sldId="1590"/>
+        </pc:sldMkLst>
+        <pc:spChg chg="mod">
+          <ac:chgData name="zhi zhang" userId="36bdf691fd3510be" providerId="LiveId" clId="{5BC97996-095E-49A7-A797-DB2E422DD13D}" dt="2025-05-12T02:32:25.334" v="8212" actId="20577"/>
+          <ac:spMkLst>
+            <pc:docMk/>
+            <pc:sldMk cId="885590572" sldId="1590"/>
+            <ac:spMk id="3" creationId="{13DB3674-2D4B-8645-8753-8E30E629B377}"/>
+          </ac:spMkLst>
+        </pc:spChg>
+      </pc:sldChg>
+      <pc:sldChg chg="modSp add mod modNotesTx">
+        <pc:chgData name="zhi zhang" userId="36bdf691fd3510be" providerId="LiveId" clId="{5BC97996-095E-49A7-A797-DB2E422DD13D}" dt="2025-05-12T03:13:47.113" v="8427" actId="20577"/>
+        <pc:sldMkLst>
+          <pc:docMk/>
+          <pc:sldMk cId="1089051023" sldId="1591"/>
+        </pc:sldMkLst>
+        <pc:spChg chg="mod">
+          <ac:chgData name="zhi zhang" userId="36bdf691fd3510be" providerId="LiveId" clId="{5BC97996-095E-49A7-A797-DB2E422DD13D}" dt="2025-05-11T00:58:30.253" v="3614" actId="20577"/>
+          <ac:spMkLst>
+            <pc:docMk/>
+            <pc:sldMk cId="1089051023" sldId="1591"/>
+            <ac:spMk id="7" creationId="{75E0A5E3-B5A7-40C6-9FE8-508ABF9E1458}"/>
+          </ac:spMkLst>
+        </pc:spChg>
+      </pc:sldChg>
+      <pc:sldChg chg="add del">
+        <pc:chgData name="zhi zhang" userId="36bdf691fd3510be" providerId="LiveId" clId="{5BC97996-095E-49A7-A797-DB2E422DD13D}" dt="2025-05-10T12:18:08.516" v="3224"/>
+        <pc:sldMkLst>
+          <pc:docMk/>
+          <pc:sldMk cId="1866259309" sldId="1591"/>
+        </pc:sldMkLst>
+      </pc:sldChg>
+      <pc:sldChg chg="addSp delSp modSp add mod modNotesTx">
+        <pc:chgData name="zhi zhang" userId="36bdf691fd3510be" providerId="LiveId" clId="{5BC97996-095E-49A7-A797-DB2E422DD13D}" dt="2025-05-12T02:17:15.740" v="7480" actId="1076"/>
+        <pc:sldMkLst>
+          <pc:docMk/>
+          <pc:sldMk cId="4174797524" sldId="1592"/>
+        </pc:sldMkLst>
+        <pc:spChg chg="add mod">
+          <ac:chgData name="zhi zhang" userId="36bdf691fd3510be" providerId="LiveId" clId="{5BC97996-095E-49A7-A797-DB2E422DD13D}" dt="2025-05-12T02:17:15.740" v="7480" actId="1076"/>
+          <ac:spMkLst>
+            <pc:docMk/>
+            <pc:sldMk cId="4174797524" sldId="1592"/>
+            <ac:spMk id="6" creationId="{38D6826D-9825-426E-B60D-6BEABC3E6646}"/>
+          </ac:spMkLst>
+        </pc:spChg>
+        <pc:picChg chg="del">
+          <ac:chgData name="zhi zhang" userId="36bdf691fd3510be" providerId="LiveId" clId="{5BC97996-095E-49A7-A797-DB2E422DD13D}" dt="2025-05-12T02:12:40.921" v="7466" actId="478"/>
+          <ac:picMkLst>
+            <pc:docMk/>
+            <pc:sldMk cId="4174797524" sldId="1592"/>
+            <ac:picMk id="1026" creationId="{59E29EA4-D58B-42FE-A83E-329DFC32C13E}"/>
+          </ac:picMkLst>
+        </pc:picChg>
+        <pc:picChg chg="add mod">
+          <ac:chgData name="zhi zhang" userId="36bdf691fd3510be" providerId="LiveId" clId="{5BC97996-095E-49A7-A797-DB2E422DD13D}" dt="2025-05-12T02:13:30.432" v="7473" actId="1076"/>
+          <ac:picMkLst>
+            <pc:docMk/>
+            <pc:sldMk cId="4174797524" sldId="1592"/>
+            <ac:picMk id="3074" creationId="{D821FDFD-CA6A-426F-8E68-AF84358ED467}"/>
+          </ac:picMkLst>
+        </pc:picChg>
+      </pc:sldChg>
+    </pc:docChg>
+  </pc:docChgLst>
+</pc:chgInfo>
 </file>
 
 <file path=ppt/notesMasters/notesMaster1.xml><?xml version="1.0" encoding="utf-8"?>
@@ -14562,7 +19120,7 @@
                   </a:outerShdw>
                 </a:effectLst>
               </a:rPr>
-              <a:t>[2 marks] Write a command to find all files that start with the string "host" (e.g., host123.txt, </a:t>
+              <a:t>[2 marks] Write a command to find all files or directories that start with the string "host" (e.g., host123.txt, </a:t>
             </a:r>
             <a:r>
               <a:rPr lang="en-AU" sz="2000" dirty="0" err="1">
@@ -15159,23 +19717,7 @@
                   <a:srgbClr val="FF0000"/>
                 </a:solidFill>
               </a:rPr>
-              <a:t>recursively deleting all files and directories in the currently logged-in </a:t>
-            </a:r>
-            <a:r>
-              <a:rPr lang="en-US" sz="2800">
-                <a:solidFill>
-                  <a:srgbClr val="FF0000"/>
-                </a:solidFill>
-              </a:rPr>
-              <a:t>user’s home </a:t>
-            </a:r>
-            <a:r>
-              <a:rPr lang="en-US" sz="2800" dirty="0">
-                <a:solidFill>
-                  <a:srgbClr val="FF0000"/>
-                </a:solidFill>
-              </a:rPr>
-              <a:t>directory</a:t>
+              <a:t>recursively deleting all files and directories in the currently logged-in user’s home directory</a:t>
             </a:r>
             <a:r>
               <a:rPr lang="en-AU" sz="2800" dirty="0">
@@ -15391,7 +19933,7 @@
                   </a:outerShdw>
                 </a:effectLst>
               </a:rPr>
-              <a:t> [4 marks] What do these directories contain?</a:t>
+              <a:t> [2 marks] What do these directories contain?</a:t>
             </a:r>
           </a:p>
           <a:p>
@@ -16115,7 +20657,7 @@
                   </a:outerShdw>
                 </a:effectLst>
               </a:rPr>
-              <a:t> [2 marks] Write a command to find all files that start with the string "host" (e.g., host123.txt, </a:t>
+              <a:t> [2 marks] Write a command to find all files or directories that start with the string "host" (e.g., host123.txt, </a:t>
             </a:r>
             <a:r>
               <a:rPr lang="en-AU" sz="2800" dirty="0" err="1">
@@ -16245,8 +20787,8 @@
         </p:nvSpPr>
         <p:spPr>
           <a:xfrm>
-            <a:off x="884439" y="1371745"/>
-            <a:ext cx="10353762" cy="2246769"/>
+            <a:off x="884438" y="1371745"/>
+            <a:ext cx="10774161" cy="2246769"/>
           </a:xfrm>
           <a:prstGeom prst="rect">
             <a:avLst/>
@@ -16306,7 +20848,7 @@
                   </a:outerShdw>
                 </a:effectLst>
               </a:rPr>
-              <a:t> [2 marks] Write a command to find all files that start with the string "host" (e.g., host123.txt, </a:t>
+              <a:t> [2 marks] Write a command to find all files or directories that start with the string "host" (e.g., host123.txt, </a:t>
             </a:r>
             <a:r>
               <a:rPr lang="en-AU" sz="2800" dirty="0" err="1">
@@ -24560,7 +29102,7 @@
           <a:p>
             <a:r>
               <a:rPr lang="en-AU" sz="2400" dirty="0"/>
-              <a:t>7 themed questions in 6 topics</a:t>
+              <a:t>7 themed questions in 6 topics (95 marks)</a:t>
             </a:r>
           </a:p>
           <a:p>
@@ -25533,15 +30075,7 @@
             </a:r>
             <a:r>
               <a:rPr lang="en-US" sz="2400" dirty="0"/>
-              <a:t>[6 marks] Describe the concept of public key infrastructure (PKI) and provide a step-by-step explanation of </a:t>
-            </a:r>
-            <a:r>
-              <a:rPr lang="en-US" sz="2400"/>
-              <a:t>how PKI </a:t>
-            </a:r>
-            <a:r>
-              <a:rPr lang="en-US" sz="2400" dirty="0"/>
-              <a:t>can be used to enable secure communication between two parties. </a:t>
+              <a:t>[6 marks] Describe the concept of public key infrastructure (PKI) and provide a step-by-step explanation of how PKI can be used to enable secure communication between two parties. </a:t>
             </a:r>
           </a:p>
           <a:p>

</xml_diff>